<commit_message>
Correct proposal bibliography against published venues and DOIs.
PILOT is Adaptive LLM Routing under Budget Constraints (Findings of EMNLP 2025), RouteLLM is ICLR 2025, Reflexion drops Berman, Generative Agents is UIST 2023, and PECAD is Guo, Woodruff and Yadav.

Co-authored-by: joyjeni <joyjeni@gmail.com>
</commit_message>
<xml_diff>
--- a/ACRS_PhD_Proposal_JenishaT_24ETRP720001.pptx
+++ b/ACRS_PhD_Proposal_JenishaT_24ETRP720001.pptx
@@ -3880,7 +3880,7 @@
           <a:lstStyle/>
           <a:p>
             <a:pPr algn="l"/>
-            <a:fld id="{83e579be-63f4-4788-a6c2-180dd5d096fe}" type="datetime3">
+            <a:fld id="{cf382ad4-9d5b-4571-a7f3-962aa0068a50}" type="datetime3">
               <a:rPr lang="en-GB" sz="1000" dirty="0">
                 <a:solidFill>
                   <a:srgbClr val="C4A35A"/>
@@ -3914,7 +3914,7 @@
           <a:lstStyle/>
           <a:p>
             <a:pPr algn="r"/>
-            <a:fld id="{ed52e502-5a0f-4e2b-9b59-06022553a770}" type="slidenum">
+            <a:fld id="{4115014d-a917-432e-ab7a-4ca04b28c853}" type="slidenum">
               <a:rPr lang="en-GB" sz="1000" dirty="0">
                 <a:solidFill>
                   <a:srgbClr val="C4A35A"/>
@@ -4725,7 +4725,7 @@
           <a:lstStyle/>
           <a:p>
             <a:pPr algn="l"/>
-            <a:fld id="{f90767aa-7782-491b-8bdb-8b478202b1cd}" type="datetime3">
+            <a:fld id="{b42acdf4-9994-462d-9fa1-57af662aee69}" type="datetime3">
               <a:rPr lang="en-GB" sz="1000" dirty="0">
                 <a:solidFill>
                   <a:srgbClr val="C4A35A"/>
@@ -4759,7 +4759,7 @@
           <a:lstStyle/>
           <a:p>
             <a:pPr algn="r"/>
-            <a:fld id="{910170b1-6529-4f59-b33b-ffd83907e1cb}" type="slidenum">
+            <a:fld id="{9a97d7dd-bbf9-459f-b737-2284bf7fe5d2}" type="slidenum">
               <a:rPr lang="en-GB" sz="1000" dirty="0">
                 <a:solidFill>
                   <a:srgbClr val="C4A35A"/>
@@ -5782,7 +5782,7 @@
           <a:lstStyle/>
           <a:p>
             <a:pPr algn="l"/>
-            <a:fld id="{d884dfe5-9119-4e49-8dc6-e43f96439049}" type="datetime3">
+            <a:fld id="{320e181c-cc21-47fd-af5d-dd7a9375cb5e}" type="datetime3">
               <a:rPr lang="en-GB" sz="1000" dirty="0">
                 <a:solidFill>
                   <a:srgbClr val="C4A35A"/>
@@ -5816,7 +5816,7 @@
           <a:lstStyle/>
           <a:p>
             <a:pPr algn="r"/>
-            <a:fld id="{650cf51f-9584-4990-8991-1c3080f07a89}" type="slidenum">
+            <a:fld id="{ced8c100-b473-46f9-8769-0e7eb749e577}" type="slidenum">
               <a:rPr lang="en-GB" sz="1000" dirty="0">
                 <a:solidFill>
                   <a:srgbClr val="C4A35A"/>
@@ -6275,7 +6275,7 @@
                 </a:solidFill>
                 <a:latin typeface="Calibri"/>
               </a:rPr>
-              <a:t>SOTA. Yue et al., MasRouter (ACL 2025, doi:10.18653/v1/2025.acl-long.757): trained neural controller over multi-agent topologies. Ong et al., RouteLLM (arXiv:2406.18665, 2024): routers among LLMs. Panda et al., PILOT (Findings of EMNLP 2025): preference-prior LinUCB for budget-constrained LLM routing. Hong et al., MetaGPT (ICLR 2024): authored SOP workflows. Pipeline: query → trained controller or difficulty model → choose one LLM/agent → execute</a:t>
+              <a:t>SOTA. Yue et al., MasRouter (ACL 2025, doi:10.18653/v1/2025.acl-long.757): trained neural controller over multi-agent topologies. Ong et al., RouteLLM (ICLR 2025, arXiv:2406.18665): routers among LLMs. Panda et al., Adaptive LLM Routing under Budget Constraints (PILOT; Findings of EMNLP 2025, doi:10.18653/v1/2025.findings-emnlp.1301): preference-prior LinUCB for budget-constrained LLM routing. Hong et al., MetaGPT (ICLR 2024): authored SOP workflows. Pipeline: query → trained controller or difficulty model → choose one LLM/agent → execute</a:t>
             </a:r>
           </a:p>
           <a:p>
@@ -6731,7 +6731,7 @@
           <a:lstStyle/>
           <a:p>
             <a:pPr algn="l"/>
-            <a:fld id="{15782857-843a-4951-90b8-d59b027ae312}" type="datetime3">
+            <a:fld id="{1b6412fb-779c-40ac-b7e9-210160e6fbc2}" type="datetime3">
               <a:rPr lang="en-GB" sz="1000" dirty="0">
                 <a:solidFill>
                   <a:srgbClr val="C4A35A"/>
@@ -6765,7 +6765,7 @@
           <a:lstStyle/>
           <a:p>
             <a:pPr algn="r"/>
-            <a:fld id="{e5fee357-7c02-4d79-81b7-b356f9faef1c}" type="slidenum">
+            <a:fld id="{093aa637-3a68-4348-92e9-3e32c93e18e3}" type="slidenum">
               <a:rPr lang="en-GB" sz="1000" dirty="0">
                 <a:solidFill>
                   <a:srgbClr val="C4A35A"/>
@@ -7224,7 +7224,7 @@
                 </a:solidFill>
                 <a:latin typeface="Calibri"/>
               </a:rPr>
-              <a:t>SOTA. Wu et al., AutoGen (ICLR 2024 LLM Agents Workshop; COLM 2024, arXiv:2308.08155): multi-agent conversation. Hong et al., MetaGPT (ICLR 2024): SOP pipeline. Qian et al., ChatDev (ACL 2024): organisational chat-chain. Li et al., CAMEL (NeurIPS 2023): communicative role-playing agents. Pipeline: manager LLM → sequential or star-topology agent messages → tool calls</a:t>
+              <a:t>SOTA. Wu et al., AutoGen (COLM 2024; ICLR 2024 LLM Agents Workshop Best Paper, arXiv:2308.08155): multi-agent conversation. Hong et al., MetaGPT (ICLR 2024): SOP pipeline. Qian et al., ChatDev (ACL 2024): organisational chat-chain. Li et al., CAMEL (NeurIPS 2023): communicative role-playing agents. Pipeline: manager LLM → sequential or star-topology agent messages → tool calls</a:t>
             </a:r>
           </a:p>
           <a:p>
@@ -7626,7 +7626,7 @@
           <a:lstStyle/>
           <a:p>
             <a:pPr algn="l"/>
-            <a:fld id="{b1a7769a-410d-4a4b-9deb-ecb129e0d8ea}" type="datetime3">
+            <a:fld id="{d3544d8b-634a-4be3-aaff-6ca081e2ee5d}" type="datetime3">
               <a:rPr lang="en-GB" sz="1000" dirty="0">
                 <a:solidFill>
                   <a:srgbClr val="C4A35A"/>
@@ -7660,7 +7660,7 @@
           <a:lstStyle/>
           <a:p>
             <a:pPr algn="r"/>
-            <a:fld id="{297e6af9-f449-4c77-b139-178b9ed3a1bf}" type="slidenum">
+            <a:fld id="{54fa8686-c5d5-4ae2-a9c6-a950a922bf27}" type="slidenum">
               <a:rPr lang="en-GB" sz="1000" dirty="0">
                 <a:solidFill>
                   <a:srgbClr val="C4A35A"/>
@@ -8119,7 +8119,7 @@
                 </a:solidFill>
                 <a:latin typeface="Calibri"/>
               </a:rPr>
-              <a:t>SOTA. Jiang et al., LLMLingua (EMNLP 2023): token-level prompt compression. Tero et al., Science 2010 (doi:10.1126/science.1177894): Physarum adaptive network. Park et al., Generative Agents (CHI 2023): language memory stream in a sandbox. Pipeline: long prompt → compressor → LLM. Memory is not written back into a tool retriever.</a:t>
+              <a:t>SOTA. Jiang et al., LLMLingua (EMNLP 2023): token-level prompt compression. Tero et al., Science 2010 (doi:10.1126/science.1177894): Physarum adaptive network. Park et al., Generative Agents (UIST 2023): language memory stream in a sandbox. Pipeline: long prompt → compressor → LLM. Memory is not written back into a tool retriever.</a:t>
             </a:r>
           </a:p>
           <a:p>
@@ -8575,7 +8575,7 @@
           <a:lstStyle/>
           <a:p>
             <a:pPr algn="l"/>
-            <a:fld id="{1f2103da-f21b-42fa-827a-3ebd3efa9e9f}" type="datetime3">
+            <a:fld id="{cfd289b2-41bf-4622-8c79-0fd966265a38}" type="datetime3">
               <a:rPr lang="en-GB" sz="1000" dirty="0">
                 <a:solidFill>
                   <a:srgbClr val="C4A35A"/>
@@ -8609,7 +8609,7 @@
           <a:lstStyle/>
           <a:p>
             <a:pPr algn="r"/>
-            <a:fld id="{c2bdb072-023c-429f-b7e4-33acfbfc82f7}" type="slidenum">
+            <a:fld id="{da124401-3e88-4a7b-9bf6-571400987b31}" type="slidenum">
               <a:rPr lang="en-GB" sz="1000" dirty="0">
                 <a:solidFill>
                   <a:srgbClr val="C4A35A"/>
@@ -9086,7 +9086,7 @@
                 </a:solidFill>
                 <a:latin typeface="Calibri"/>
               </a:rPr>
-              <a:t>RQ2. Can routing sample a training-free posterior over tool-specialist agents instead of a trained neural controller or an authored SOP (Yue et al., MasRouter, ACL 2025; Hong et al., MetaGPT, ICLR 2024; Ong et al., RouteLLM, 2024)?  →  addressed by O2 (Adaptive Probabilistic Routing Reinforcement (APRR)).</a:t>
+              <a:t>RQ2. Can routing sample a training-free posterior over tool-specialist agents instead of a trained neural controller or an authored SOP (Yue et al., MasRouter, ACL 2025; Hong et al., MetaGPT, ICLR 2024; Ong et al., RouteLLM, ICLR 2025)?  →  addressed by O2 (Adaptive Probabilistic Routing Reinforcement (APRR)).</a:t>
             </a:r>
           </a:p>
           <a:p>
@@ -9148,7 +9148,7 @@
           <a:lstStyle/>
           <a:p>
             <a:pPr algn="l"/>
-            <a:fld id="{8291e4b9-ddf5-472d-845b-23f69fa140b0}" type="datetime3">
+            <a:fld id="{341773cd-b688-4285-99a5-4153c11901d7}" type="datetime3">
               <a:rPr lang="en-GB" sz="1000" dirty="0">
                 <a:solidFill>
                   <a:srgbClr val="C4A35A"/>
@@ -9182,7 +9182,7 @@
           <a:lstStyle/>
           <a:p>
             <a:pPr algn="r"/>
-            <a:fld id="{d1c11a1d-86c3-4325-bfca-6eb1736a58e6}" type="slidenum">
+            <a:fld id="{6ae21204-8da0-4105-ae07-d5a0959f6b6e}" type="slidenum">
               <a:rPr lang="en-GB" sz="1000" dirty="0">
                 <a:solidFill>
                   <a:srgbClr val="C4A35A"/>
@@ -10134,7 +10134,7 @@
           <a:lstStyle/>
           <a:p>
             <a:pPr algn="l"/>
-            <a:fld id="{0f034aa5-9251-46b6-8b37-bbf5bed02ddb}" type="datetime3">
+            <a:fld id="{c3324ae9-4da0-47fb-b8eb-54fe14240bb7}" type="datetime3">
               <a:rPr lang="en-GB" sz="1000" dirty="0">
                 <a:solidFill>
                   <a:srgbClr val="C4A35A"/>
@@ -10168,7 +10168,7 @@
           <a:lstStyle/>
           <a:p>
             <a:pPr algn="r"/>
-            <a:fld id="{e31d84c6-9c34-4ae3-b059-414c1b348969}" type="slidenum">
+            <a:fld id="{96b32d34-258a-4a24-8b89-8210200daf86}" type="slidenum">
               <a:rPr lang="en-GB" sz="1000" dirty="0">
                 <a:solidFill>
                   <a:srgbClr val="C4A35A"/>
@@ -10743,7 +10743,7 @@
           <a:lstStyle/>
           <a:p>
             <a:pPr algn="l"/>
-            <a:fld id="{6d122bc5-fac9-41f0-9724-ae9723b8bb30}" type="datetime3">
+            <a:fld id="{b7a04f51-5ba2-4abf-b68d-968c7825b3ee}" type="datetime3">
               <a:rPr lang="en-GB" sz="1000" dirty="0">
                 <a:solidFill>
                   <a:srgbClr val="C4A35A"/>
@@ -10777,7 +10777,7 @@
           <a:lstStyle/>
           <a:p>
             <a:pPr algn="r"/>
-            <a:fld id="{6b437917-906d-455a-b1e3-a6a6f0c24ee8}" type="slidenum">
+            <a:fld id="{92d69429-b4bd-4aca-aba6-115f73b36510}" type="slidenum">
               <a:rPr lang="en-GB" sz="1000" dirty="0">
                 <a:solidFill>
                   <a:srgbClr val="C4A35A"/>
@@ -11352,7 +11352,7 @@
           <a:lstStyle/>
           <a:p>
             <a:pPr algn="l"/>
-            <a:fld id="{6d2a41ad-8a07-4bb7-b393-8dae1b791f82}" type="datetime3">
+            <a:fld id="{d7f3cd70-8b75-4ed5-979d-b22bb9654b30}" type="datetime3">
               <a:rPr lang="en-GB" sz="1000" dirty="0">
                 <a:solidFill>
                   <a:srgbClr val="C4A35A"/>
@@ -11386,7 +11386,7 @@
           <a:lstStyle/>
           <a:p>
             <a:pPr algn="r"/>
-            <a:fld id="{3e929ac0-3c05-466c-ba11-6e24f0e123e5}" type="slidenum">
+            <a:fld id="{0aced49a-16dc-4b48-80d7-03bf1135ac44}" type="slidenum">
               <a:rPr lang="en-GB" sz="1000" dirty="0">
                 <a:solidFill>
                   <a:srgbClr val="C4A35A"/>
@@ -11961,7 +11961,7 @@
           <a:lstStyle/>
           <a:p>
             <a:pPr algn="l"/>
-            <a:fld id="{032c2daf-b888-42d3-8eb1-b0ec911c82dc}" type="datetime3">
+            <a:fld id="{5822a2d4-1eec-42de-b121-20902f4d4982}" type="datetime3">
               <a:rPr lang="en-GB" sz="1000" dirty="0">
                 <a:solidFill>
                   <a:srgbClr val="C4A35A"/>
@@ -11995,7 +11995,7 @@
           <a:lstStyle/>
           <a:p>
             <a:pPr algn="r"/>
-            <a:fld id="{ba648479-646a-48ff-90db-39ed4006d22f}" type="slidenum">
+            <a:fld id="{e2560189-ea0e-4f50-97b4-2d294e5ee0ee}" type="slidenum">
               <a:rPr lang="en-GB" sz="1000" dirty="0">
                 <a:solidFill>
                   <a:srgbClr val="C4A35A"/>
@@ -12971,7 +12971,7 @@
           <a:lstStyle/>
           <a:p>
             <a:pPr algn="l"/>
-            <a:fld id="{b4579f13-7b13-4779-8530-c0ac35db377a}" type="datetime3">
+            <a:fld id="{d13d980e-9a2c-4812-ac6a-d8a3ad81cafd}" type="datetime3">
               <a:rPr lang="en-GB" sz="1000" dirty="0">
                 <a:solidFill>
                   <a:srgbClr val="C4A35A"/>
@@ -13005,7 +13005,7 @@
           <a:lstStyle/>
           <a:p>
             <a:pPr algn="r"/>
-            <a:fld id="{d682814e-f95a-4a7f-8a83-8ecf758a7113}" type="slidenum">
+            <a:fld id="{86489c17-82d4-40f9-adad-23f5f7da950e}" type="slidenum">
               <a:rPr lang="en-GB" sz="1000" dirty="0">
                 <a:solidFill>
                   <a:srgbClr val="C4A35A"/>
@@ -13580,7 +13580,7 @@
           <a:lstStyle/>
           <a:p>
             <a:pPr algn="l"/>
-            <a:fld id="{2c5e8bc4-e04b-4a2a-bff8-bd04950680f7}" type="datetime3">
+            <a:fld id="{adcadd0e-2fcb-445a-9938-cdbb93397236}" type="datetime3">
               <a:rPr lang="en-GB" sz="1000" dirty="0">
                 <a:solidFill>
                   <a:srgbClr val="C4A35A"/>
@@ -13614,7 +13614,7 @@
           <a:lstStyle/>
           <a:p>
             <a:pPr algn="r"/>
-            <a:fld id="{dd327c99-9dc1-4ba4-9a1a-dd634cde3cd7}" type="slidenum">
+            <a:fld id="{4774cd38-e984-4137-900c-26b27ccacadb}" type="slidenum">
               <a:rPr lang="en-GB" sz="1000" dirty="0">
                 <a:solidFill>
                   <a:srgbClr val="C4A35A"/>
@@ -14583,7 +14583,7 @@
           <a:lstStyle/>
           <a:p>
             <a:pPr algn="l"/>
-            <a:fld id="{ff9e8050-41f1-4cd5-ad4a-571a72a3d51e}" type="datetime3">
+            <a:fld id="{362f7b63-d8bc-441e-9368-e2a62bb9c88d}" type="datetime3">
               <a:rPr lang="en-GB" sz="1000" dirty="0">
                 <a:solidFill>
                   <a:srgbClr val="C4A35A"/>
@@ -14617,7 +14617,7 @@
           <a:lstStyle/>
           <a:p>
             <a:pPr algn="r"/>
-            <a:fld id="{984b57e9-b723-4113-a13c-1a03bfa36444}" type="slidenum">
+            <a:fld id="{a7339dc4-b60c-4f96-902e-ac987b8814e9}" type="slidenum">
               <a:rPr lang="en-GB" sz="1000" dirty="0">
                 <a:solidFill>
                   <a:srgbClr val="C4A35A"/>
@@ -15428,7 +15428,7 @@
           <a:lstStyle/>
           <a:p>
             <a:pPr algn="l"/>
-            <a:fld id="{b20bf3b9-d51c-4b89-bd7a-b90e39ccf131}" type="datetime3">
+            <a:fld id="{b7275cf1-995f-4ea1-b6e9-53ae9ec899c3}" type="datetime3">
               <a:rPr lang="en-GB" sz="1000" dirty="0">
                 <a:solidFill>
                   <a:srgbClr val="C4A35A"/>
@@ -15462,7 +15462,7 @@
           <a:lstStyle/>
           <a:p>
             <a:pPr algn="r"/>
-            <a:fld id="{5158a0a1-7ea9-42d5-8f43-15f073790545}" type="slidenum">
+            <a:fld id="{ba38338f-517f-4230-9bd9-fa7e8331db15}" type="slidenum">
               <a:rPr lang="en-GB" sz="1000" dirty="0">
                 <a:solidFill>
                   <a:srgbClr val="C4A35A"/>
@@ -16054,7 +16054,7 @@
           <a:lstStyle/>
           <a:p>
             <a:pPr algn="l"/>
-            <a:fld id="{d9cf41e1-6d2e-407a-b496-da6b73f15326}" type="datetime3">
+            <a:fld id="{3a719e08-2afb-4238-b868-78b7d5f5fcca}" type="datetime3">
               <a:rPr lang="en-GB" sz="1000" dirty="0">
                 <a:solidFill>
                   <a:srgbClr val="C4A35A"/>
@@ -16088,7 +16088,7 @@
           <a:lstStyle/>
           <a:p>
             <a:pPr algn="r"/>
-            <a:fld id="{4567793e-acda-4149-b8eb-eca6c8b5c0e2}" type="slidenum">
+            <a:fld id="{5de8015c-8c45-4ddb-a783-82f9cf18582b}" type="slidenum">
               <a:rPr lang="en-GB" sz="1000" dirty="0">
                 <a:solidFill>
                   <a:srgbClr val="C4A35A"/>
@@ -16680,7 +16680,7 @@
           <a:lstStyle/>
           <a:p>
             <a:pPr algn="l"/>
-            <a:fld id="{230c114c-225b-4fe2-8006-e59029bcbc42}" type="datetime3">
+            <a:fld id="{1e400cfc-c8db-4425-bfb9-18861736248b}" type="datetime3">
               <a:rPr lang="en-GB" sz="1000" dirty="0">
                 <a:solidFill>
                   <a:srgbClr val="C4A35A"/>
@@ -16714,7 +16714,7 @@
           <a:lstStyle/>
           <a:p>
             <a:pPr algn="r"/>
-            <a:fld id="{11c7c39a-e098-46df-90a0-d600553d3c72}" type="slidenum">
+            <a:fld id="{2d04b296-06fc-4ab4-991b-9d4886ec38d5}" type="slidenum">
               <a:rPr lang="en-GB" sz="1000" dirty="0">
                 <a:solidFill>
                   <a:srgbClr val="C4A35A"/>
@@ -17271,7 +17271,7 @@
           <a:lstStyle/>
           <a:p>
             <a:pPr algn="l"/>
-            <a:fld id="{f416b8ab-dc34-4091-a64a-9724bed8fb74}" type="datetime3">
+            <a:fld id="{7d82533d-7618-4554-8c26-732ceea2a632}" type="datetime3">
               <a:rPr lang="en-GB" sz="1000" dirty="0">
                 <a:solidFill>
                   <a:srgbClr val="C4A35A"/>
@@ -17305,7 +17305,7 @@
           <a:lstStyle/>
           <a:p>
             <a:pPr algn="r"/>
-            <a:fld id="{e5bc0dd9-8c55-4d78-b837-e643d138f5f8}" type="slidenum">
+            <a:fld id="{a617c65f-33bc-438b-b7ae-b1f7e798ee90}" type="slidenum">
               <a:rPr lang="en-GB" sz="1000" dirty="0">
                 <a:solidFill>
                   <a:srgbClr val="C4A35A"/>
@@ -17729,7 +17729,7 @@
                 </a:solidFill>
                 <a:latin typeface="Calibri"/>
               </a:rPr>
-              <a:t>Wu, Q., Bansal, G., Zhang, J., Wu, Y., Li, B., Zhu, E., Jiang, L., Zhang, X., Zhang, S., Liu, J., Awadallah, A. H., White, R. W., Burger, D., and Wang, C. AutoGen: Enabling Next-Gen LLM Applications via Multi-Agent Conversation. ICLR 2024 Workshop on Large Language Model (LLM) Agents; also COLM 2024. arXiv:2308.08155.</a:t>
+              <a:t>Wu, Q., Bansal, G., Zhang, J., Wu, Y., Li, B., Zhu, E., Jiang, L., Zhang, X., Zhang, S., Liu, J., Awadallah, A. H., White, R. W., Burger, D., and Wang, C. AutoGen: Enabling Next-Gen LLM Applications via Multi-Agent Conversations. Conference on Language Modeling (COLM) 2024. Also ICLR 2024 Workshop on Large Language Model (LLM) Agents (Best Paper). arXiv:2308.08155.</a:t>
             </a:r>
           </a:p>
           <a:p>
@@ -17783,7 +17783,7 @@
                 </a:solidFill>
                 <a:latin typeface="Calibri"/>
               </a:rPr>
-              <a:t>Qian, C., Liu, W., Liu, H., Chen, N., Dang, Y., Li, J., Yang, C., Chen, W., Su, Y., Cong, X., Xu, J., Li, D., Liu, Z., and Sun, M. ChatDev: Communicative Agents for Software Development. ACL 2024. arXiv:2307.07924.</a:t>
+              <a:t>Qian, C., Liu, W., Liu, H., Chen, N., Dang, Y., Li, J., Yang, C., Chen, W., Su, Y., Cong, X., Xu, J., Li, D., Liu, Z., and Sun, M. ChatDev: Communicative Agents for Software Development. ACL 2024 (long), pages 15174–15186. doi:10.18653/v1/2024.acl-long.810.</a:t>
             </a:r>
           </a:p>
           <a:p>
@@ -17819,7 +17819,7 @@
                 </a:solidFill>
                 <a:latin typeface="Calibri"/>
               </a:rPr>
-              <a:t>Zheng, Y., Li, P., Liu, W., Liu, Y., Luan, J., and Wang, B. ToolRerank: Adaptive and Hierarchy-Aware Reranking for Tool Retrieval. LREC-COLING 2024.</a:t>
+              <a:t>Zheng, Y., Li, P., Liu, W., Liu, Y., Luan, J., and Wang, B. ToolRerank: Adaptive and Hierarchy-Aware Reranking for Tool Retrieval. LREC-COLING 2024, pages 16263–16273. ACL Anthology 2024.lrec-main.1413.</a:t>
             </a:r>
           </a:p>
         </p:txBody>
@@ -17845,7 +17845,7 @@
           <a:lstStyle/>
           <a:p>
             <a:pPr algn="l"/>
-            <a:fld id="{9cdb6dfa-da93-495b-a150-a5d82e7710de}" type="datetime3">
+            <a:fld id="{bdbd47cb-badf-4b98-bfe8-334b5bd330f7}" type="datetime3">
               <a:rPr lang="en-GB" sz="1000" dirty="0">
                 <a:solidFill>
                   <a:srgbClr val="C4A35A"/>
@@ -17879,7 +17879,7 @@
           <a:lstStyle/>
           <a:p>
             <a:pPr algn="r"/>
-            <a:fld id="{81fa6b54-347d-4f02-bd8c-3c1541a1f152}" type="slidenum">
+            <a:fld id="{db5565c4-e592-46ce-bbf1-cc963147bc3b}" type="slidenum">
               <a:rPr lang="en-GB" sz="1000" dirty="0">
                 <a:solidFill>
                   <a:srgbClr val="C4A35A"/>
@@ -18303,7 +18303,7 @@
                 </a:solidFill>
                 <a:latin typeface="Calibri"/>
               </a:rPr>
-              <a:t>Ong, I., Almahairi, A., Wu, V., Chiang, W.-L., Wu, T., Gonzalez, J. E., Kadous, M. W., and Stoica, I. RouteLLM: Learning to Route LLMs with Preference Data. arXiv:2406.18665, 2024.</a:t>
+              <a:t>Ong, I., Almahairi, A., Wu, V., Chiang, W.-L., Wu, T., Gonzalez, J. E., Kadous, M. W., and Stoica, I. RouteLLM: Learning to Route LLMs from Preference Data. ICLR 2025. arXiv:2406.18665.</a:t>
             </a:r>
           </a:p>
           <a:p>
@@ -18321,7 +18321,7 @@
                 </a:solidFill>
                 <a:latin typeface="Calibri"/>
               </a:rPr>
-              <a:t>Panda, S., and co-authors. PILOT: Preference-informed LinUCB for routing among language models. Findings of EMNLP 2025.</a:t>
+              <a:t>Panda, P., Magazine, R., Devaguptapu, C., Takemori, S., and Sharma, V. Adaptive LLM Routing under Budget Constraints. Findings of the Association for Computational Linguistics: EMNLP 2025, pages 23934–23949. doi:10.18653/v1/2025.findings-emnlp.1301.</a:t>
             </a:r>
           </a:p>
           <a:p>
@@ -18339,7 +18339,7 @@
                 </a:solidFill>
                 <a:latin typeface="Calibri"/>
               </a:rPr>
-              <a:t>Yue, Y., Zhang, G., Liu, B., Wan, G., Wang, K., Cheng, D., and Qi, Y. MasRouter: Learning to Route LLMs for Multi-Agent Systems. ACL 2025 (long). doi:10.18653/v1/2025.acl-long.757.</a:t>
+              <a:t>Yue, Y., Zhang, G., Liu, B., Wan, G., Wang, K., Cheng, D., and Qi, Y. MasRouter: Learning to Route LLMs for Multi-Agent Systems. ACL 2025 (long), pages 15549–15572. doi:10.18653/v1/2025.acl-long.757.</a:t>
             </a:r>
           </a:p>
           <a:p>
@@ -18357,7 +18357,7 @@
                 </a:solidFill>
                 <a:latin typeface="Calibri"/>
               </a:rPr>
-              <a:t>Jiang, H., Wu, Q., Lin, C.-Y., Yang, Y., and Qiu, L. LLMLingua: Compressing Prompts for Accelerated Inference of Large Language Models. EMNLP 2023.</a:t>
+              <a:t>Jiang, H., Wu, Q., Lin, C.-Y., Yang, Y., and Qiu, L. LLMLingua: Compressing Prompts for Accelerated Inference of Large Language Models. EMNLP 2023, pages 13358–13376. doi:10.18653/v1/2023.emnlp-main.825.</a:t>
             </a:r>
           </a:p>
           <a:p>
@@ -18429,7 +18429,7 @@
                 </a:solidFill>
                 <a:latin typeface="Calibri"/>
               </a:rPr>
-              <a:t>Tero, A., Takagi, S., Saigusa, T., Ito, K., Bebber, D. P., Fricker, M. D., Yumiki, K., Kobayashi, R., and Nakagaki, T. Rules for Biologically Inspired Adaptive Network Design. Science, 2010. doi:10.1126/science.1177894.</a:t>
+              <a:t>Tero, A., Takagi, S., Saigusa, T., Ito, K., Bebber, D. P., Fricker, M. D., Yumiki, K., Kobayashi, R., and Nakagaki, T. Rules for Biologically Inspired Adaptive Network Design. Science 327(5964):439–442, 2010. doi:10.1126/science.1177894.</a:t>
             </a:r>
           </a:p>
         </p:txBody>
@@ -18455,7 +18455,7 @@
           <a:lstStyle/>
           <a:p>
             <a:pPr algn="l"/>
-            <a:fld id="{562959d6-ef5e-4a9e-af27-b616b9d5d687}" type="datetime3">
+            <a:fld id="{f30ab948-5360-4967-8e47-120f2038b09b}" type="datetime3">
               <a:rPr lang="en-GB" sz="1000" dirty="0">
                 <a:solidFill>
                   <a:srgbClr val="C4A35A"/>
@@ -18489,7 +18489,7 @@
           <a:lstStyle/>
           <a:p>
             <a:pPr algn="r"/>
-            <a:fld id="{d83c6a4c-5d4d-4e13-9e3e-6fce3b0005ec}" type="slidenum">
+            <a:fld id="{cbf3415a-7a29-48d1-8270-3a647fbde29a}" type="slidenum">
               <a:rPr lang="en-GB" sz="1000" dirty="0">
                 <a:solidFill>
                   <a:srgbClr val="C4A35A"/>
@@ -18913,7 +18913,7 @@
                 </a:solidFill>
                 <a:latin typeface="Calibri"/>
               </a:rPr>
-              <a:t>Park, J. S., O’Brien, J. C., Cai, C. J., Morris, M. R., Liang, P., and Bernstein, M. S. Generative Agents: Interactive Simulacra of Human Behavior. CHI 2023.</a:t>
+              <a:t>Park, J. S., O’Brien, J. C., Cai, C. J., Morris, M. R., Liang, P., and Bernstein, M. S. Generative Agents: Interactive Simulacra of Human Behavior. UIST 2023 (Best Paper). doi:10.1145/3586183.3606763.</a:t>
             </a:r>
           </a:p>
           <a:p>
@@ -18931,7 +18931,7 @@
                 </a:solidFill>
                 <a:latin typeface="Calibri"/>
               </a:rPr>
-              <a:t>Shinn, N., Cassano, F., Berman, E., Gopinath, A., Narasimhan, K., and Yao, S. Reflexion: Language Agents with Verbal Reinforcement Learning. NeurIPS 2023.</a:t>
+              <a:t>Shinn, N., Cassano, F., Gopinath, A., Narasimhan, K., and Yao, S. Reflexion: Language Agents with Verbal Reinforcement Learning. NeurIPS 2023.</a:t>
             </a:r>
           </a:p>
           <a:p>
@@ -18967,7 +18967,7 @@
                 </a:solidFill>
                 <a:latin typeface="Calibri"/>
               </a:rPr>
-              <a:t>Schick, T., Dwivedi-Yu, J., Dessì, R., Raileanu, R., Lomeli, M., Zettlemoyer, L., Cancedda, N., and Scialom, T. Toolformer: Language Models Can Teach Themselves to Use Tools. NeurIPS 2023.</a:t>
+              <a:t>Schick, T., Dwivedi-Yu, J., Dessì, R., Raileanu, R., Lomeli, M., Hambro, E., Zettlemoyer, L., Cancedda, N., and Scialom, T. Toolformer: Language Models Can Teach Themselves to Use Tools. NeurIPS 2023.</a:t>
             </a:r>
           </a:p>
           <a:p>
@@ -19064,7 +19064,7 @@
           <a:lstStyle/>
           <a:p>
             <a:pPr algn="l"/>
-            <a:fld id="{95b8df89-af37-4df7-8146-f0d9e9d8bae4}" type="datetime3">
+            <a:fld id="{8845a490-4f47-499e-b909-8aa5c80d54fd}" type="datetime3">
               <a:rPr lang="en-GB" sz="1000" dirty="0">
                 <a:solidFill>
                   <a:srgbClr val="C4A35A"/>
@@ -19098,7 +19098,7 @@
           <a:lstStyle/>
           <a:p>
             <a:pPr algn="r"/>
-            <a:fld id="{cb08ca71-0ebf-4857-8a68-891e08413128}" type="slidenum">
+            <a:fld id="{2812f601-7f41-4fce-a530-fa9ae32528d7}" type="slidenum">
               <a:rPr lang="en-GB" sz="1000" dirty="0">
                 <a:solidFill>
                   <a:srgbClr val="C4A35A"/>
@@ -19673,7 +19673,7 @@
           <a:lstStyle/>
           <a:p>
             <a:pPr algn="l"/>
-            <a:fld id="{b09ad385-af60-43f0-9156-1f204ce994d0}" type="datetime3">
+            <a:fld id="{8db6c439-ad45-4641-9244-04cfb319adc4}" type="datetime3">
               <a:rPr lang="en-GB" sz="1000" dirty="0">
                 <a:solidFill>
                   <a:srgbClr val="C4A35A"/>
@@ -19707,7 +19707,7 @@
           <a:lstStyle/>
           <a:p>
             <a:pPr algn="r"/>
-            <a:fld id="{7732671a-b82b-4df5-bb6e-0afebe3b34c3}" type="slidenum">
+            <a:fld id="{66b0b058-1519-45e6-b8e9-a19977264c7c}" type="slidenum">
               <a:rPr lang="en-GB" sz="1000" dirty="0">
                 <a:solidFill>
                   <a:srgbClr val="C4A35A"/>
@@ -20480,7 +20480,7 @@
           <a:lstStyle/>
           <a:p>
             <a:pPr algn="l"/>
-            <a:fld id="{223d533e-fcb4-4588-9325-65460c2034f3}" type="datetime3">
+            <a:fld id="{00c878d5-56e1-450d-9045-5e1f625b010e}" type="datetime3">
               <a:rPr lang="en-GB" sz="1000" dirty="0">
                 <a:solidFill>
                   <a:srgbClr val="C4A35A"/>
@@ -20514,7 +20514,7 @@
           <a:lstStyle/>
           <a:p>
             <a:pPr algn="r"/>
-            <a:fld id="{7db883b2-5e65-4d0a-9577-685629fc0312}" type="slidenum">
+            <a:fld id="{435ae7ac-45c3-4143-bbc1-680e90b3d59c}" type="slidenum">
               <a:rPr lang="en-GB" sz="1000" dirty="0">
                 <a:solidFill>
                   <a:srgbClr val="C4A35A"/>
@@ -21053,7 +21053,7 @@
           <a:lstStyle/>
           <a:p>
             <a:pPr algn="l"/>
-            <a:fld id="{9620dd0e-9894-4538-9932-b75ff274520f}" type="datetime3">
+            <a:fld id="{104b5bdf-a8ac-47d1-bd7a-57e979f6a94a}" type="datetime3">
               <a:rPr lang="en-GB" sz="1000" dirty="0">
                 <a:solidFill>
                   <a:srgbClr val="C4A35A"/>
@@ -21087,7 +21087,7 @@
           <a:lstStyle/>
           <a:p>
             <a:pPr algn="r"/>
-            <a:fld id="{5863f060-9947-48c4-bafc-e68bb0e01203}" type="slidenum">
+            <a:fld id="{a31c0cce-42b4-4181-b080-696eb8cf1677}" type="slidenum">
               <a:rPr lang="en-GB" sz="1000" dirty="0">
                 <a:solidFill>
                   <a:srgbClr val="C4A35A"/>
@@ -21644,7 +21644,7 @@
           <a:lstStyle/>
           <a:p>
             <a:pPr algn="l"/>
-            <a:fld id="{64aedd5c-30a7-43d8-9988-d66312523c97}" type="datetime3">
+            <a:fld id="{8ba1e492-1ae7-481b-b862-1ebcdf07a286}" type="datetime3">
               <a:rPr lang="en-GB" sz="1000" dirty="0">
                 <a:solidFill>
                   <a:srgbClr val="C4A35A"/>
@@ -21678,7 +21678,7 @@
           <a:lstStyle/>
           <a:p>
             <a:pPr algn="r"/>
-            <a:fld id="{1cc698ae-86b1-4454-9fb2-7fc6c9a6cdde}" type="slidenum">
+            <a:fld id="{afb8084b-2e94-449d-aa2b-5ed3da0f56be}" type="slidenum">
               <a:rPr lang="en-GB" sz="1000" dirty="0">
                 <a:solidFill>
                   <a:srgbClr val="C4A35A"/>
@@ -22155,7 +22155,7 @@
                 </a:solidFill>
                 <a:latin typeface="Calibri"/>
               </a:rPr>
-              <a:t>Ong et al., RouteLLM (2024); Yue et al., MasRouter (ACL 2025); Panda et al., PILOT (Findings of EMNLP 2025): learned or bandit routers over LLM SKUs or collaboration modes. Gap: they do not maintain a training-free Dirichlet–Thompson posterior over named tool specialists.</a:t>
+              <a:t>Ong et al., RouteLLM (ICLR 2025); Yue et al., MasRouter (ACL 2025); Panda et al., Adaptive LLM Routing / PILOT (Findings of EMNLP 2025): learned or bandit routers over LLM SKUs or collaboration modes. Gap: they do not maintain a training-free Dirichlet–Thompson posterior over named tool specialists.</a:t>
             </a:r>
           </a:p>
           <a:p>
@@ -22217,7 +22217,7 @@
           <a:lstStyle/>
           <a:p>
             <a:pPr algn="l"/>
-            <a:fld id="{a3e7f3a8-432e-455d-a4a7-ed4792f841e5}" type="datetime3">
+            <a:fld id="{d360d952-ccb4-49a8-a1bc-239a283780f0}" type="datetime3">
               <a:rPr lang="en-GB" sz="1000" dirty="0">
                 <a:solidFill>
                   <a:srgbClr val="C4A35A"/>
@@ -22251,7 +22251,7 @@
           <a:lstStyle/>
           <a:p>
             <a:pPr algn="r"/>
-            <a:fld id="{949733b5-734e-48ad-ab4e-dcce487b897e}" type="slidenum">
+            <a:fld id="{8b39cc19-3373-41f3-a3a4-414a814de599}" type="slidenum">
               <a:rPr lang="en-GB" sz="1000" dirty="0">
                 <a:solidFill>
                   <a:srgbClr val="C4A35A"/>
@@ -23130,7 +23130,7 @@
           <a:lstStyle/>
           <a:p>
             <a:pPr algn="l"/>
-            <a:fld id="{e4e8b7a3-cf70-4e74-87b1-1232394058e4}" type="datetime3">
+            <a:fld id="{c552fd5e-d268-4730-be36-75aa8cbf14f5}" type="datetime3">
               <a:rPr lang="en-GB" sz="1000" dirty="0">
                 <a:solidFill>
                   <a:srgbClr val="C4A35A"/>
@@ -23164,7 +23164,7 @@
           <a:lstStyle/>
           <a:p>
             <a:pPr algn="r"/>
-            <a:fld id="{73d42dcb-cd8b-4fe6-bd23-3cacbb0b4035}" type="slidenum">
+            <a:fld id="{33606c85-0073-4913-b1b9-9fc870523cb7}" type="slidenum">
               <a:rPr lang="en-GB" sz="1000" dirty="0">
                 <a:solidFill>
                   <a:srgbClr val="C4A35A"/>
@@ -23756,7 +23756,7 @@
           <a:lstStyle/>
           <a:p>
             <a:pPr algn="l"/>
-            <a:fld id="{b5fe9bf3-f919-4574-8479-076138fc083e}" type="datetime3">
+            <a:fld id="{c9317def-778d-43d7-8d25-bb8fc53f6084}" type="datetime3">
               <a:rPr lang="en-GB" sz="1000" dirty="0">
                 <a:solidFill>
                   <a:srgbClr val="C4A35A"/>
@@ -23790,7 +23790,7 @@
           <a:lstStyle/>
           <a:p>
             <a:pPr algn="r"/>
-            <a:fld id="{a4b3f19e-b0eb-404b-8cf5-e2af2088801b}" type="slidenum">
+            <a:fld id="{7938b078-7bbb-4754-beb3-fd1d0444eda6}" type="slidenum">
               <a:rPr lang="en-GB" sz="1000" dirty="0">
                 <a:solidFill>
                   <a:srgbClr val="C4A35A"/>
@@ -24347,7 +24347,7 @@
           <a:lstStyle/>
           <a:p>
             <a:pPr algn="l"/>
-            <a:fld id="{a3e62801-1a5f-4f1a-a6f1-1aee747ea848}" type="datetime3">
+            <a:fld id="{a7622a34-11ef-40fc-8043-27160bd6baf9}" type="datetime3">
               <a:rPr lang="en-GB" sz="1000" dirty="0">
                 <a:solidFill>
                   <a:srgbClr val="C4A35A"/>
@@ -24381,7 +24381,7 @@
           <a:lstStyle/>
           <a:p>
             <a:pPr algn="r"/>
-            <a:fld id="{12cdba31-4ff3-4cd0-bc61-2705891444f4}" type="slidenum">
+            <a:fld id="{2becf470-8354-46f4-be26-db6b206de56f}" type="slidenum">
               <a:rPr lang="en-GB" sz="1000" dirty="0">
                 <a:solidFill>
                   <a:srgbClr val="C4A35A"/>

</xml_diff>

<commit_message>
Cite conference papers with full international proceedings titles.
Evidence Publication and the reference slides now use Proceedings of ICLR,
ACL, IJCAI, COLM, AAAI, UIST, EMNLP, LREC-COLING, VLDB, and Advances in
Neural Information Processing Systems, not acronym-only venues.
</commit_message>
<xml_diff>
--- a/ACRS_PhD_Proposal_JenishaT_24ETRP720001.pptx
+++ b/ACRS_PhD_Proposal_JenishaT_24ETRP720001.pptx
@@ -3888,7 +3888,7 @@
           <a:lstStyle/>
           <a:p>
             <a:pPr algn="l"/>
-            <a:fld id="{a592af38-2bfd-4192-a6a8-a4839c0c4e20}" type="datetime3">
+            <a:fld id="{d71baf80-5258-41ee-8fd2-382f927572be}" type="datetime3">
               <a:rPr lang="en-GB" sz="1000" dirty="0">
                 <a:solidFill>
                   <a:srgbClr val="C4A35A"/>
@@ -3922,7 +3922,7 @@
           <a:lstStyle/>
           <a:p>
             <a:pPr algn="r"/>
-            <a:fld id="{c15ca4eb-9eca-4f91-a923-d001c1b5ecb1}" type="slidenum">
+            <a:fld id="{92c44f60-c4e4-4a6f-9559-5ef99c7ba133}" type="slidenum">
               <a:rPr lang="en-GB" sz="1000" dirty="0">
                 <a:solidFill>
                   <a:srgbClr val="C4A35A"/>
@@ -4532,7 +4532,7 @@
                 </a:solidFill>
                 <a:latin typeface="Calibri"/>
               </a:rPr>
-              <a:t>ICLR 2025</a:t>
+              <a:t>Proceedings of the Thirteenth International Conference on Learning Representations (ICLR 2025)</a:t>
             </a:r>
           </a:p>
           <a:p>
@@ -4836,7 +4836,7 @@
                 </a:solidFill>
                 <a:latin typeface="Calibri"/>
               </a:rPr>
-              <a:t>ACL 2025 (long), pages 15549–15572. doi:10.18653/v1/2025.acl-long.757</a:t>
+              <a:t>Proceedings of the 63rd Annual Meeting of the Association for Computational Linguistics (Volume 1: Long Papers), pages 15549–15572. doi:10.18653/v1/2025.acl-long.757</a:t>
             </a:r>
           </a:p>
           <a:p>
@@ -4974,7 +4974,7 @@
           <a:lstStyle/>
           <a:p>
             <a:pPr algn="l"/>
-            <a:fld id="{359bcabc-11ed-4743-89a3-0800f232a054}" type="datetime3">
+            <a:fld id="{80ef18aa-2b0f-4233-9d52-0fd9df770a24}" type="datetime3">
               <a:rPr lang="en-GB" sz="1000" dirty="0">
                 <a:solidFill>
                   <a:srgbClr val="C4A35A"/>
@@ -5008,7 +5008,7 @@
           <a:lstStyle/>
           <a:p>
             <a:pPr algn="r"/>
-            <a:fld id="{f989ff85-efbd-454c-b2ca-935acf6efafc}" type="slidenum">
+            <a:fld id="{0833e2d1-1197-4696-91a4-a3c44a98cec4}" type="slidenum">
               <a:rPr lang="en-GB" sz="1000" dirty="0">
                 <a:solidFill>
                   <a:srgbClr val="C4A35A"/>
@@ -5922,7 +5922,7 @@
                 </a:solidFill>
                 <a:latin typeface="Calibri"/>
               </a:rPr>
-              <a:t>EMNLP 2023, pages 13358–13376. doi:10.18653/v1/2023.emnlp-main.825</a:t>
+              <a:t>Proceedings of the 2023 Conference on Empirical Methods in Natural Language Processing, pages 13358–13376. doi:10.18653/v1/2023.emnlp-main.825</a:t>
             </a:r>
           </a:p>
           <a:p>
@@ -6060,7 +6060,7 @@
           <a:lstStyle/>
           <a:p>
             <a:pPr algn="l"/>
-            <a:fld id="{ab5bc1b3-b702-4250-bd2f-5536a390cfe6}" type="datetime3">
+            <a:fld id="{a3c3ed8d-5eca-4b6c-affa-4463181892e0}" type="datetime3">
               <a:rPr lang="en-GB" sz="1000" dirty="0">
                 <a:solidFill>
                   <a:srgbClr val="C4A35A"/>
@@ -6094,7 +6094,7 @@
           <a:lstStyle/>
           <a:p>
             <a:pPr algn="r"/>
-            <a:fld id="{21bae128-38b6-42d6-bd8a-8f0b0f91fcb9}" type="slidenum">
+            <a:fld id="{0effeffd-2f24-4a9f-8898-95648ebb57b7}" type="slidenum">
               <a:rPr lang="en-GB" sz="1000" dirty="0">
                 <a:solidFill>
                   <a:srgbClr val="C4A35A"/>
@@ -6704,7 +6704,7 @@
                 </a:solidFill>
                 <a:latin typeface="Calibri"/>
               </a:rPr>
-              <a:t>UIST 2023 (Best Paper). doi:10.1145/3586183.3606763</a:t>
+              <a:t>Proceedings of the 36th Annual ACM Symposium on User Interface Software and Technology (UIST 2023), Best Paper. doi:10.1145/3586183.3606763</a:t>
             </a:r>
           </a:p>
           <a:p>
@@ -7146,7 +7146,7 @@
           <a:lstStyle/>
           <a:p>
             <a:pPr algn="l"/>
-            <a:fld id="{866ad9a2-330d-4d3d-8ed0-32cad833f8ff}" type="datetime3">
+            <a:fld id="{fe0c510a-1e40-42a6-b006-af52ef4bf2aa}" type="datetime3">
               <a:rPr lang="en-GB" sz="1000" dirty="0">
                 <a:solidFill>
                   <a:srgbClr val="C4A35A"/>
@@ -7180,7 +7180,7 @@
           <a:lstStyle/>
           <a:p>
             <a:pPr algn="r"/>
-            <a:fld id="{dac10e69-b2b0-4914-a024-9b16e5c8d942}" type="slidenum">
+            <a:fld id="{12341f12-dc4b-4ec5-aef5-3c91ad41838e}" type="slidenum">
               <a:rPr lang="en-GB" sz="1000" dirty="0">
                 <a:solidFill>
                   <a:srgbClr val="C4A35A"/>
@@ -7790,7 +7790,7 @@
                 </a:solidFill>
                 <a:latin typeface="Calibri"/>
               </a:rPr>
-              <a:t>AAAI 2020. doi:10.1609/aaai.v34i08.7039</a:t>
+              <a:t>Proceedings of the AAAI Conference on Artificial Intelligence, 34(08):13294–13299. doi:10.1609/aaai.v34i08.7039</a:t>
             </a:r>
           </a:p>
           <a:p>
@@ -8094,7 +8094,7 @@
                 </a:solidFill>
                 <a:latin typeface="Calibri"/>
               </a:rPr>
-              <a:t>ICLR 2023</a:t>
+              <a:t>Proceedings of the Eleventh International Conference on Learning Representations (ICLR 2023)</a:t>
             </a:r>
           </a:p>
           <a:p>
@@ -8232,7 +8232,7 @@
           <a:lstStyle/>
           <a:p>
             <a:pPr algn="l"/>
-            <a:fld id="{01d6946c-2e7d-4bb1-9975-51c81c6e9159}" type="datetime3">
+            <a:fld id="{c068383b-94a3-4f48-a86f-e712d0cabad4}" type="datetime3">
               <a:rPr lang="en-GB" sz="1000" dirty="0">
                 <a:solidFill>
                   <a:srgbClr val="C4A35A"/>
@@ -8266,7 +8266,7 @@
           <a:lstStyle/>
           <a:p>
             <a:pPr algn="r"/>
-            <a:fld id="{d34a5259-7744-460a-b4e8-4a4a23644793}" type="slidenum">
+            <a:fld id="{b2c704d7-b40d-4475-adbb-8cad5ec62fef}" type="slidenum">
               <a:rPr lang="en-GB" sz="1000" dirty="0">
                 <a:solidFill>
                   <a:srgbClr val="C4A35A"/>
@@ -9213,7 +9213,7 @@
           <a:lstStyle/>
           <a:p>
             <a:pPr algn="l"/>
-            <a:fld id="{cb9777ca-19c7-43d0-adaa-f97648cbb815}" type="datetime3">
+            <a:fld id="{5669dba5-5a17-4b7d-a4ab-7a8b204c0447}" type="datetime3">
               <a:rPr lang="en-GB" sz="1000" dirty="0">
                 <a:solidFill>
                   <a:srgbClr val="C4A35A"/>
@@ -9247,7 +9247,7 @@
           <a:lstStyle/>
           <a:p>
             <a:pPr algn="r"/>
-            <a:fld id="{7ef55010-d0b2-4c0c-9cbb-df4584cd687f}" type="slidenum">
+            <a:fld id="{c60a1332-34d9-4596-8055-3476abdd9518}" type="slidenum">
               <a:rPr lang="en-GB" sz="1000" dirty="0">
                 <a:solidFill>
                   <a:srgbClr val="C4A35A"/>
@@ -10126,7 +10126,7 @@
           <a:lstStyle/>
           <a:p>
             <a:pPr algn="l"/>
-            <a:fld id="{a7541f5c-8c0d-433e-8536-e58b57be70ae}" type="datetime3">
+            <a:fld id="{4af2f500-35b1-436a-a91f-a05b93a29324}" type="datetime3">
               <a:rPr lang="en-GB" sz="1000" dirty="0">
                 <a:solidFill>
                   <a:srgbClr val="C4A35A"/>
@@ -10160,7 +10160,7 @@
           <a:lstStyle/>
           <a:p>
             <a:pPr algn="r"/>
-            <a:fld id="{0a519498-032c-4c01-81b3-625cd666956a}" type="slidenum">
+            <a:fld id="{1f9b74e3-961a-4ddf-b54c-4350121d15a2}" type="slidenum">
               <a:rPr lang="en-GB" sz="1000" dirty="0">
                 <a:solidFill>
                   <a:srgbClr val="C4A35A"/>
@@ -10752,7 +10752,7 @@
           <a:lstStyle/>
           <a:p>
             <a:pPr algn="l"/>
-            <a:fld id="{2c96e9e0-c412-4d2c-9989-686d13f13e86}" type="datetime3">
+            <a:fld id="{55acb93c-94e0-4f18-8cca-4442e7025315}" type="datetime3">
               <a:rPr lang="en-GB" sz="1000" dirty="0">
                 <a:solidFill>
                   <a:srgbClr val="C4A35A"/>
@@ -10786,7 +10786,7 @@
           <a:lstStyle/>
           <a:p>
             <a:pPr algn="r"/>
-            <a:fld id="{37770477-ed62-4fc1-bd32-543c6b3d375a}" type="slidenum">
+            <a:fld id="{aa9f4d0c-fc34-43f0-9afd-5253eac15ef8}" type="slidenum">
               <a:rPr lang="en-GB" sz="1000" dirty="0">
                 <a:solidFill>
                   <a:srgbClr val="C4A35A"/>
@@ -11343,7 +11343,7 @@
           <a:lstStyle/>
           <a:p>
             <a:pPr algn="l"/>
-            <a:fld id="{d5d09001-286b-46ee-baf7-de3b7724f4c0}" type="datetime3">
+            <a:fld id="{98a746dd-a0f8-400b-965e-d91c4512dfaa}" type="datetime3">
               <a:rPr lang="en-GB" sz="1000" dirty="0">
                 <a:solidFill>
                   <a:srgbClr val="C4A35A"/>
@@ -11377,7 +11377,7 @@
           <a:lstStyle/>
           <a:p>
             <a:pPr algn="r"/>
-            <a:fld id="{e123b192-fb9b-4644-b015-dff371019967}" type="slidenum">
+            <a:fld id="{cfdef9ae-b28d-4cee-b4bd-feffcababcdd}" type="slidenum">
               <a:rPr lang="en-GB" sz="1000" dirty="0">
                 <a:solidFill>
                   <a:srgbClr val="C4A35A"/>
@@ -12188,7 +12188,7 @@
           <a:lstStyle/>
           <a:p>
             <a:pPr algn="l"/>
-            <a:fld id="{68b03453-3e86-4f64-9320-8f32d4aa2a7f}" type="datetime3">
+            <a:fld id="{46227e9c-8ef0-44d0-bf9c-e8f500ae93c3}" type="datetime3">
               <a:rPr lang="en-GB" sz="1000" dirty="0">
                 <a:solidFill>
                   <a:srgbClr val="C4A35A"/>
@@ -12222,7 +12222,7 @@
           <a:lstStyle/>
           <a:p>
             <a:pPr algn="r"/>
-            <a:fld id="{f8969b57-d5df-47b6-869f-798f1a73b396}" type="slidenum">
+            <a:fld id="{ebb3e152-2d02-427e-808c-4a7f6a1b460a}" type="slidenum">
               <a:rPr lang="en-GB" sz="1000" dirty="0">
                 <a:solidFill>
                   <a:srgbClr val="C4A35A"/>
@@ -13245,7 +13245,7 @@
           <a:lstStyle/>
           <a:p>
             <a:pPr algn="l"/>
-            <a:fld id="{d7dcd491-07ea-40a6-b2b5-87c0ef64f8a9}" type="datetime3">
+            <a:fld id="{6398514c-04ac-4f34-b2e9-43a3b1293156}" type="datetime3">
               <a:rPr lang="en-GB" sz="1000" dirty="0">
                 <a:solidFill>
                   <a:srgbClr val="C4A35A"/>
@@ -13279,7 +13279,7 @@
           <a:lstStyle/>
           <a:p>
             <a:pPr algn="r"/>
-            <a:fld id="{e33e67fa-3fc8-48b3-b5cc-82a5be004694}" type="slidenum">
+            <a:fld id="{6e6062b4-a982-4cdc-aba2-8dd2a021fa6a}" type="slidenum">
               <a:rPr lang="en-GB" sz="1000" dirty="0">
                 <a:solidFill>
                   <a:srgbClr val="C4A35A"/>
@@ -14255,7 +14255,7 @@
           <a:lstStyle/>
           <a:p>
             <a:pPr algn="l"/>
-            <a:fld id="{44c251bf-3ab3-468f-9418-27697c48c374}" type="datetime3">
+            <a:fld id="{3282c333-6e27-41c4-bffc-44c1acb576f9}" type="datetime3">
               <a:rPr lang="en-GB" sz="1000" dirty="0">
                 <a:solidFill>
                   <a:srgbClr val="C4A35A"/>
@@ -14289,7 +14289,7 @@
           <a:lstStyle/>
           <a:p>
             <a:pPr algn="r"/>
-            <a:fld id="{2eec9dba-4eef-494d-b224-dee0259a174c}" type="slidenum">
+            <a:fld id="{6f87e086-c5b0-4fe8-9ac1-cbc9c45fd56d}" type="slidenum">
               <a:rPr lang="en-GB" sz="1000" dirty="0">
                 <a:solidFill>
                   <a:srgbClr val="C4A35A"/>
@@ -15204,7 +15204,7 @@
           <a:lstStyle/>
           <a:p>
             <a:pPr algn="l"/>
-            <a:fld id="{089d6e83-3805-4c87-b3b9-cecd3693127e}" type="datetime3">
+            <a:fld id="{f782c0cc-c21d-42d9-a163-17db2cffd165}" type="datetime3">
               <a:rPr lang="en-GB" sz="1000" dirty="0">
                 <a:solidFill>
                   <a:srgbClr val="C4A35A"/>
@@ -15238,7 +15238,7 @@
           <a:lstStyle/>
           <a:p>
             <a:pPr algn="r"/>
-            <a:fld id="{e78ef978-ce2d-4573-b837-41ae78040204}" type="slidenum">
+            <a:fld id="{69c331df-02c5-4be4-ae0e-1dad3c0b3bcc}" type="slidenum">
               <a:rPr lang="en-GB" sz="1000" dirty="0">
                 <a:solidFill>
                   <a:srgbClr val="C4A35A"/>
@@ -16099,7 +16099,7 @@
           <a:lstStyle/>
           <a:p>
             <a:pPr algn="l"/>
-            <a:fld id="{92b66b4b-718c-4a9c-9384-9a83b42ccde9}" type="datetime3">
+            <a:fld id="{deb4b421-3bc1-48f4-b6f6-3a30519bf896}" type="datetime3">
               <a:rPr lang="en-GB" sz="1000" dirty="0">
                 <a:solidFill>
                   <a:srgbClr val="C4A35A"/>
@@ -16133,7 +16133,7 @@
           <a:lstStyle/>
           <a:p>
             <a:pPr algn="r"/>
-            <a:fld id="{1dcad377-8849-49f5-b394-2755819130b0}" type="slidenum">
+            <a:fld id="{28145069-2800-481b-92e8-c40b5facddf9}" type="slidenum">
               <a:rPr lang="en-GB" sz="1000" dirty="0">
                 <a:solidFill>
                   <a:srgbClr val="C4A35A"/>
@@ -17048,7 +17048,7 @@
           <a:lstStyle/>
           <a:p>
             <a:pPr algn="l"/>
-            <a:fld id="{adf3b84c-66b7-4806-bda7-dbe89e147a58}" type="datetime3">
+            <a:fld id="{edb4078d-af2c-4190-80f1-590e3383c0a8}" type="datetime3">
               <a:rPr lang="en-GB" sz="1000" dirty="0">
                 <a:solidFill>
                   <a:srgbClr val="C4A35A"/>
@@ -17082,7 +17082,7 @@
           <a:lstStyle/>
           <a:p>
             <a:pPr algn="r"/>
-            <a:fld id="{12c37e77-af7d-4463-892d-90fc9c1a5acd}" type="slidenum">
+            <a:fld id="{9000935d-5de4-4def-8315-b8ceb7a03d68}" type="slidenum">
               <a:rPr lang="en-GB" sz="1000" dirty="0">
                 <a:solidFill>
                   <a:srgbClr val="C4A35A"/>
@@ -17621,7 +17621,7 @@
           <a:lstStyle/>
           <a:p>
             <a:pPr algn="l"/>
-            <a:fld id="{44a91fcc-0266-4c88-812e-40152ab32524}" type="datetime3">
+            <a:fld id="{4f6e9deb-58e6-42ab-9759-590ff1ae9b49}" type="datetime3">
               <a:rPr lang="en-GB" sz="1000" dirty="0">
                 <a:solidFill>
                   <a:srgbClr val="C4A35A"/>
@@ -17655,7 +17655,7 @@
           <a:lstStyle/>
           <a:p>
             <a:pPr algn="r"/>
-            <a:fld id="{75b0cddd-ae62-455a-9736-6e458fd72700}" type="slidenum">
+            <a:fld id="{4738fe04-9507-436f-b459-a31a20b55165}" type="slidenum">
               <a:rPr lang="en-GB" sz="1000" dirty="0">
                 <a:solidFill>
                   <a:srgbClr val="C4A35A"/>
@@ -18607,7 +18607,7 @@
           <a:lstStyle/>
           <a:p>
             <a:pPr algn="l"/>
-            <a:fld id="{031166c3-5ffe-4bd9-bbad-108368caa7f5}" type="datetime3">
+            <a:fld id="{078a16c0-2001-478e-9a5d-f537e19c5c91}" type="datetime3">
               <a:rPr lang="en-GB" sz="1000" dirty="0">
                 <a:solidFill>
                   <a:srgbClr val="C4A35A"/>
@@ -18641,7 +18641,7 @@
           <a:lstStyle/>
           <a:p>
             <a:pPr algn="r"/>
-            <a:fld id="{3cf87082-bf11-4119-a08e-ec1cbc8c7689}" type="slidenum">
+            <a:fld id="{94e3b12a-ba12-423a-8c18-81c3f07c5b40}" type="slidenum">
               <a:rPr lang="en-GB" sz="1000" dirty="0">
                 <a:solidFill>
                   <a:srgbClr val="C4A35A"/>
@@ -19216,7 +19216,7 @@
           <a:lstStyle/>
           <a:p>
             <a:pPr algn="l"/>
-            <a:fld id="{b297694d-09df-41e3-8ae6-d9a1e600a644}" type="datetime3">
+            <a:fld id="{86ca9b64-c0bb-408c-95e8-46a852909882}" type="datetime3">
               <a:rPr lang="en-GB" sz="1000" dirty="0">
                 <a:solidFill>
                   <a:srgbClr val="C4A35A"/>
@@ -19250,7 +19250,7 @@
           <a:lstStyle/>
           <a:p>
             <a:pPr algn="r"/>
-            <a:fld id="{d0647af6-dc4a-4f45-a3b4-82321bff3b1e}" type="slidenum">
+            <a:fld id="{033420c5-3419-4963-9d96-b9b1965900b8}" type="slidenum">
               <a:rPr lang="en-GB" sz="1000" dirty="0">
                 <a:solidFill>
                   <a:srgbClr val="C4A35A"/>
@@ -19825,7 +19825,7 @@
           <a:lstStyle/>
           <a:p>
             <a:pPr algn="l"/>
-            <a:fld id="{5b33bf48-2989-4acb-b027-6a5fa2e3cad9}" type="datetime3">
+            <a:fld id="{32df07e0-ecff-4d1d-bb55-7f37681f3043}" type="datetime3">
               <a:rPr lang="en-GB" sz="1000" dirty="0">
                 <a:solidFill>
                   <a:srgbClr val="C4A35A"/>
@@ -19859,7 +19859,7 @@
           <a:lstStyle/>
           <a:p>
             <a:pPr algn="r"/>
-            <a:fld id="{cc893ca0-cf49-4246-84c8-25a8ae0b26e3}" type="slidenum">
+            <a:fld id="{281bebbf-2d90-4959-97b8-f56472cfab6f}" type="slidenum">
               <a:rPr lang="en-GB" sz="1000" dirty="0">
                 <a:solidFill>
                   <a:srgbClr val="C4A35A"/>
@@ -20434,7 +20434,7 @@
           <a:lstStyle/>
           <a:p>
             <a:pPr algn="l"/>
-            <a:fld id="{72a9bf4f-2028-48a8-a316-be230cbd3092}" type="datetime3">
+            <a:fld id="{1a431efa-404b-4388-ac3b-238957cf7fd3}" type="datetime3">
               <a:rPr lang="en-GB" sz="1000" dirty="0">
                 <a:solidFill>
                   <a:srgbClr val="C4A35A"/>
@@ -20468,7 +20468,7 @@
           <a:lstStyle/>
           <a:p>
             <a:pPr algn="r"/>
-            <a:fld id="{5230787d-625f-4ee9-a49f-2df02fabe3a2}" type="slidenum">
+            <a:fld id="{a98b6e33-b4d7-4af1-b299-464d5bea1e99}" type="slidenum">
               <a:rPr lang="en-GB" sz="1000" dirty="0">
                 <a:solidFill>
                   <a:srgbClr val="C4A35A"/>
@@ -21043,7 +21043,7 @@
           <a:lstStyle/>
           <a:p>
             <a:pPr algn="l"/>
-            <a:fld id="{f4439b7d-5f5f-4722-9f50-af19d8a9612f}" type="datetime3">
+            <a:fld id="{163db0e1-9c7b-4723-a275-11f73dd8a5c7}" type="datetime3">
               <a:rPr lang="en-GB" sz="1000" dirty="0">
                 <a:solidFill>
                   <a:srgbClr val="C4A35A"/>
@@ -21077,7 +21077,7 @@
           <a:lstStyle/>
           <a:p>
             <a:pPr algn="r"/>
-            <a:fld id="{dc6f4874-ec18-4aa7-b86c-1a263e989e8d}" type="slidenum">
+            <a:fld id="{7d2990bb-84f3-4e75-8478-7178bcab328b}" type="slidenum">
               <a:rPr lang="en-GB" sz="1000" dirty="0">
                 <a:solidFill>
                   <a:srgbClr val="C4A35A"/>
@@ -22046,7 +22046,7 @@
           <a:lstStyle/>
           <a:p>
             <a:pPr algn="l"/>
-            <a:fld id="{054e8042-0499-42dc-ae32-b7f6a90f8ce3}" type="datetime3">
+            <a:fld id="{92f5d081-8ca8-439d-8591-e64f6dde8bee}" type="datetime3">
               <a:rPr lang="en-GB" sz="1000" dirty="0">
                 <a:solidFill>
                   <a:srgbClr val="C4A35A"/>
@@ -22080,7 +22080,7 @@
           <a:lstStyle/>
           <a:p>
             <a:pPr algn="r"/>
-            <a:fld id="{2681fa6d-ff5e-4568-acd6-0ad485369a6e}" type="slidenum">
+            <a:fld id="{a1dc31de-12ca-44d3-89ca-5d68389493fb}" type="slidenum">
               <a:rPr lang="en-GB" sz="1000" dirty="0">
                 <a:solidFill>
                   <a:srgbClr val="C4A35A"/>
@@ -22871,7 +22871,7 @@
           <a:lstStyle/>
           <a:p>
             <a:pPr algn="l"/>
-            <a:fld id="{3a3e51fc-7134-4edc-879e-a34e7fcdb6d3}" type="datetime3">
+            <a:fld id="{9a4fbf78-f12e-49aa-9788-d6d30dd14603}" type="datetime3">
               <a:rPr lang="en-GB" sz="1000" dirty="0">
                 <a:solidFill>
                   <a:srgbClr val="C4A35A"/>
@@ -22905,7 +22905,7 @@
           <a:lstStyle/>
           <a:p>
             <a:pPr algn="r"/>
-            <a:fld id="{b45f0f29-41d1-44e5-afb2-6eaad4f92fed}" type="slidenum">
+            <a:fld id="{75382165-4812-411e-aa54-1e25131180c4}" type="slidenum">
               <a:rPr lang="en-GB" sz="1000" dirty="0">
                 <a:solidFill>
                   <a:srgbClr val="C4A35A"/>
@@ -23716,7 +23716,7 @@
           <a:lstStyle/>
           <a:p>
             <a:pPr algn="l"/>
-            <a:fld id="{ebeb2b45-25cc-4612-81d4-8555266e92f5}" type="datetime3">
+            <a:fld id="{bc71ca46-2131-4257-9429-57f9957cfee7}" type="datetime3">
               <a:rPr lang="en-GB" sz="1000" dirty="0">
                 <a:solidFill>
                   <a:srgbClr val="C4A35A"/>
@@ -23750,7 +23750,7 @@
           <a:lstStyle/>
           <a:p>
             <a:pPr algn="r"/>
-            <a:fld id="{dd0e9598-9073-4892-b0bb-04d4c82709e1}" type="slidenum">
+            <a:fld id="{77b496b8-90b6-4225-90e3-6229ca4feaf5}" type="slidenum">
               <a:rPr lang="en-GB" sz="1000" dirty="0">
                 <a:solidFill>
                   <a:srgbClr val="C4A35A"/>
@@ -24342,7 +24342,7 @@
           <a:lstStyle/>
           <a:p>
             <a:pPr algn="l"/>
-            <a:fld id="{50758c20-f5bd-4fb4-aaca-e09d37af4410}" type="datetime3">
+            <a:fld id="{80a1cfef-7f2d-45a1-b1fd-fdf6d9e4240a}" type="datetime3">
               <a:rPr lang="en-GB" sz="1000" dirty="0">
                 <a:solidFill>
                   <a:srgbClr val="C4A35A"/>
@@ -24376,7 +24376,7 @@
           <a:lstStyle/>
           <a:p>
             <a:pPr algn="r"/>
-            <a:fld id="{d415777c-f86d-4ccc-bcaf-d2c6bbabc25e}" type="slidenum">
+            <a:fld id="{21277150-b1e2-4deb-ba07-c71270a77b4c}" type="slidenum">
               <a:rPr lang="en-GB" sz="1000" dirty="0">
                 <a:solidFill>
                   <a:srgbClr val="C4A35A"/>
@@ -24968,7 +24968,7 @@
           <a:lstStyle/>
           <a:p>
             <a:pPr algn="l"/>
-            <a:fld id="{4e291afa-0131-4997-af56-a51dea43ddfe}" type="datetime3">
+            <a:fld id="{120b136f-223b-4107-9840-3e98487ffba1}" type="datetime3">
               <a:rPr lang="en-GB" sz="1000" dirty="0">
                 <a:solidFill>
                   <a:srgbClr val="C4A35A"/>
@@ -25002,7 +25002,7 @@
           <a:lstStyle/>
           <a:p>
             <a:pPr algn="r"/>
-            <a:fld id="{4a0248f8-445b-497d-b18b-9cf3b22198d4}" type="slidenum">
+            <a:fld id="{5ab24881-973b-4c80-a28e-4d7d823cb625}" type="slidenum">
               <a:rPr lang="en-GB" sz="1000" dirty="0">
                 <a:solidFill>
                   <a:srgbClr val="C4A35A"/>
@@ -25559,7 +25559,7 @@
           <a:lstStyle/>
           <a:p>
             <a:pPr algn="l"/>
-            <a:fld id="{07c22726-c74e-40b5-8f9b-6b83237095fe}" type="datetime3">
+            <a:fld id="{36408254-1929-44f3-9c9a-f459a1e038fd}" type="datetime3">
               <a:rPr lang="en-GB" sz="1000" dirty="0">
                 <a:solidFill>
                   <a:srgbClr val="C4A35A"/>
@@ -25593,7 +25593,7 @@
           <a:lstStyle/>
           <a:p>
             <a:pPr algn="r"/>
-            <a:fld id="{39a27919-5fcd-4548-a814-d47729fe662e}" type="slidenum">
+            <a:fld id="{6c691614-5aff-456d-8857-accc0dd8c635}" type="slidenum">
               <a:rPr lang="en-GB" sz="1000" dirty="0">
                 <a:solidFill>
                   <a:srgbClr val="C4A35A"/>
@@ -26089,7 +26089,7 @@
                 </a:solidFill>
                 <a:latin typeface="Calibri"/>
               </a:rPr>
-              <a:t>Wu, Q., Bansal, G., Zhang, J., Wu, Y., Li, B., Zhu, E., Jiang, L., Zhang, X., Zhang, S., Liu, J., Awadallah, A. H., White, R. W., Burger, D., and Wang, C. AutoGen: Enabling Next-Gen LLM Applications via Multi-Agent Conversations. Conference on Language Modeling (COLM) 2024.</a:t>
+              <a:t>Wu, Q., Bansal, G., Zhang, J., Wu, Y., Li, B., Zhu, E., Jiang, L., Zhang, X., Zhang, S., Liu, J., Awadallah, A. H., White, R. W., Burger, D., and Wang, C. AutoGen: Enabling Next-Gen LLM Applications via Multi-Agent Conversations. Proceedings of the First Conference on Language Modeling (COLM 2024).</a:t>
             </a:r>
           </a:p>
           <a:p>
@@ -26107,7 +26107,7 @@
                 </a:solidFill>
                 <a:latin typeface="Calibri"/>
               </a:rPr>
-              <a:t>Hong, S., Zhuge, M., Chen, J., Zheng, X., Cheng, Y., Wang, J., Zhang, C., Wang, Z., Yau, S. K. S., Lin, Z., Zhou, L., Ran, C., Xiao, L., Wu, C., and Schmidhuber, J. MetaGPT: Meta Programming for A Multi-Agent Collaborative Framework. ICLR 2024.</a:t>
+              <a:t>Hong, S., Zhuge, M., Chen, J., Zheng, X., Cheng, Y., Wang, J., Zhang, C., Wang, Z., Yau, S. K. S., Lin, Z., Zhou, L., Ran, C., Xiao, L., Wu, C., and Schmidhuber, J. MetaGPT: Meta Programming for A Multi-Agent Collaborative Framework. Proceedings of the Twelfth International Conference on Learning Representations (ICLR 2024).</a:t>
             </a:r>
           </a:p>
           <a:p>
@@ -26125,7 +26125,7 @@
                 </a:solidFill>
                 <a:latin typeface="Calibri"/>
               </a:rPr>
-              <a:t>Li, G., Hammoud, H. A. A. K., Itani, H., Khizbullin, D., and Ghanem, B. CAMEL: Communicative Agents for “Mind” Exploration of Large Language Model Society. NeurIPS 2023.</a:t>
+              <a:t>Li, G., Hammoud, H. A. A. K., Itani, H., Khizbullin, D., and Ghanem, B. CAMEL: Communicative Agents for “Mind” Exploration of Large Language Model Society. Advances in Neural Information Processing Systems 36 (NeurIPS 2023).</a:t>
             </a:r>
           </a:p>
           <a:p>
@@ -26143,7 +26143,7 @@
                 </a:solidFill>
                 <a:latin typeface="Calibri"/>
               </a:rPr>
-              <a:t>Qian, C., Liu, W., Liu, H., Chen, N., Dang, Y., Li, J., Yang, C., Chen, W., Su, Y., Cong, X., Xu, J., Li, D., Liu, Z., and Sun, M. ChatDev: Communicative Agents for Software Development. ACL 2024 (long), pages 15174–15186. doi:10.18653/v1/2024.acl-long.810.</a:t>
+              <a:t>Qian, C., Liu, W., Liu, H., Chen, N., Dang, Y., Li, J., Yang, C., Chen, W., Su, Y., Cong, X., Xu, J., Li, D., Liu, Z., and Sun, M. ChatDev: Communicative Agents for Software Development. Proceedings of the 62nd Annual Meeting of the Association for Computational Linguistics (Volume 1: Long Papers), pages 15174–15186. doi:10.18653/v1/2024.acl-long.810.</a:t>
             </a:r>
           </a:p>
         </p:txBody>
@@ -26169,7 +26169,7 @@
           <a:lstStyle/>
           <a:p>
             <a:pPr algn="l"/>
-            <a:fld id="{a5c718af-0715-4364-8b7d-7acc49722591}" type="datetime3">
+            <a:fld id="{ec1287ae-0a9e-4355-ab27-01d85551cf39}" type="datetime3">
               <a:rPr lang="en-GB" sz="1000" dirty="0">
                 <a:solidFill>
                   <a:srgbClr val="C4A35A"/>
@@ -26203,7 +26203,7 @@
           <a:lstStyle/>
           <a:p>
             <a:pPr algn="r"/>
-            <a:fld id="{df32d1cb-e294-4787-b634-982999d56f83}" type="slidenum">
+            <a:fld id="{df1bc67c-1d2b-495a-8ed0-01572de2a505}" type="slidenum">
               <a:rPr lang="en-GB" sz="1000" dirty="0">
                 <a:solidFill>
                   <a:srgbClr val="C4A35A"/>
@@ -26627,7 +26627,7 @@
                 </a:solidFill>
                 <a:latin typeface="Calibri"/>
               </a:rPr>
-              <a:t>Qin, Y., Liang, S., Ye, Y., Zhu, K., Yan, L., Lu, Y., Lin, Y., Cong, X., Tang, X., Qian, B., Zhao, S., Hong, L., Tian, R., Xie, R., Zhou, J., Gerstein, M., Li, D., Liu, Z., and Sun, M. ToolLLM: Facilitating Large Language Models to Master 16000+ Real-world APIs. ICLR 2024.</a:t>
+              <a:t>Qin, Y., Liang, S., Ye, Y., Zhu, K., Yan, L., Lu, Y., Lin, Y., Cong, X., Tang, X., Qian, B., Zhao, S., Hong, L., Tian, R., Xie, R., Zhou, J., Gerstein, M., Li, D., Liu, Z., and Sun, M. ToolLLM: Facilitating Large Language Models to Master 16000+ Real-world APIs. Proceedings of the Twelfth International Conference on Learning Representations (ICLR 2024).</a:t>
             </a:r>
           </a:p>
           <a:p>
@@ -26645,7 +26645,7 @@
                 </a:solidFill>
                 <a:latin typeface="Calibri"/>
               </a:rPr>
-              <a:t>Zheng, Y., Li, P., Liu, W., Liu, Y., Luan, J., and Wang, B. ToolRerank: Adaptive and Hierarchy-Aware Reranking for Tool Retrieval. LREC-COLING 2024, pages 16263–16273. ACL Anthology 2024.lrec-main.1413.</a:t>
+              <a:t>Zheng, Y., Li, P., Liu, W., Liu, Y., Luan, J., and Wang, B. ToolRerank: Adaptive and Hierarchy-Aware Reranking for Tool Retrieval. Proceedings of the 2024 Joint International Conference on Computational Linguistics, Language Resources and Evaluation (LREC-COLING 2024), pages 16263–16273. ACL Anthology 2024.lrec-main.1413.</a:t>
             </a:r>
           </a:p>
           <a:p>
@@ -26663,7 +26663,7 @@
                 </a:solidFill>
                 <a:latin typeface="Calibri"/>
               </a:rPr>
-              <a:t>Ong, I., Almahairi, A., Wu, V., Chiang, W.-L., Wu, T., Gonzalez, J. E., Kadous, M. W., and Stoica, I. RouteLLM: Learning to Route LLMs from Preference Data. ICLR 2025.</a:t>
+              <a:t>Ong, I., Almahairi, A., Wu, V., Chiang, W.-L., Wu, T., Gonzalez, J. E., Kadous, M. W., and Stoica, I. RouteLLM: Learning to Route LLMs from Preference Data. Proceedings of the Thirteenth International Conference on Learning Representations (ICLR 2025).</a:t>
             </a:r>
           </a:p>
           <a:p>
@@ -26699,7 +26699,7 @@
                 </a:solidFill>
                 <a:latin typeface="Calibri"/>
               </a:rPr>
-              <a:t>Yue, Y., Zhang, G., Liu, B., Wan, G., Wang, K., Cheng, D., and Qi, Y. MasRouter: Learning to Route LLMs for Multi-Agent Systems. ACL 2025 (long), pages 15549–15572. doi:10.18653/v1/2025.acl-long.757.</a:t>
+              <a:t>Yue, Y., Zhang, G., Liu, B., Wan, G., Wang, K., Cheng, D., and Qi, Y. MasRouter: Learning to Route LLMs for Multi-Agent Systems. Proceedings of the 63rd Annual Meeting of the Association for Computational Linguistics (Volume 1: Long Papers), pages 15549–15572. doi:10.18653/v1/2025.acl-long.757.</a:t>
             </a:r>
           </a:p>
           <a:p>
@@ -26717,7 +26717,7 @@
                 </a:solidFill>
                 <a:latin typeface="Calibri"/>
               </a:rPr>
-              <a:t>Jiang, H., Wu, Q., Lin, C.-Y., Yang, Y., and Qiu, L. LLMLingua: Compressing Prompts for Accelerated Inference of Large Language Models. EMNLP 2023, pages 13358–13376. doi:10.18653/v1/2023.emnlp-main.825.</a:t>
+              <a:t>Jiang, H., Wu, Q., Lin, C.-Y., Yang, Y., and Qiu, L. LLMLingua: Compressing Prompts for Accelerated Inference of Large Language Models. Proceedings of the 2023 Conference on Empirical Methods in Natural Language Processing, pages 13358–13376. doi:10.18653/v1/2023.emnlp-main.825.</a:t>
             </a:r>
           </a:p>
           <a:p>
@@ -26735,7 +26735,7 @@
                 </a:solidFill>
                 <a:latin typeface="Calibri"/>
               </a:rPr>
-              <a:t>Wei, J., Wang, X., Schuurmans, D., Bosma, M., Ichter, B., Xia, F., Chi, E., Le, Q., and Zhou, D. Chain-of-Thought Prompting Elicits Reasoning in Large Language Models. NeurIPS 2022.</a:t>
+              <a:t>Wei, J., Wang, X., Schuurmans, D., Bosma, M., Ichter, B., Xia, F., Chi, E., Le, Q., and Zhou, D. Chain-of-Thought Prompting Elicits Reasoning in Large Language Models. Advances in Neural Information Processing Systems 35 (NeurIPS 2022).</a:t>
             </a:r>
           </a:p>
           <a:p>
@@ -26753,7 +26753,7 @@
                 </a:solidFill>
                 <a:latin typeface="Calibri"/>
               </a:rPr>
-              <a:t>Yao, S., Zhao, J., Yu, D., Du, N., Shafran, I., Narasimhan, K., and Cao, Y. ReAct: Synergizing Reasoning and Acting in Language Models. ICLR 2023.</a:t>
+              <a:t>Yao, S., Zhao, J., Yu, D., Du, N., Shafran, I., Narasimhan, K., and Cao, Y. ReAct: Synergizing Reasoning and Acting in Language Models. Proceedings of the Eleventh International Conference on Learning Representations (ICLR 2023).</a:t>
             </a:r>
           </a:p>
         </p:txBody>
@@ -26779,7 +26779,7 @@
           <a:lstStyle/>
           <a:p>
             <a:pPr algn="l"/>
-            <a:fld id="{70191280-7c70-429a-9484-252d21e94484}" type="datetime3">
+            <a:fld id="{511d6bfe-66cf-4e4e-a423-9a637bbbbc4c}" type="datetime3">
               <a:rPr lang="en-GB" sz="1000" dirty="0">
                 <a:solidFill>
                   <a:srgbClr val="C4A35A"/>
@@ -26813,7 +26813,7 @@
           <a:lstStyle/>
           <a:p>
             <a:pPr algn="r"/>
-            <a:fld id="{89bee0e0-4768-4480-b582-39cbd4fc3ffd}" type="slidenum">
+            <a:fld id="{349acc61-3c29-4969-821e-0cb397fb4045}" type="slidenum">
               <a:rPr lang="en-GB" sz="1000" dirty="0">
                 <a:solidFill>
                   <a:srgbClr val="C4A35A"/>
@@ -27237,7 +27237,7 @@
                 </a:solidFill>
                 <a:latin typeface="Calibri"/>
               </a:rPr>
-              <a:t>Yao, S., Yu, D., Zhao, J., Shafran, I., Griffiths, T. L., Cao, Y., and Narasimhan, K. Tree of Thoughts: Deliberate Problem Solving with Large Language Models. NeurIPS 2023.</a:t>
+              <a:t>Yao, S., Yu, D., Zhao, J., Shafran, I., Griffiths, T. L., Cao, Y., and Narasimhan, K. Tree of Thoughts: Deliberate Problem Solving with Large Language Models. Advances in Neural Information Processing Systems 36 (NeurIPS 2023).</a:t>
             </a:r>
           </a:p>
           <a:p>
@@ -27255,7 +27255,7 @@
                 </a:solidFill>
                 <a:latin typeface="Calibri"/>
               </a:rPr>
-              <a:t>Park, J. S., O’Brien, J. C., Cai, C. J., Morris, M. R., Liang, P., and Bernstein, M. S. Generative Agents: Interactive Simulacra of Human Behavior. UIST 2023 (Best Paper). doi:10.1145/3586183.3606763.</a:t>
+              <a:t>Park, J. S., O’Brien, J. C., Cai, C. J., Morris, M. R., Liang, P., and Bernstein, M. S. Generative Agents: Interactive Simulacra of Human Behavior. Proceedings of the 36th Annual ACM Symposium on User Interface Software and Technology (UIST 2023), Best Paper. doi:10.1145/3586183.3606763.</a:t>
             </a:r>
           </a:p>
           <a:p>
@@ -27291,7 +27291,7 @@
                 </a:solidFill>
                 <a:latin typeface="Calibri"/>
               </a:rPr>
-              <a:t>Shinn, N., Cassano, F., Gopinath, A., Narasimhan, K., and Yao, S. Reflexion: Language Agents with Verbal Reinforcement Learning. NeurIPS 2023.</a:t>
+              <a:t>Shinn, N., Cassano, F., Gopinath, A., Narasimhan, K., and Yao, S. Reflexion: Language Agents with Verbal Reinforcement Learning. Advances in Neural Information Processing Systems 36 (NeurIPS 2023).</a:t>
             </a:r>
           </a:p>
           <a:p>
@@ -27309,7 +27309,7 @@
                 </a:solidFill>
                 <a:latin typeface="Calibri"/>
               </a:rPr>
-              <a:t>Shen, Y., Song, K., Tan, X., Li, D., Lu, W., and Zhuang, Y. HuggingGPT: Solving AI Tasks with ChatGPT and its Friends in Hugging Face. NeurIPS 2023.</a:t>
+              <a:t>Shen, Y., Song, K., Tan, X., Li, D., Lu, W., and Zhuang, Y. HuggingGPT: Solving AI Tasks with ChatGPT and its Friends in Hugging Face. Advances in Neural Information Processing Systems 36 (NeurIPS 2023).</a:t>
             </a:r>
           </a:p>
           <a:p>
@@ -27327,7 +27327,7 @@
                 </a:solidFill>
                 <a:latin typeface="Calibri"/>
               </a:rPr>
-              <a:t>Schick, T., Dwivedi-Yu, J., Dessì, R., Raileanu, R., Lomeli, M., Hambro, E., Zettlemoyer, L., Cancedda, N., and Scialom, T. Toolformer: Language Models Can Teach Themselves to Use Tools. NeurIPS 2023.</a:t>
+              <a:t>Schick, T., Dwivedi-Yu, J., Dessì, R., Raileanu, R., Lomeli, M., Hambro, E., Zettlemoyer, L., Cancedda, N., and Scialom, T. Toolformer: Language Models Can Teach Themselves to Use Tools. Advances in Neural Information Processing Systems 36 (NeurIPS 2023).</a:t>
             </a:r>
           </a:p>
           <a:p>
@@ -27345,7 +27345,7 @@
                 </a:solidFill>
                 <a:latin typeface="Calibri"/>
               </a:rPr>
-              <a:t>Guo, H., Woodruff, A., and Yadav, A. Improving Lives of Indebted Farmers Using Deep Learning: Predicting Agricultural Produce Prices Using Convolutional Neural Networks (PECAD). AAAI 2020. doi:10.1609/aaai.v34i08.7039. AGMARKNET scrape for price prediction; cited here as Indian OGD precedent, not as a baseline this proposal claims to beat.</a:t>
+              <a:t>Guo, H., Woodruff, A., and Yadav, A. Improving Lives of Indebted Farmers Using Deep Learning: Predicting Agricultural Produce Prices Using Convolutional Neural Networks (PECAD). Proceedings of the AAAI Conference on Artificial Intelligence, 34(08):13294–13299. doi:10.1609/aaai.v34i08.7039. AGMARKNET scrape for price prediction; cited here as Indian OGD precedent, not as a baseline this proposal claims to beat.</a:t>
             </a:r>
           </a:p>
           <a:p>
@@ -27424,7 +27424,7 @@
           <a:lstStyle/>
           <a:p>
             <a:pPr algn="l"/>
-            <a:fld id="{5cd37dfa-9fb7-413d-b0b7-88ae9a1b91d7}" type="datetime3">
+            <a:fld id="{eed4704f-367c-4efb-a9b9-d173f636102b}" type="datetime3">
               <a:rPr lang="en-GB" sz="1000" dirty="0">
                 <a:solidFill>
                   <a:srgbClr val="C4A35A"/>
@@ -27458,7 +27458,7 @@
           <a:lstStyle/>
           <a:p>
             <a:pPr algn="r"/>
-            <a:fld id="{1b06f2d8-21ae-472f-b4de-411fbece50d1}" type="slidenum">
+            <a:fld id="{16feb509-4f75-402f-822f-80fdd9f94104}" type="slidenum">
               <a:rPr lang="en-GB" sz="1000" dirty="0">
                 <a:solidFill>
                   <a:srgbClr val="C4A35A"/>
@@ -28033,7 +28033,7 @@
           <a:lstStyle/>
           <a:p>
             <a:pPr algn="l"/>
-            <a:fld id="{4a6fc49e-0990-4e55-8cb5-7405b3c209d7}" type="datetime3">
+            <a:fld id="{4237108f-9196-42a8-9ede-5ba3d99c00ec}" type="datetime3">
               <a:rPr lang="en-GB" sz="1000" dirty="0">
                 <a:solidFill>
                   <a:srgbClr val="C4A35A"/>
@@ -28067,7 +28067,7 @@
           <a:lstStyle/>
           <a:p>
             <a:pPr algn="r"/>
-            <a:fld id="{061762f7-2cdb-43da-bbcb-e56ad762c65d}" type="slidenum">
+            <a:fld id="{d181acde-5a46-47ce-bda5-05478a7ffcb5}" type="slidenum">
               <a:rPr lang="en-GB" sz="1000" dirty="0">
                 <a:solidFill>
                   <a:srgbClr val="C4A35A"/>
@@ -28624,7 +28624,7 @@
           <a:lstStyle/>
           <a:p>
             <a:pPr algn="l"/>
-            <a:fld id="{0298fed2-18a5-4eb8-9eca-597534549e68}" type="datetime3">
+            <a:fld id="{0dcdaeb4-6425-4e4d-aeb2-4aa0b0e2d629}" type="datetime3">
               <a:rPr lang="en-GB" sz="1000" dirty="0">
                 <a:solidFill>
                   <a:srgbClr val="C4A35A"/>
@@ -28658,7 +28658,7 @@
           <a:lstStyle/>
           <a:p>
             <a:pPr algn="r"/>
-            <a:fld id="{045300fe-3791-4257-bac4-8320224a57f2}" type="slidenum">
+            <a:fld id="{21984bfa-6b85-424e-a2a7-1a191f69139d}" type="slidenum">
               <a:rPr lang="en-GB" sz="1000" dirty="0">
                 <a:solidFill>
                   <a:srgbClr val="C4A35A"/>
@@ -29076,7 +29076,7 @@
                 </a:solidFill>
                 <a:latin typeface="Calibri"/>
               </a:rPr>
-              <a:t>FET template. Each paper is one Evidence block: Author(s), Year, Title, Publication, Objective, Methodology, Findings, Limitations, To solve the research gap. Venues are journals or top international conference proceedings — not preprint reports.</a:t>
+              <a:t>FET template. Each paper is one Evidence block: Author(s), Year, Title, Publication, Objective, Methodology, Findings, Limitations, To solve the research gap. Publication is the journal or the full international conference proceedings title — not a preprint report.</a:t>
             </a:r>
           </a:p>
         </p:txBody>
@@ -29710,7 +29710,7 @@
           <a:lstStyle/>
           <a:p>
             <a:pPr algn="l"/>
-            <a:fld id="{01e485bb-39a8-4822-acfc-53b2f1e48acc}" type="datetime3">
+            <a:fld id="{f0867af2-9d98-4820-9d7c-4f6c6c1b4e22}" type="datetime3">
               <a:rPr lang="en-GB" sz="1000" dirty="0">
                 <a:solidFill>
                   <a:srgbClr val="C4A35A"/>
@@ -29744,7 +29744,7 @@
           <a:lstStyle/>
           <a:p>
             <a:pPr algn="r"/>
-            <a:fld id="{83e84172-a615-4fe6-8a7e-7964370945d5}" type="slidenum">
+            <a:fld id="{03d0a7bb-bfe6-4a6e-b6fd-fc9e6c09aebd}" type="slidenum">
               <a:rPr lang="en-GB" sz="1000" dirty="0">
                 <a:solidFill>
                   <a:srgbClr val="C4A35A"/>
@@ -30796,7 +30796,7 @@
           <a:lstStyle/>
           <a:p>
             <a:pPr algn="l"/>
-            <a:fld id="{61e08b4d-3c4f-4186-abfa-811ec51e3a90}" type="datetime3">
+            <a:fld id="{14db6e45-e613-4f57-a6b2-5d017d02dfd2}" type="datetime3">
               <a:rPr lang="en-GB" sz="1000" dirty="0">
                 <a:solidFill>
                   <a:srgbClr val="C4A35A"/>
@@ -30830,7 +30830,7 @@
           <a:lstStyle/>
           <a:p>
             <a:pPr algn="r"/>
-            <a:fld id="{7749d738-8b1d-4333-8290-1681ef7f14ea}" type="slidenum">
+            <a:fld id="{e1424b5e-4f83-4f6a-87f1-ba4f4878446d}" type="slidenum">
               <a:rPr lang="en-GB" sz="1000" dirty="0">
                 <a:solidFill>
                   <a:srgbClr val="C4A35A"/>
@@ -31440,7 +31440,7 @@
                 </a:solidFill>
                 <a:latin typeface="Calibri"/>
               </a:rPr>
-              <a:t>Conference on Language Modeling (COLM) 2024</a:t>
+              <a:t>Proceedings of the First Conference on Language Modeling (COLM 2024)</a:t>
             </a:r>
           </a:p>
           <a:p>
@@ -31744,7 +31744,7 @@
                 </a:solidFill>
                 <a:latin typeface="Calibri"/>
               </a:rPr>
-              <a:t>ICLR 2024</a:t>
+              <a:t>Proceedings of the Twelfth International Conference on Learning Representations (ICLR 2024)</a:t>
             </a:r>
           </a:p>
           <a:p>
@@ -31882,7 +31882,7 @@
           <a:lstStyle/>
           <a:p>
             <a:pPr algn="l"/>
-            <a:fld id="{fefb8df8-8a24-4489-bdca-73608b7453e9}" type="datetime3">
+            <a:fld id="{80b00913-893a-4471-a7cf-625f85ea8a26}" type="datetime3">
               <a:rPr lang="en-GB" sz="1000" dirty="0">
                 <a:solidFill>
                   <a:srgbClr val="C4A35A"/>
@@ -31916,7 +31916,7 @@
           <a:lstStyle/>
           <a:p>
             <a:pPr algn="r"/>
-            <a:fld id="{38cdff50-6b0d-4fcb-8de0-972f8dc33330}" type="slidenum">
+            <a:fld id="{71cd3473-68cd-4a5a-800c-4791cfc239b5}" type="slidenum">
               <a:rPr lang="en-GB" sz="1000" dirty="0">
                 <a:solidFill>
                   <a:srgbClr val="C4A35A"/>
@@ -32526,7 +32526,7 @@
                 </a:solidFill>
                 <a:latin typeface="Calibri"/>
               </a:rPr>
-              <a:t>ACL 2024 (long), pages 15174–15186. doi:10.18653/v1/2024.acl-long.810</a:t>
+              <a:t>Proceedings of the 62nd Annual Meeting of the Association for Computational Linguistics (Volume 1: Long Papers), pages 15174–15186. doi:10.18653/v1/2024.acl-long.810</a:t>
             </a:r>
           </a:p>
           <a:p>
@@ -32830,7 +32830,7 @@
                 </a:solidFill>
                 <a:latin typeface="Calibri"/>
               </a:rPr>
-              <a:t>NeurIPS 2023</a:t>
+              <a:t>Advances in Neural Information Processing Systems 36 (NeurIPS 2023)</a:t>
             </a:r>
           </a:p>
           <a:p>
@@ -32968,7 +32968,7 @@
           <a:lstStyle/>
           <a:p>
             <a:pPr algn="l"/>
-            <a:fld id="{71eb00ed-f26f-465a-b125-1720ec23410d}" type="datetime3">
+            <a:fld id="{355fe881-3713-41b5-9e61-22eac1c78df8}" type="datetime3">
               <a:rPr lang="en-GB" sz="1000" dirty="0">
                 <a:solidFill>
                   <a:srgbClr val="C4A35A"/>
@@ -33002,7 +33002,7 @@
           <a:lstStyle/>
           <a:p>
             <a:pPr algn="r"/>
-            <a:fld id="{783abf1c-9725-452d-95f0-fcc11e43f05f}" type="slidenum">
+            <a:fld id="{94abc3fc-b33b-4e92-a246-746dd6ce8055}" type="slidenum">
               <a:rPr lang="en-GB" sz="1000" dirty="0">
                 <a:solidFill>
                   <a:srgbClr val="C4A35A"/>
@@ -33612,7 +33612,7 @@
                 </a:solidFill>
                 <a:latin typeface="Calibri"/>
               </a:rPr>
-              <a:t>ICLR 2024</a:t>
+              <a:t>Proceedings of the Twelfth International Conference on Learning Representations (ICLR 2024)</a:t>
             </a:r>
           </a:p>
           <a:p>
@@ -33916,7 +33916,7 @@
                 </a:solidFill>
                 <a:latin typeface="Calibri"/>
               </a:rPr>
-              <a:t>LREC-COLING 2024, pages 16263–16273. ACL Anthology 2024.lrec-main.1413</a:t>
+              <a:t>Proceedings of the 2024 Joint International Conference on Computational Linguistics, Language Resources and Evaluation (LREC-COLING 2024), pages 16263–16273. ACL Anthology 2024.lrec-main.1413</a:t>
             </a:r>
           </a:p>
           <a:p>
@@ -34054,7 +34054,7 @@
           <a:lstStyle/>
           <a:p>
             <a:pPr algn="l"/>
-            <a:fld id="{0cf3df41-7e57-4ab9-b046-f45e28b54131}" type="datetime3">
+            <a:fld id="{16d6341f-3d26-4718-830f-7d6c198fd3b6}" type="datetime3">
               <a:rPr lang="en-GB" sz="1000" dirty="0">
                 <a:solidFill>
                   <a:srgbClr val="C4A35A"/>
@@ -34088,7 +34088,7 @@
           <a:lstStyle/>
           <a:p>
             <a:pPr algn="r"/>
-            <a:fld id="{8de0a052-db6e-4e7a-9741-268ba6ab249e}" type="slidenum">
+            <a:fld id="{9011e848-7ea6-478c-86c6-852cdf7dedcc}" type="slidenum">
               <a:rPr lang="en-GB" sz="1000" dirty="0">
                 <a:solidFill>
                   <a:srgbClr val="C4A35A"/>

</xml_diff>

<commit_message>
Drop the admissions banner from the ACRS title slide.
Keep the Gnanagangothri campus entrance photograph and Ramaiah logo.
Archived v4–v8 decks are unchanged.
</commit_message>
<xml_diff>
--- a/ACRS_PhD_Proposal_JenishaT_24ETRP720001.pptx
+++ b/ACRS_PhD_Proposal_JenishaT_24ETRP720001.pptx
@@ -3808,30 +3808,6 @@
           </a:p>
         </p:txBody>
       </p:sp>
-      <p:pic>
-        <p:nvPicPr>
-          <p:cNvPr id="15" name="Picture 14" descr="campus-coe-slide.jpg"/>
-          <p:cNvPicPr>
-            <a:picLocks noChangeAspect="1"/>
-          </p:cNvPicPr>
-          <p:nvPr/>
-        </p:nvPicPr>
-        <p:blipFill>
-          <a:blip r:embed="rId4"/>
-          <a:stretch>
-            <a:fillRect/>
-          </a:stretch>
-        </p:blipFill>
-        <p:spPr>
-          <a:xfrm>
-            <a:off x="365760" y="5687568"/>
-            <a:ext cx="11430000" cy="749808"/>
-          </a:xfrm>
-          <a:prstGeom prst="rect">
-            <a:avLst/>
-          </a:prstGeom>
-        </p:spPr>
-      </p:pic>
       <p:sp>
         <p:nvSpPr>
           <p:cNvPr id="4001" name="Automatic Date 1"/>
@@ -3853,7 +3829,7 @@
           <a:lstStyle/>
           <a:p>
             <a:pPr algn="l"/>
-            <a:fld id="{69f3f7cc-cb36-4aee-9eaa-242d594ab6cf}" type="datetime3">
+            <a:fld id="{18db1da8-0893-407e-b629-303c77d36d2d}" type="datetime3">
               <a:rPr lang="en-GB" sz="1000" dirty="0">
                 <a:solidFill>
                   <a:srgbClr val="9AA3AE"/>
@@ -3887,7 +3863,7 @@
           <a:lstStyle/>
           <a:p>
             <a:pPr algn="ctr"/>
-            <a:fld id="{b8fc8b65-38ad-47f0-af92-b142dc1f0de5}" type="slidenum">
+            <a:fld id="{12525ce8-caf5-4c22-bd37-40b6d15d9483}" type="slidenum">
               <a:rPr lang="en-GB" sz="1200" b="1" dirty="0">
                 <a:solidFill>
                   <a:srgbClr val="FFFFFF"/>
@@ -4814,7 +4790,7 @@
           <a:lstStyle/>
           <a:p>
             <a:pPr algn="l"/>
-            <a:fld id="{663338ed-6a11-4679-a76d-934d7acf14fc}" type="datetime3">
+            <a:fld id="{b065faf0-92b4-41a4-8344-9916cf1e3201}" type="datetime3">
               <a:rPr lang="en-GB" sz="1000" dirty="0">
                 <a:solidFill>
                   <a:srgbClr val="9AA3AE"/>
@@ -4848,7 +4824,7 @@
           <a:lstStyle/>
           <a:p>
             <a:pPr algn="ctr"/>
-            <a:fld id="{fa9d1acb-eccd-496d-aacb-97df922365fb}" type="slidenum">
+            <a:fld id="{80cac5db-df01-4d38-b5bc-51019ef67e78}" type="slidenum">
               <a:rPr lang="en-GB" sz="1200" b="1" dirty="0">
                 <a:solidFill>
                   <a:srgbClr val="FFFFFF"/>
@@ -5775,7 +5751,7 @@
           <a:lstStyle/>
           <a:p>
             <a:pPr algn="l"/>
-            <a:fld id="{2ddb174a-8886-4ed5-83af-a89ecc93d78c}" type="datetime3">
+            <a:fld id="{abbc29fb-a276-4f25-a9e8-44af1baa0bf1}" type="datetime3">
               <a:rPr lang="en-GB" sz="1000" dirty="0">
                 <a:solidFill>
                   <a:srgbClr val="9AA3AE"/>
@@ -5809,7 +5785,7 @@
           <a:lstStyle/>
           <a:p>
             <a:pPr algn="ctr"/>
-            <a:fld id="{2c0ab186-74c2-48ee-a991-955d5c3fd7b9}" type="slidenum">
+            <a:fld id="{be1fc8c4-b12d-43c4-9062-a1851ef41dc4}" type="slidenum">
               <a:rPr lang="en-GB" sz="1200" b="1" dirty="0">
                 <a:solidFill>
                   <a:srgbClr val="FFFFFF"/>
@@ -6736,7 +6712,7 @@
           <a:lstStyle/>
           <a:p>
             <a:pPr algn="l"/>
-            <a:fld id="{0f0557d8-bc8d-4ceb-bf47-c2b974ec4a87}" type="datetime3">
+            <a:fld id="{3d76038e-a90a-4c21-bc9c-7bac0b10343c}" type="datetime3">
               <a:rPr lang="en-GB" sz="1000" dirty="0">
                 <a:solidFill>
                   <a:srgbClr val="9AA3AE"/>
@@ -6770,7 +6746,7 @@
           <a:lstStyle/>
           <a:p>
             <a:pPr algn="ctr"/>
-            <a:fld id="{46b22415-f569-41d8-be4e-a7a8f9579ace}" type="slidenum">
+            <a:fld id="{a394284a-bc50-4a7e-beca-78f6bb0ecb83}" type="slidenum">
               <a:rPr lang="en-GB" sz="1200" b="1" dirty="0">
                 <a:solidFill>
                   <a:srgbClr val="FFFFFF"/>
@@ -7697,7 +7673,7 @@
           <a:lstStyle/>
           <a:p>
             <a:pPr algn="l"/>
-            <a:fld id="{45dad787-7060-4aee-b661-877af8bd2961}" type="datetime3">
+            <a:fld id="{283f2263-8b34-4f85-a994-08840dfd6c4b}" type="datetime3">
               <a:rPr lang="en-GB" sz="1000" dirty="0">
                 <a:solidFill>
                   <a:srgbClr val="9AA3AE"/>
@@ -7731,7 +7707,7 @@
           <a:lstStyle/>
           <a:p>
             <a:pPr algn="ctr"/>
-            <a:fld id="{859621d4-b76b-4f2a-9061-4745102ec863}" type="slidenum">
+            <a:fld id="{032ff5a3-b61e-4220-8559-131659f1de93}" type="slidenum">
               <a:rPr lang="en-GB" sz="1200" b="1" dirty="0">
                 <a:solidFill>
                   <a:srgbClr val="FFFFFF"/>
@@ -8553,7 +8529,7 @@
           <a:lstStyle/>
           <a:p>
             <a:pPr algn="l"/>
-            <a:fld id="{285702b5-b9bf-4c27-a7dd-e60a4913ce11}" type="datetime3">
+            <a:fld id="{0176bb95-5e59-4a2b-a594-a040bbb2efea}" type="datetime3">
               <a:rPr lang="en-GB" sz="1000" dirty="0">
                 <a:solidFill>
                   <a:srgbClr val="9AA3AE"/>
@@ -8587,7 +8563,7 @@
           <a:lstStyle/>
           <a:p>
             <a:pPr algn="ctr"/>
-            <a:fld id="{267ecccf-3bb3-49bf-8563-f88d3b00235b}" type="slidenum">
+            <a:fld id="{e89c4a6f-eb0a-4fee-94e2-00d48459a753}" type="slidenum">
               <a:rPr lang="en-GB" sz="1200" b="1" dirty="0">
                 <a:solidFill>
                   <a:srgbClr val="FFFFFF"/>
@@ -9341,7 +9317,7 @@
           <a:lstStyle/>
           <a:p>
             <a:pPr algn="l"/>
-            <a:fld id="{aa32ce77-ed44-4a66-b31e-776164193142}" type="datetime3">
+            <a:fld id="{77fc0926-5000-4272-8cb7-3956fce39bec}" type="datetime3">
               <a:rPr lang="en-GB" sz="1000" dirty="0">
                 <a:solidFill>
                   <a:srgbClr val="9AA3AE"/>
@@ -9375,7 +9351,7 @@
           <a:lstStyle/>
           <a:p>
             <a:pPr algn="ctr"/>
-            <a:fld id="{23d1c1fa-7a16-43f0-ae35-00f57670bb42}" type="slidenum">
+            <a:fld id="{8e090adf-3bda-4b43-b7be-85b18d16c69f}" type="slidenum">
               <a:rPr lang="en-GB" sz="1200" b="1" dirty="0">
                 <a:solidFill>
                   <a:srgbClr val="FFFFFF"/>
@@ -9842,7 +9818,7 @@
           <a:lstStyle/>
           <a:p>
             <a:pPr algn="l"/>
-            <a:fld id="{4d1812ce-7a07-467f-a995-63a4b49f983d}" type="datetime3">
+            <a:fld id="{30004519-f4f2-4fb0-94bc-8143c72aaf64}" type="datetime3">
               <a:rPr lang="en-GB" sz="1000" dirty="0">
                 <a:solidFill>
                   <a:srgbClr val="9AA3AE"/>
@@ -9876,7 +9852,7 @@
           <a:lstStyle/>
           <a:p>
             <a:pPr algn="ctr"/>
-            <a:fld id="{f043d800-f4d2-402b-b8a0-f73f5cccdc64}" type="slidenum">
+            <a:fld id="{178ed62a-689d-473d-b5c8-7b24b91bbed5}" type="slidenum">
               <a:rPr lang="en-GB" sz="1200" b="1" dirty="0">
                 <a:solidFill>
                   <a:srgbClr val="FFFFFF"/>
@@ -10308,7 +10284,7 @@
           <a:lstStyle/>
           <a:p>
             <a:pPr algn="l"/>
-            <a:fld id="{733625af-2220-4803-88ad-755412064500}" type="datetime3">
+            <a:fld id="{54d4075f-f591-4f89-b838-cb839363d5b5}" type="datetime3">
               <a:rPr lang="en-GB" sz="1000" dirty="0">
                 <a:solidFill>
                   <a:srgbClr val="9AA3AE"/>
@@ -10342,7 +10318,7 @@
           <a:lstStyle/>
           <a:p>
             <a:pPr algn="ctr"/>
-            <a:fld id="{12a8cc5f-1e62-471c-98a5-6172e2704195}" type="slidenum">
+            <a:fld id="{51e42d80-cb51-4383-84d4-8fd198bc6fb3}" type="slidenum">
               <a:rPr lang="en-GB" sz="1200" b="1" dirty="0">
                 <a:solidFill>
                   <a:srgbClr val="FFFFFF"/>
@@ -11028,7 +11004,7 @@
           <a:lstStyle/>
           <a:p>
             <a:pPr algn="l"/>
-            <a:fld id="{3799e83d-7c2b-44f0-90c0-5c474fe4126c}" type="datetime3">
+            <a:fld id="{af92c558-fbb5-4adf-93db-8108ac94cd54}" type="datetime3">
               <a:rPr lang="en-GB" sz="1000" dirty="0">
                 <a:solidFill>
                   <a:srgbClr val="9AA3AE"/>
@@ -11062,7 +11038,7 @@
           <a:lstStyle/>
           <a:p>
             <a:pPr algn="ctr"/>
-            <a:fld id="{8f91d0a1-469b-43b0-ba14-3c606f690304}" type="slidenum">
+            <a:fld id="{5cc06e59-f315-448c-936d-a3f1d53b5fdc}" type="slidenum">
               <a:rPr lang="en-GB" sz="1200" b="1" dirty="0">
                 <a:solidFill>
                   <a:srgbClr val="FFFFFF"/>
@@ -11960,7 +11936,7 @@
           <a:lstStyle/>
           <a:p>
             <a:pPr algn="l"/>
-            <a:fld id="{9fef5810-f08e-4e54-a9cc-afa686652d28}" type="datetime3">
+            <a:fld id="{8e4854e5-5fef-4836-9214-63f2ab7a534e}" type="datetime3">
               <a:rPr lang="en-GB" sz="1000" dirty="0">
                 <a:solidFill>
                   <a:srgbClr val="9AA3AE"/>
@@ -11994,7 +11970,7 @@
           <a:lstStyle/>
           <a:p>
             <a:pPr algn="ctr"/>
-            <a:fld id="{c2d3578f-71ad-4b74-aa94-5c4909fab8ab}" type="slidenum">
+            <a:fld id="{8fa83415-597a-410c-b17e-fb582cb1e8f9}" type="slidenum">
               <a:rPr lang="en-GB" sz="1200" b="1" dirty="0">
                 <a:solidFill>
                   <a:srgbClr val="FFFFFF"/>
@@ -12846,7 +12822,7 @@
           <a:lstStyle/>
           <a:p>
             <a:pPr algn="l"/>
-            <a:fld id="{b554c97c-90e7-467b-a8cf-28b62707001c}" type="datetime3">
+            <a:fld id="{3336881b-17f7-4a1b-82e9-413f94f6e4c8}" type="datetime3">
               <a:rPr lang="en-GB" sz="1000" dirty="0">
                 <a:solidFill>
                   <a:srgbClr val="9AA3AE"/>
@@ -12880,7 +12856,7 @@
           <a:lstStyle/>
           <a:p>
             <a:pPr algn="ctr"/>
-            <a:fld id="{b8c55a7c-68bc-4313-b9df-773cceacac9e}" type="slidenum">
+            <a:fld id="{949e44ac-0bdd-43c9-9726-73c2ff22c101}" type="slidenum">
               <a:rPr lang="en-GB" sz="1200" b="1" dirty="0">
                 <a:solidFill>
                   <a:srgbClr val="FFFFFF"/>
@@ -13670,7 +13646,7 @@
           <a:lstStyle/>
           <a:p>
             <a:pPr algn="l"/>
-            <a:fld id="{d3b7681c-8fbf-4296-ac28-93857a304417}" type="datetime3">
+            <a:fld id="{bd275d07-6f45-42fd-98f2-c34a4749ac10}" type="datetime3">
               <a:rPr lang="en-GB" sz="1000" dirty="0">
                 <a:solidFill>
                   <a:srgbClr val="9AA3AE"/>
@@ -13704,7 +13680,7 @@
           <a:lstStyle/>
           <a:p>
             <a:pPr algn="ctr"/>
-            <a:fld id="{16e564e6-a317-43b6-b54d-2f07b8284335}" type="slidenum">
+            <a:fld id="{ea141fdf-28af-448a-891f-76d31d24ab7a}" type="slidenum">
               <a:rPr lang="en-GB" sz="1200" b="1" dirty="0">
                 <a:solidFill>
                   <a:srgbClr val="FFFFFF"/>
@@ -14440,7 +14416,7 @@
           <a:lstStyle/>
           <a:p>
             <a:pPr algn="l"/>
-            <a:fld id="{9df6cce8-aa4f-48da-9a6b-c46cb35b535a}" type="datetime3">
+            <a:fld id="{9310211e-0904-4ed1-89c2-32f530052a4a}" type="datetime3">
               <a:rPr lang="en-GB" sz="1000" dirty="0">
                 <a:solidFill>
                   <a:srgbClr val="9AA3AE"/>
@@ -14474,7 +14450,7 @@
           <a:lstStyle/>
           <a:p>
             <a:pPr algn="ctr"/>
-            <a:fld id="{4d4e1cf0-791f-4e84-91df-b1b8365e9b26}" type="slidenum">
+            <a:fld id="{5612f403-6e9d-4d87-845e-a2cf7236c288}" type="slidenum">
               <a:rPr lang="en-GB" sz="1200" b="1" dirty="0">
                 <a:solidFill>
                   <a:srgbClr val="FFFFFF"/>
@@ -15264,7 +15240,7 @@
           <a:lstStyle/>
           <a:p>
             <a:pPr algn="l"/>
-            <a:fld id="{3effae0a-0036-4e59-8615-d95511fa83f8}" type="datetime3">
+            <a:fld id="{f0bb86df-fb7a-4251-9df1-9a30925cb78b}" type="datetime3">
               <a:rPr lang="en-GB" sz="1000" dirty="0">
                 <a:solidFill>
                   <a:srgbClr val="9AA3AE"/>
@@ -15298,7 +15274,7 @@
           <a:lstStyle/>
           <a:p>
             <a:pPr algn="ctr"/>
-            <a:fld id="{7a0485d0-ac77-4699-af2e-f824fc547bc3}" type="slidenum">
+            <a:fld id="{e7dc9557-bbb3-4ec1-a43b-bc024de48b1b}" type="slidenum">
               <a:rPr lang="en-GB" sz="1200" b="1" dirty="0">
                 <a:solidFill>
                   <a:srgbClr val="FFFFFF"/>
@@ -15712,7 +15688,7 @@
           <a:lstStyle/>
           <a:p>
             <a:pPr algn="l"/>
-            <a:fld id="{a7507d4c-3982-419e-9166-d0a2c1421d50}" type="datetime3">
+            <a:fld id="{e07d2716-8fcd-42f1-98c9-7a42d1a17fc8}" type="datetime3">
               <a:rPr lang="en-GB" sz="1000" dirty="0">
                 <a:solidFill>
                   <a:srgbClr val="9AA3AE"/>
@@ -15746,7 +15722,7 @@
           <a:lstStyle/>
           <a:p>
             <a:pPr algn="ctr"/>
-            <a:fld id="{6efb88b5-1d58-4186-b6db-4874e40eb35f}" type="slidenum">
+            <a:fld id="{3cdc0ba0-d15c-40f0-80af-2a4e90949935}" type="slidenum">
               <a:rPr lang="en-GB" sz="1200" b="1" dirty="0">
                 <a:solidFill>
                   <a:srgbClr val="FFFFFF"/>
@@ -16573,7 +16549,7 @@
           <a:lstStyle/>
           <a:p>
             <a:pPr algn="l"/>
-            <a:fld id="{29983251-8e56-42ef-8a56-eb9a811a7aa0}" type="datetime3">
+            <a:fld id="{a7d7ff34-9e82-4498-8a66-64e512e6ccc5}" type="datetime3">
               <a:rPr lang="en-GB" sz="1000" dirty="0">
                 <a:solidFill>
                   <a:srgbClr val="9AA3AE"/>
@@ -16607,7 +16583,7 @@
           <a:lstStyle/>
           <a:p>
             <a:pPr algn="ctr"/>
-            <a:fld id="{061bd2fd-f3cf-4591-b217-12d296f797a7}" type="slidenum">
+            <a:fld id="{8b6a91b9-f742-4721-b1f9-aeb867ad26fc}" type="slidenum">
               <a:rPr lang="en-GB" sz="1200" b="1" dirty="0">
                 <a:solidFill>
                   <a:srgbClr val="FFFFFF"/>
@@ -17057,7 +17033,7 @@
           <a:lstStyle/>
           <a:p>
             <a:pPr algn="l"/>
-            <a:fld id="{47dddce9-0aab-43c2-9e0e-7449ca213ad2}" type="datetime3">
+            <a:fld id="{69cef7ea-cc5b-4fa0-84c7-85ed226d61cf}" type="datetime3">
               <a:rPr lang="en-GB" sz="1000" dirty="0">
                 <a:solidFill>
                   <a:srgbClr val="9AA3AE"/>
@@ -17091,7 +17067,7 @@
           <a:lstStyle/>
           <a:p>
             <a:pPr algn="ctr"/>
-            <a:fld id="{9ade9d3b-058b-4715-856e-89b5c373fb02}" type="slidenum">
+            <a:fld id="{22355ec6-753f-4f73-8263-28dd73aa71a9}" type="slidenum">
               <a:rPr lang="en-GB" sz="1200" b="1" dirty="0">
                 <a:solidFill>
                   <a:srgbClr val="FFFFFF"/>
@@ -17541,7 +17517,7 @@
           <a:lstStyle/>
           <a:p>
             <a:pPr algn="l"/>
-            <a:fld id="{393ee241-e1d1-46aa-8f77-ef7bfa37976b}" type="datetime3">
+            <a:fld id="{73b68d56-16e5-45d7-95a4-47d27672e99f}" type="datetime3">
               <a:rPr lang="en-GB" sz="1000" dirty="0">
                 <a:solidFill>
                   <a:srgbClr val="9AA3AE"/>
@@ -17575,7 +17551,7 @@
           <a:lstStyle/>
           <a:p>
             <a:pPr algn="ctr"/>
-            <a:fld id="{03f93939-f6c5-4b9c-8e8b-5cff8bdef327}" type="slidenum">
+            <a:fld id="{fa4e2341-7799-4ea3-9d95-8ad1188ef125}" type="slidenum">
               <a:rPr lang="en-GB" sz="1200" b="1" dirty="0">
                 <a:solidFill>
                   <a:srgbClr val="FFFFFF"/>
@@ -18025,7 +18001,7 @@
           <a:lstStyle/>
           <a:p>
             <a:pPr algn="l"/>
-            <a:fld id="{fe9e3b58-af82-4d4c-a641-bd1b5c684ee9}" type="datetime3">
+            <a:fld id="{f7c1fa21-f2f3-4f1e-8b29-f3e4f2d077e5}" type="datetime3">
               <a:rPr lang="en-GB" sz="1000" dirty="0">
                 <a:solidFill>
                   <a:srgbClr val="9AA3AE"/>
@@ -18059,7 +18035,7 @@
           <a:lstStyle/>
           <a:p>
             <a:pPr algn="ctr"/>
-            <a:fld id="{62d5a221-c6bd-48b3-963a-401666b42abb}" type="slidenum">
+            <a:fld id="{51cbd352-2b2e-4c7f-baca-1199d5c47954}" type="slidenum">
               <a:rPr lang="en-GB" sz="1200" b="1" dirty="0">
                 <a:solidFill>
                   <a:srgbClr val="FFFFFF"/>
@@ -18509,7 +18485,7 @@
           <a:lstStyle/>
           <a:p>
             <a:pPr algn="l"/>
-            <a:fld id="{09075067-2636-4291-b44e-ea51cbe7f6e7}" type="datetime3">
+            <a:fld id="{70e73ff5-7c8a-4504-93e0-f57d0f5543e6}" type="datetime3">
               <a:rPr lang="en-GB" sz="1000" dirty="0">
                 <a:solidFill>
                   <a:srgbClr val="9AA3AE"/>
@@ -18543,7 +18519,7 @@
           <a:lstStyle/>
           <a:p>
             <a:pPr algn="ctr"/>
-            <a:fld id="{1bf73c06-e9d9-4baa-bff6-697182cf0637}" type="slidenum">
+            <a:fld id="{e05b7348-07eb-443e-a87f-ca919a68fb73}" type="slidenum">
               <a:rPr lang="en-GB" sz="1200" b="1" dirty="0">
                 <a:solidFill>
                   <a:srgbClr val="FFFFFF"/>
@@ -19387,7 +19363,7 @@
           <a:lstStyle/>
           <a:p>
             <a:pPr algn="l"/>
-            <a:fld id="{45fd43ba-5c79-4b03-8110-5d4736feb910}" type="datetime3">
+            <a:fld id="{9d2c57e7-66d0-41e0-bc7b-02542c0f3c53}" type="datetime3">
               <a:rPr lang="en-GB" sz="1000" dirty="0">
                 <a:solidFill>
                   <a:srgbClr val="9AA3AE"/>
@@ -19421,7 +19397,7 @@
           <a:lstStyle/>
           <a:p>
             <a:pPr algn="ctr"/>
-            <a:fld id="{264a445a-94c0-4877-b6f6-0ed78758f779}" type="slidenum">
+            <a:fld id="{a20c8d6e-0e34-4444-94cc-041bf129f192}" type="slidenum">
               <a:rPr lang="en-GB" sz="1200" b="1" dirty="0">
                 <a:solidFill>
                   <a:srgbClr val="FFFFFF"/>
@@ -20087,7 +20063,7 @@
           <a:lstStyle/>
           <a:p>
             <a:pPr algn="l"/>
-            <a:fld id="{5106e9c3-1941-438b-b6f9-9d009feb545b}" type="datetime3">
+            <a:fld id="{b6882a56-aa72-4027-b367-efe5a8c2c819}" type="datetime3">
               <a:rPr lang="en-GB" sz="1000" dirty="0">
                 <a:solidFill>
                   <a:srgbClr val="9AA3AE"/>
@@ -20121,7 +20097,7 @@
           <a:lstStyle/>
           <a:p>
             <a:pPr algn="ctr"/>
-            <a:fld id="{9c74dfb4-519f-4559-844b-49df064b6e18}" type="slidenum">
+            <a:fld id="{ea783fcc-f880-492c-b57a-e1db3ff52833}" type="slidenum">
               <a:rPr lang="en-GB" sz="1200" b="1" dirty="0">
                 <a:solidFill>
                   <a:srgbClr val="FFFFFF"/>
@@ -20807,7 +20783,7 @@
           <a:lstStyle/>
           <a:p>
             <a:pPr algn="l"/>
-            <a:fld id="{e2834637-d77c-437c-9b1a-bcf0371d935c}" type="datetime3">
+            <a:fld id="{63b247c1-e106-4154-91e9-534da8f70826}" type="datetime3">
               <a:rPr lang="en-GB" sz="1000" dirty="0">
                 <a:solidFill>
                   <a:srgbClr val="9AA3AE"/>
@@ -20841,7 +20817,7 @@
           <a:lstStyle/>
           <a:p>
             <a:pPr algn="ctr"/>
-            <a:fld id="{c256066c-df74-43de-b765-2625706ac7e3}" type="slidenum">
+            <a:fld id="{f3ee6ba5-2640-452c-ac14-ba5052f054e1}" type="slidenum">
               <a:rPr lang="en-GB" sz="1200" b="1" dirty="0">
                 <a:solidFill>
                   <a:srgbClr val="FFFFFF"/>
@@ -21308,7 +21284,7 @@
           <a:lstStyle/>
           <a:p>
             <a:pPr algn="l"/>
-            <a:fld id="{42b3b448-f15e-4150-9db4-92cfe18eeaaa}" type="datetime3">
+            <a:fld id="{bf355f82-082c-42ef-8954-a55148055c72}" type="datetime3">
               <a:rPr lang="en-GB" sz="1000" dirty="0">
                 <a:solidFill>
                   <a:srgbClr val="9AA3AE"/>
@@ -21342,7 +21318,7 @@
           <a:lstStyle/>
           <a:p>
             <a:pPr algn="ctr"/>
-            <a:fld id="{0b17883e-05c1-42ff-8d4c-0f798a3a06a3}" type="slidenum">
+            <a:fld id="{923e6aee-6487-482f-90b3-5e9b393fb784}" type="slidenum">
               <a:rPr lang="en-GB" sz="1200" b="1" dirty="0">
                 <a:solidFill>
                   <a:srgbClr val="FFFFFF"/>
@@ -21809,7 +21785,7 @@
           <a:lstStyle/>
           <a:p>
             <a:pPr algn="l"/>
-            <a:fld id="{276dfddd-7995-46cd-a318-d3be223799ee}" type="datetime3">
+            <a:fld id="{640c10e6-32a0-4eee-b760-9285771022e4}" type="datetime3">
               <a:rPr lang="en-GB" sz="1000" dirty="0">
                 <a:solidFill>
                   <a:srgbClr val="9AA3AE"/>
@@ -21843,7 +21819,7 @@
           <a:lstStyle/>
           <a:p>
             <a:pPr algn="ctr"/>
-            <a:fld id="{30d760e2-3495-46fb-8e7c-4f668ab2f734}" type="slidenum">
+            <a:fld id="{9c5e36ea-8b07-4d1d-b009-4be245004f48}" type="slidenum">
               <a:rPr lang="en-GB" sz="1200" b="1" dirty="0">
                 <a:solidFill>
                   <a:srgbClr val="FFFFFF"/>
@@ -22275,7 +22251,7 @@
           <a:lstStyle/>
           <a:p>
             <a:pPr algn="l"/>
-            <a:fld id="{fe9a0abe-eb87-4f4f-8114-3e00254ba710}" type="datetime3">
+            <a:fld id="{daca3a06-aeb0-4133-91c5-7fab39006ab2}" type="datetime3">
               <a:rPr lang="en-GB" sz="1000" dirty="0">
                 <a:solidFill>
                   <a:srgbClr val="9AA3AE"/>
@@ -22309,7 +22285,7 @@
           <a:lstStyle/>
           <a:p>
             <a:pPr algn="ctr"/>
-            <a:fld id="{e0b7849a-47cf-4ace-8f47-a3b201b48ed0}" type="slidenum">
+            <a:fld id="{26f69c7f-16b7-4288-adf2-1f1740ce7f74}" type="slidenum">
               <a:rPr lang="en-GB" sz="1200" b="1" dirty="0">
                 <a:solidFill>
                   <a:srgbClr val="FFFFFF"/>
@@ -22760,7 +22736,7 @@
           <a:lstStyle/>
           <a:p>
             <a:pPr algn="l"/>
-            <a:fld id="{93425bff-f793-4d2d-8f65-77840508fc9b}" type="datetime3">
+            <a:fld id="{0451e302-021c-4791-b629-d22c02222cc0}" type="datetime3">
               <a:rPr lang="en-GB" sz="1000" dirty="0">
                 <a:solidFill>
                   <a:srgbClr val="9AA3AE"/>
@@ -22794,7 +22770,7 @@
           <a:lstStyle/>
           <a:p>
             <a:pPr algn="ctr"/>
-            <a:fld id="{f74ae963-5949-4d83-823a-826dda7ae873}" type="slidenum">
+            <a:fld id="{f64e56ae-ee65-4471-9164-b7f657a072ac}" type="slidenum">
               <a:rPr lang="en-GB" sz="1200" b="1" dirty="0">
                 <a:solidFill>
                   <a:srgbClr val="FFFFFF"/>
@@ -23245,7 +23221,7 @@
           <a:lstStyle/>
           <a:p>
             <a:pPr algn="l"/>
-            <a:fld id="{060e6c76-0455-4f08-ad86-b1c6afed2cc0}" type="datetime3">
+            <a:fld id="{3f33373d-dcdb-4324-8d51-964b9c9eadde}" type="datetime3">
               <a:rPr lang="en-GB" sz="1000" dirty="0">
                 <a:solidFill>
                   <a:srgbClr val="9AA3AE"/>
@@ -23279,7 +23255,7 @@
           <a:lstStyle/>
           <a:p>
             <a:pPr algn="ctr"/>
-            <a:fld id="{2e08aaba-7cef-4edc-9520-4bed8a082cbc}" type="slidenum">
+            <a:fld id="{e15da2e2-de15-4744-8d43-8fefa38b6b20}" type="slidenum">
               <a:rPr lang="en-GB" sz="1200" b="1" dirty="0">
                 <a:solidFill>
                   <a:srgbClr val="FFFFFF"/>
@@ -23765,7 +23741,7 @@
           <a:lstStyle/>
           <a:p>
             <a:pPr algn="l"/>
-            <a:fld id="{c6790d0c-a859-423d-b94c-0ce4a9e6c6ee}" type="datetime3">
+            <a:fld id="{626b8fdb-92fe-4e8b-a577-1d5b72301a6f}" type="datetime3">
               <a:rPr lang="en-GB" sz="1000" dirty="0">
                 <a:solidFill>
                   <a:srgbClr val="9AA3AE"/>
@@ -23799,7 +23775,7 @@
           <a:lstStyle/>
           <a:p>
             <a:pPr algn="ctr"/>
-            <a:fld id="{4c4e50a0-e92b-4573-8cb0-6df23bb92767}" type="slidenum">
+            <a:fld id="{5ed2ef63-10f2-4b4a-985b-eece7d3a22fd}" type="slidenum">
               <a:rPr lang="en-GB" sz="1200" b="1" dirty="0">
                 <a:solidFill>
                   <a:srgbClr val="FFFFFF"/>
@@ -24249,7 +24225,7 @@
           <a:lstStyle/>
           <a:p>
             <a:pPr algn="l"/>
-            <a:fld id="{a6f4441e-5d8f-4eb0-a2aa-40805dfadac6}" type="datetime3">
+            <a:fld id="{a9cd5c77-cdaf-4f0f-9123-d3dd4efccbda}" type="datetime3">
               <a:rPr lang="en-GB" sz="1000" dirty="0">
                 <a:solidFill>
                   <a:srgbClr val="9AA3AE"/>
@@ -24283,7 +24259,7 @@
           <a:lstStyle/>
           <a:p>
             <a:pPr algn="ctr"/>
-            <a:fld id="{a8714cc0-1683-48dc-ac4c-98562661eb64}" type="slidenum">
+            <a:fld id="{70f103f2-176f-4069-aa5c-db6a88ab8c23}" type="slidenum">
               <a:rPr lang="en-GB" sz="1200" b="1" dirty="0">
                 <a:solidFill>
                   <a:srgbClr val="FFFFFF"/>
@@ -24715,7 +24691,7 @@
           <a:lstStyle/>
           <a:p>
             <a:pPr algn="l"/>
-            <a:fld id="{4f7771e5-047f-4cdf-8580-03d0d59ca521}" type="datetime3">
+            <a:fld id="{6ad3158c-e62b-4e23-b41d-570e23eae695}" type="datetime3">
               <a:rPr lang="en-GB" sz="1000" dirty="0">
                 <a:solidFill>
                   <a:srgbClr val="9AA3AE"/>
@@ -24749,7 +24725,7 @@
           <a:lstStyle/>
           <a:p>
             <a:pPr algn="ctr"/>
-            <a:fld id="{1eab6623-36b6-45db-b6fe-b4336e2fbb41}" type="slidenum">
+            <a:fld id="{bf79af1d-d7ff-4a8c-be61-ab7760eb2ffe}" type="slidenum">
               <a:rPr lang="en-GB" sz="1200" b="1" dirty="0">
                 <a:solidFill>
                   <a:srgbClr val="FFFFFF"/>
@@ -25676,7 +25652,7 @@
           <a:lstStyle/>
           <a:p>
             <a:pPr algn="l"/>
-            <a:fld id="{f85e607b-d029-4b2b-a730-7b32fc924f60}" type="datetime3">
+            <a:fld id="{b494ecb4-dd22-43fb-ade2-43f47082c721}" type="datetime3">
               <a:rPr lang="en-GB" sz="1000" dirty="0">
                 <a:solidFill>
                   <a:srgbClr val="9AA3AE"/>
@@ -25710,7 +25686,7 @@
           <a:lstStyle/>
           <a:p>
             <a:pPr algn="ctr"/>
-            <a:fld id="{c0e73d1b-a0e8-4887-97ab-f331fb6f6dde}" type="slidenum">
+            <a:fld id="{753ca4d6-1acc-45d2-a62b-922ad4baafbe}" type="slidenum">
               <a:rPr lang="en-GB" sz="1200" b="1" dirty="0">
                 <a:solidFill>
                   <a:srgbClr val="FFFFFF"/>
@@ -26637,7 +26613,7 @@
           <a:lstStyle/>
           <a:p>
             <a:pPr algn="l"/>
-            <a:fld id="{3e82595f-684d-4601-b4a1-45ea4f0dd324}" type="datetime3">
+            <a:fld id="{f33a0f06-7bbc-422c-bb05-e8161c5728cb}" type="datetime3">
               <a:rPr lang="en-GB" sz="1000" dirty="0">
                 <a:solidFill>
                   <a:srgbClr val="9AA3AE"/>
@@ -26671,7 +26647,7 @@
           <a:lstStyle/>
           <a:p>
             <a:pPr algn="ctr"/>
-            <a:fld id="{1b4dd74f-2a9a-465c-91a5-fc436b9b9721}" type="slidenum">
+            <a:fld id="{7647f45f-5186-4ae6-b68a-c0544bfb23d7}" type="slidenum">
               <a:rPr lang="en-GB" sz="1200" b="1" dirty="0">
                 <a:solidFill>
                   <a:srgbClr val="FFFFFF"/>
@@ -27598,7 +27574,7 @@
           <a:lstStyle/>
           <a:p>
             <a:pPr algn="l"/>
-            <a:fld id="{40c28361-d833-409c-912a-f32f14f33ae9}" type="datetime3">
+            <a:fld id="{10a3d7ee-749a-4aef-94a0-d5d1c79aec9d}" type="datetime3">
               <a:rPr lang="en-GB" sz="1000" dirty="0">
                 <a:solidFill>
                   <a:srgbClr val="9AA3AE"/>
@@ -27632,7 +27608,7 @@
           <a:lstStyle/>
           <a:p>
             <a:pPr algn="ctr"/>
-            <a:fld id="{a68a9411-e424-4cd1-92c4-bd0294847e2d}" type="slidenum">
+            <a:fld id="{9d1fa946-2e7d-46cc-b195-304f624d43f3}" type="slidenum">
               <a:rPr lang="en-GB" sz="1200" b="1" dirty="0">
                 <a:solidFill>
                   <a:srgbClr val="FFFFFF"/>
@@ -28559,7 +28535,7 @@
           <a:lstStyle/>
           <a:p>
             <a:pPr algn="l"/>
-            <a:fld id="{fe2a0019-5d6a-4f96-be09-a844643021dc}" type="datetime3">
+            <a:fld id="{3060debf-74ce-407b-8df5-1c242b9274df}" type="datetime3">
               <a:rPr lang="en-GB" sz="1000" dirty="0">
                 <a:solidFill>
                   <a:srgbClr val="9AA3AE"/>
@@ -28593,7 +28569,7 @@
           <a:lstStyle/>
           <a:p>
             <a:pPr algn="ctr"/>
-            <a:fld id="{a624d4ac-28b5-4d4f-a66d-2fc4090325fa}" type="slidenum">
+            <a:fld id="{0ffa432b-7044-44bb-bef4-079843f94918}" type="slidenum">
               <a:rPr lang="en-GB" sz="1200" b="1" dirty="0">
                 <a:solidFill>
                   <a:srgbClr val="FFFFFF"/>
@@ -29520,7 +29496,7 @@
           <a:lstStyle/>
           <a:p>
             <a:pPr algn="l"/>
-            <a:fld id="{5f3c7b34-8dc4-40e6-b14c-25f8a702fa0c}" type="datetime3">
+            <a:fld id="{337f72e7-2ad9-459b-9725-ce1b2c0eaea9}" type="datetime3">
               <a:rPr lang="en-GB" sz="1000" dirty="0">
                 <a:solidFill>
                   <a:srgbClr val="9AA3AE"/>
@@ -29554,7 +29530,7 @@
           <a:lstStyle/>
           <a:p>
             <a:pPr algn="ctr"/>
-            <a:fld id="{677b8924-bedb-4679-bd7a-58fc7bd55425}" type="slidenum">
+            <a:fld id="{fb0cc5e5-1d98-444f-b78d-9dfe45d9b303}" type="slidenum">
               <a:rPr lang="en-GB" sz="1200" b="1" dirty="0">
                 <a:solidFill>
                   <a:srgbClr val="FFFFFF"/>

</xml_diff>

<commit_message>
Show only the ten main FET sections on Contents of Slides.
Sub-section slides stay in the deck; they are no longer TOC entries.
</commit_message>
<xml_diff>
--- a/ACRS_PhD_Proposal_JenishaT_24ETRP720001.pptx
+++ b/ACRS_PhD_Proposal_JenishaT_24ETRP720001.pptx
@@ -3835,7 +3835,7 @@
           <a:lstStyle/>
           <a:p>
             <a:pPr algn="l"/>
-            <a:fld id="{e7773d2e-318f-4457-8677-d577c4ddb4b1}" type="datetime3">
+            <a:fld id="{79bc40c5-0f19-449d-bbc3-50e058a4d530}" type="datetime3">
               <a:rPr lang="en-GB" sz="1000" dirty="0">
                 <a:solidFill>
                   <a:srgbClr val="9AA3AE"/>
@@ -3869,7 +3869,7 @@
           <a:lstStyle/>
           <a:p>
             <a:pPr algn="ctr"/>
-            <a:fld id="{d8b95837-488b-4c1b-b66f-5ac67e282be8}" type="slidenum">
+            <a:fld id="{6b7ce373-bd35-4a2d-8481-a46c88d74846}" type="slidenum">
               <a:rPr lang="en-GB" sz="1200" b="1" dirty="0">
                 <a:solidFill>
                   <a:srgbClr val="FFFFFF"/>
@@ -4796,7 +4796,7 @@
           <a:lstStyle/>
           <a:p>
             <a:pPr algn="l"/>
-            <a:fld id="{282af29f-e115-428e-8f3b-02a34fb98211}" type="datetime3">
+            <a:fld id="{5d61c29b-9830-4696-b7f2-55af113138e5}" type="datetime3">
               <a:rPr lang="en-GB" sz="1000" dirty="0">
                 <a:solidFill>
                   <a:srgbClr val="9AA3AE"/>
@@ -4830,7 +4830,7 @@
           <a:lstStyle/>
           <a:p>
             <a:pPr algn="ctr"/>
-            <a:fld id="{d7c2cf6a-10c6-431e-bf8c-96d6a61296aa}" type="slidenum">
+            <a:fld id="{a239dbfe-d22a-4c1f-a938-ce1573dc5f73}" type="slidenum">
               <a:rPr lang="en-GB" sz="1200" b="1" dirty="0">
                 <a:solidFill>
                   <a:srgbClr val="FFFFFF"/>
@@ -5757,7 +5757,7 @@
           <a:lstStyle/>
           <a:p>
             <a:pPr algn="l"/>
-            <a:fld id="{2eb26855-ebfa-40fe-bc91-a41c011c6b74}" type="datetime3">
+            <a:fld id="{4e82ab66-753e-41e3-bff6-968c41d4ab38}" type="datetime3">
               <a:rPr lang="en-GB" sz="1000" dirty="0">
                 <a:solidFill>
                   <a:srgbClr val="9AA3AE"/>
@@ -5791,7 +5791,7 @@
           <a:lstStyle/>
           <a:p>
             <a:pPr algn="ctr"/>
-            <a:fld id="{6711f79b-8f43-4629-9772-330f1fcc3185}" type="slidenum">
+            <a:fld id="{403f6587-f939-45f1-9c68-d81dc51c06fa}" type="slidenum">
               <a:rPr lang="en-GB" sz="1200" b="1" dirty="0">
                 <a:solidFill>
                   <a:srgbClr val="FFFFFF"/>
@@ -6718,7 +6718,7 @@
           <a:lstStyle/>
           <a:p>
             <a:pPr algn="l"/>
-            <a:fld id="{570e095b-cb1a-4ec5-9224-8ebb59ed97ec}" type="datetime3">
+            <a:fld id="{4685405d-e35e-47bf-afcd-b8d9e805f68d}" type="datetime3">
               <a:rPr lang="en-GB" sz="1000" dirty="0">
                 <a:solidFill>
                   <a:srgbClr val="9AA3AE"/>
@@ -6752,7 +6752,7 @@
           <a:lstStyle/>
           <a:p>
             <a:pPr algn="ctr"/>
-            <a:fld id="{cce1baab-1aa3-4ff0-8c70-6a5e86bb229a}" type="slidenum">
+            <a:fld id="{7cb31cd2-e21f-43c7-a9c6-e393b35c427f}" type="slidenum">
               <a:rPr lang="en-GB" sz="1200" b="1" dirty="0">
                 <a:solidFill>
                   <a:srgbClr val="FFFFFF"/>
@@ -7679,7 +7679,7 @@
           <a:lstStyle/>
           <a:p>
             <a:pPr algn="l"/>
-            <a:fld id="{eadb0972-6343-4ed7-ac0d-c8fd23e1d313}" type="datetime3">
+            <a:fld id="{3f602372-ae1c-470e-902b-fa58489d3680}" type="datetime3">
               <a:rPr lang="en-GB" sz="1000" dirty="0">
                 <a:solidFill>
                   <a:srgbClr val="9AA3AE"/>
@@ -7713,7 +7713,7 @@
           <a:lstStyle/>
           <a:p>
             <a:pPr algn="ctr"/>
-            <a:fld id="{2d362543-2763-41a6-82da-db8858659055}" type="slidenum">
+            <a:fld id="{7ec21884-11b9-4c5d-ba19-b0a03c53c444}" type="slidenum">
               <a:rPr lang="en-GB" sz="1200" b="1" dirty="0">
                 <a:solidFill>
                   <a:srgbClr val="FFFFFF"/>
@@ -8640,7 +8640,7 @@
           <a:lstStyle/>
           <a:p>
             <a:pPr algn="l"/>
-            <a:fld id="{9ca2661e-e464-405a-a567-4fe2cd93d3dc}" type="datetime3">
+            <a:fld id="{f46035cb-1ce0-4cbc-be49-3df87982d6f9}" type="datetime3">
               <a:rPr lang="en-GB" sz="1000" dirty="0">
                 <a:solidFill>
                   <a:srgbClr val="9AA3AE"/>
@@ -8674,7 +8674,7 @@
           <a:lstStyle/>
           <a:p>
             <a:pPr algn="ctr"/>
-            <a:fld id="{9ed95ebc-c19f-429a-adb5-b44a26af0bc1}" type="slidenum">
+            <a:fld id="{ecb0d392-1e74-4f6a-a784-e106f292d46f}" type="slidenum">
               <a:rPr lang="en-GB" sz="1200" b="1" dirty="0">
                 <a:solidFill>
                   <a:srgbClr val="FFFFFF"/>
@@ -9496,7 +9496,7 @@
           <a:lstStyle/>
           <a:p>
             <a:pPr algn="l"/>
-            <a:fld id="{2ef79ee2-89e6-4834-80fe-b4929cfd857b}" type="datetime3">
+            <a:fld id="{5cc98f82-ce20-43ba-a532-78aea2d81f7b}" type="datetime3">
               <a:rPr lang="en-GB" sz="1000" dirty="0">
                 <a:solidFill>
                   <a:srgbClr val="9AA3AE"/>
@@ -9530,7 +9530,7 @@
           <a:lstStyle/>
           <a:p>
             <a:pPr algn="ctr"/>
-            <a:fld id="{4655f8d8-3178-49e7-809b-bb2932da9ebe}" type="slidenum">
+            <a:fld id="{9638127b-1133-4198-92f0-9f93a64d5561}" type="slidenum">
               <a:rPr lang="en-GB" sz="1200" b="1" dirty="0">
                 <a:solidFill>
                   <a:srgbClr val="FFFFFF"/>
@@ -10284,7 +10284,7 @@
           <a:lstStyle/>
           <a:p>
             <a:pPr algn="l"/>
-            <a:fld id="{674cfa13-4126-4db1-8ad6-7cf1af4086c8}" type="datetime3">
+            <a:fld id="{19e6085b-48e5-49e5-95c5-3401909deebf}" type="datetime3">
               <a:rPr lang="en-GB" sz="1000" dirty="0">
                 <a:solidFill>
                   <a:srgbClr val="9AA3AE"/>
@@ -10318,7 +10318,7 @@
           <a:lstStyle/>
           <a:p>
             <a:pPr algn="ctr"/>
-            <a:fld id="{4a026e9a-6a78-4ac7-abb6-57d53bd2c711}" type="slidenum">
+            <a:fld id="{0d00fb5a-fd5d-43c4-8b88-6e85cc9d1175}" type="slidenum">
               <a:rPr lang="en-GB" sz="1200" b="1" dirty="0">
                 <a:solidFill>
                   <a:srgbClr val="FFFFFF"/>
@@ -11018,7 +11018,7 @@
           <a:lstStyle/>
           <a:p>
             <a:pPr algn="l"/>
-            <a:fld id="{453cd54f-8bb2-42ab-a03e-3e88b0358b59}" type="datetime3">
+            <a:fld id="{cd1f5dea-ced5-48b3-b240-d3d7ae7a38df}" type="datetime3">
               <a:rPr lang="en-GB" sz="1000" dirty="0">
                 <a:solidFill>
                   <a:srgbClr val="9AA3AE"/>
@@ -11052,7 +11052,7 @@
           <a:lstStyle/>
           <a:p>
             <a:pPr algn="ctr"/>
-            <a:fld id="{146a97fa-6c3c-447a-9c71-e28fc22a6ce1}" type="slidenum">
+            <a:fld id="{a62a0ee5-96f8-41b5-a0ab-5b15dd7fde06}" type="slidenum">
               <a:rPr lang="en-GB" sz="1200" b="1" dirty="0">
                 <a:solidFill>
                   <a:srgbClr val="FFFFFF"/>
@@ -11860,7 +11860,7 @@
           <a:lstStyle/>
           <a:p>
             <a:pPr algn="l"/>
-            <a:fld id="{bbff781b-4ce8-4451-aad1-61327014aff0}" type="datetime3">
+            <a:fld id="{839a08de-57a2-4e4f-8e03-c239c89d69f9}" type="datetime3">
               <a:rPr lang="en-GB" sz="1000" dirty="0">
                 <a:solidFill>
                   <a:srgbClr val="9AA3AE"/>
@@ -11894,7 +11894,7 @@
           <a:lstStyle/>
           <a:p>
             <a:pPr algn="ctr"/>
-            <a:fld id="{83f851ac-1c7b-4b4e-9400-172de6e93db7}" type="slidenum">
+            <a:fld id="{45c5cbb9-4351-41f9-a116-50f7bf46e5fd}" type="slidenum">
               <a:rPr lang="en-GB" sz="1200" b="1" dirty="0">
                 <a:solidFill>
                   <a:srgbClr val="FFFFFF"/>
@@ -12361,7 +12361,7 @@
           <a:lstStyle/>
           <a:p>
             <a:pPr algn="l"/>
-            <a:fld id="{6b120672-5081-488c-8ba0-e958b846078c}" type="datetime3">
+            <a:fld id="{063b7edd-66ed-4887-8183-e2d2e7d909db}" type="datetime3">
               <a:rPr lang="en-GB" sz="1000" dirty="0">
                 <a:solidFill>
                   <a:srgbClr val="9AA3AE"/>
@@ -12395,7 +12395,7 @@
           <a:lstStyle/>
           <a:p>
             <a:pPr algn="ctr"/>
-            <a:fld id="{d1a9b669-91c7-474e-bb3e-def6207776ab}" type="slidenum">
+            <a:fld id="{dca317f8-e0b0-4f95-be4b-7ee47a33072a}" type="slidenum">
               <a:rPr lang="en-GB" sz="1200" b="1" dirty="0">
                 <a:solidFill>
                   <a:srgbClr val="FFFFFF"/>
@@ -13247,7 +13247,7 @@
           <a:lstStyle/>
           <a:p>
             <a:pPr algn="l"/>
-            <a:fld id="{b9506bea-f4dc-410f-839e-514c43a12fb8}" type="datetime3">
+            <a:fld id="{b2c918a2-3c26-4fa6-b05b-f8025c3d1b96}" type="datetime3">
               <a:rPr lang="en-GB" sz="1000" dirty="0">
                 <a:solidFill>
                   <a:srgbClr val="9AA3AE"/>
@@ -13281,7 +13281,7 @@
           <a:lstStyle/>
           <a:p>
             <a:pPr algn="ctr"/>
-            <a:fld id="{966ec7b8-53d3-4523-a6bc-fb02b166a3b1}" type="slidenum">
+            <a:fld id="{67feafdc-8afe-468e-bf04-8c4c9bcbc2a1}" type="slidenum">
               <a:rPr lang="en-GB" sz="1200" b="1" dirty="0">
                 <a:solidFill>
                   <a:srgbClr val="FFFFFF"/>
@@ -13713,7 +13713,7 @@
           <a:lstStyle/>
           <a:p>
             <a:pPr algn="l"/>
-            <a:fld id="{59583018-e9f7-4020-b354-acc9e3a84363}" type="datetime3">
+            <a:fld id="{9c26b402-3eaf-4551-8bd3-130ac0adbb17}" type="datetime3">
               <a:rPr lang="en-GB" sz="1000" dirty="0">
                 <a:solidFill>
                   <a:srgbClr val="9AA3AE"/>
@@ -13747,7 +13747,7 @@
           <a:lstStyle/>
           <a:p>
             <a:pPr algn="ctr"/>
-            <a:fld id="{50684804-63fa-40e3-afcd-6d54d281070d}" type="slidenum">
+            <a:fld id="{03e010f6-919f-458d-8d76-532d43b23070}" type="slidenum">
               <a:rPr lang="en-GB" sz="1200" b="1" dirty="0">
                 <a:solidFill>
                   <a:srgbClr val="FFFFFF"/>
@@ -14196,7 +14196,7 @@
           <a:lstStyle/>
           <a:p>
             <a:pPr algn="l"/>
-            <a:fld id="{a68ec423-29c9-42b3-9559-ebbbfe776c99}" type="datetime3">
+            <a:fld id="{7485621a-bc46-4f9e-a50b-684f8da1a82c}" type="datetime3">
               <a:rPr lang="en-GB" sz="1000" dirty="0">
                 <a:solidFill>
                   <a:srgbClr val="9AA3AE"/>
@@ -14230,7 +14230,7 @@
           <a:lstStyle/>
           <a:p>
             <a:pPr algn="ctr"/>
-            <a:fld id="{4f3ab8e3-557f-415f-881f-e47527c319a5}" type="slidenum">
+            <a:fld id="{5797ff8d-9003-4c9c-a48b-43c032073e86}" type="slidenum">
               <a:rPr lang="en-GB" sz="1200" b="1" dirty="0">
                 <a:solidFill>
                   <a:srgbClr val="FFFFFF"/>
@@ -14916,7 +14916,7 @@
           <a:lstStyle/>
           <a:p>
             <a:pPr algn="l"/>
-            <a:fld id="{e448ea58-2cf6-49c8-881a-54cbeb8066a8}" type="datetime3">
+            <a:fld id="{1a1f67f3-5396-4dad-b135-654733e278ed}" type="datetime3">
               <a:rPr lang="en-GB" sz="1000" dirty="0">
                 <a:solidFill>
                   <a:srgbClr val="9AA3AE"/>
@@ -14950,7 +14950,7 @@
           <a:lstStyle/>
           <a:p>
             <a:pPr algn="ctr"/>
-            <a:fld id="{e1293123-d30f-4d30-bf70-a82c8f64e013}" type="slidenum">
+            <a:fld id="{ab615862-4615-46fe-921f-f34b14840e8d}" type="slidenum">
               <a:rPr lang="en-GB" sz="1200" b="1" dirty="0">
                 <a:solidFill>
                   <a:srgbClr val="FFFFFF"/>
@@ -15848,7 +15848,7 @@
           <a:lstStyle/>
           <a:p>
             <a:pPr algn="l"/>
-            <a:fld id="{ca3b18e8-467e-47a9-b6e3-7a38099fb5a4}" type="datetime3">
+            <a:fld id="{51d99c80-f9d8-4146-bb03-48b1a4ce8f82}" type="datetime3">
               <a:rPr lang="en-GB" sz="1000" dirty="0">
                 <a:solidFill>
                   <a:srgbClr val="9AA3AE"/>
@@ -15882,7 +15882,7 @@
           <a:lstStyle/>
           <a:p>
             <a:pPr algn="ctr"/>
-            <a:fld id="{7ebfaa28-1194-452e-98dd-4f646d66af4d}" type="slidenum">
+            <a:fld id="{3f85f916-1749-49d5-81cb-d89044e6c756}" type="slidenum">
               <a:rPr lang="en-GB" sz="1200" b="1" dirty="0">
                 <a:solidFill>
                   <a:srgbClr val="FFFFFF"/>
@@ -16672,7 +16672,7 @@
           <a:lstStyle/>
           <a:p>
             <a:pPr algn="l"/>
-            <a:fld id="{85f407ee-6d08-408c-914c-ffe5d40c42ae}" type="datetime3">
+            <a:fld id="{9c41a283-6aa9-4f59-8a79-696a3d674058}" type="datetime3">
               <a:rPr lang="en-GB" sz="1000" dirty="0">
                 <a:solidFill>
                   <a:srgbClr val="9AA3AE"/>
@@ -16706,7 +16706,7 @@
           <a:lstStyle/>
           <a:p>
             <a:pPr algn="ctr"/>
-            <a:fld id="{41c55e36-4f12-4b1d-a006-10ecd7956920}" type="slidenum">
+            <a:fld id="{b9ece9b5-87d0-48e9-b193-0719d6f83b78}" type="slidenum">
               <a:rPr lang="en-GB" sz="1200" b="1" dirty="0">
                 <a:solidFill>
                   <a:srgbClr val="FFFFFF"/>
@@ -17442,7 +17442,7 @@
           <a:lstStyle/>
           <a:p>
             <a:pPr algn="l"/>
-            <a:fld id="{09b4f6a6-35f1-4747-b4c3-4d60608aed75}" type="datetime3">
+            <a:fld id="{8b089f03-993f-45b4-aff3-05a1331f2598}" type="datetime3">
               <a:rPr lang="en-GB" sz="1000" dirty="0">
                 <a:solidFill>
                   <a:srgbClr val="9AA3AE"/>
@@ -17476,7 +17476,7 @@
           <a:lstStyle/>
           <a:p>
             <a:pPr algn="ctr"/>
-            <a:fld id="{f58664e2-49f6-4fde-9c13-7394dfbbd197}" type="slidenum">
+            <a:fld id="{3fac42c5-9437-4b88-9a3d-cc74bf6ebd9f}" type="slidenum">
               <a:rPr lang="en-GB" sz="1200" b="1" dirty="0">
                 <a:solidFill>
                   <a:srgbClr val="FFFFFF"/>
@@ -18266,7 +18266,7 @@
           <a:lstStyle/>
           <a:p>
             <a:pPr algn="l"/>
-            <a:fld id="{c4e20540-66ec-46c5-afe0-0ff7ddf8ec84}" type="datetime3">
+            <a:fld id="{1b64cfe2-8505-4818-948b-50850dc318f5}" type="datetime3">
               <a:rPr lang="en-GB" sz="1000" dirty="0">
                 <a:solidFill>
                   <a:srgbClr val="9AA3AE"/>
@@ -18300,7 +18300,7 @@
           <a:lstStyle/>
           <a:p>
             <a:pPr algn="ctr"/>
-            <a:fld id="{f399c300-8ea0-42d6-a2ca-45a915dbf074}" type="slidenum">
+            <a:fld id="{9b0cbcdf-35d3-4f4a-b2b7-f08869c66faa}" type="slidenum">
               <a:rPr lang="en-GB" sz="1200" b="1" dirty="0">
                 <a:solidFill>
                   <a:srgbClr val="FFFFFF"/>
@@ -18731,7 +18731,7 @@
           <a:lstStyle/>
           <a:p>
             <a:pPr algn="l"/>
-            <a:fld id="{7b82b865-111c-4a06-b9b8-6a66ebfd93d0}" type="datetime3">
+            <a:fld id="{3afb6d49-9ce3-40f2-89f9-ac188f238c43}" type="datetime3">
               <a:rPr lang="en-GB" sz="1000" dirty="0">
                 <a:solidFill>
                   <a:srgbClr val="9AA3AE"/>
@@ -18765,7 +18765,7 @@
           <a:lstStyle/>
           <a:p>
             <a:pPr algn="ctr"/>
-            <a:fld id="{4367e38f-3d2b-44fe-ae21-2c18f5a0c7a9}" type="slidenum">
+            <a:fld id="{34f27d28-ab41-47a9-b327-015fdf112844}" type="slidenum">
               <a:rPr lang="en-GB" sz="1200" b="1" dirty="0">
                 <a:solidFill>
                   <a:srgbClr val="FFFFFF"/>
@@ -19179,7 +19179,7 @@
           <a:lstStyle/>
           <a:p>
             <a:pPr algn="l"/>
-            <a:fld id="{a4801d7c-7ff0-4297-9f11-7c9881940240}" type="datetime3">
+            <a:fld id="{50e05be2-8efb-42d9-a256-8c00ad199e14}" type="datetime3">
               <a:rPr lang="en-GB" sz="1000" dirty="0">
                 <a:solidFill>
                   <a:srgbClr val="9AA3AE"/>
@@ -19213,7 +19213,7 @@
           <a:lstStyle/>
           <a:p>
             <a:pPr algn="ctr"/>
-            <a:fld id="{e050cfc2-9f35-4fb7-80ee-daa176b2032c}" type="slidenum">
+            <a:fld id="{3c091813-8e18-4b6a-915c-e767aef831eb}" type="slidenum">
               <a:rPr lang="en-GB" sz="1200" b="1" dirty="0">
                 <a:solidFill>
                   <a:srgbClr val="FFFFFF"/>
@@ -20040,7 +20040,7 @@
           <a:lstStyle/>
           <a:p>
             <a:pPr algn="l"/>
-            <a:fld id="{97356abb-6a22-4a98-a3c7-eb64dfa9d2bb}" type="datetime3">
+            <a:fld id="{44c42270-9f08-4dfe-b1eb-21819604775d}" type="datetime3">
               <a:rPr lang="en-GB" sz="1000" dirty="0">
                 <a:solidFill>
                   <a:srgbClr val="9AA3AE"/>
@@ -20074,7 +20074,7 @@
           <a:lstStyle/>
           <a:p>
             <a:pPr algn="ctr"/>
-            <a:fld id="{bc26bcd8-3f37-4eec-80f7-064bfbd55b8c}" type="slidenum">
+            <a:fld id="{92580bb5-0d92-4382-a024-492ccd376510}" type="slidenum">
               <a:rPr lang="en-GB" sz="1200" b="1" dirty="0">
                 <a:solidFill>
                   <a:srgbClr val="FFFFFF"/>
@@ -20367,7 +20367,7 @@
                 </a:solidFill>
                 <a:latin typeface="Calibri"/>
               </a:rPr>
-              <a:t>Nine required sections plus the FET mapping To Solve the Research Gap. Literature Review follows the Evidence 1, Evidence 2, … template. After the literature summary, each limitation is closed by a named ACRS module. Research Title &amp; Aim is followed by the overall objective, four individual design objectives with artefacts, and what those objectives do not claim (docs/RESEARCH_OBJECTIVES.md). Research Methodology is expanded for each objective (O1 SATR, O2 APRR, O3 MNCD, O4 FCNP), the integrated loop, the exact repository formulas, and two worked traces (ToolBench-schema ranking; live data.gov.in). Objective order is SATR → APRR → MNCD → FCNP (not SMART).</a:t>
+              <a:t>Main FET sections only. Motivation, architecture figures, O1–O4, and methodology detail remain in the deck under these headings; they are not listed as sub-sections here.</a:t>
             </a:r>
           </a:p>
         </p:txBody>
@@ -20426,7 +20426,7 @@
                 </a:solidFill>
                 <a:latin typeface="Calibri"/>
               </a:rPr>
-              <a:t>01a   Motivation</a:t>
+              <a:t>02   Literature Review</a:t>
             </a:r>
           </a:p>
           <a:p>
@@ -20444,7 +20444,7 @@
                 </a:solidFill>
                 <a:latin typeface="Calibri"/>
               </a:rPr>
-              <a:t>02   Literature Review</a:t>
+              <a:t>03   Summary of Literature Review</a:t>
             </a:r>
           </a:p>
           <a:p>
@@ -20462,7 +20462,7 @@
                 </a:solidFill>
                 <a:latin typeface="Calibri"/>
               </a:rPr>
-              <a:t>03   Summary of Literature Review</a:t>
+              <a:t>04   To Solve the Research Gap</a:t>
             </a:r>
           </a:p>
           <a:p>
@@ -20480,7 +20480,7 @@
                 </a:solidFill>
                 <a:latin typeface="Calibri"/>
               </a:rPr>
-              <a:t>03a   To Solve the Research Gap</a:t>
+              <a:t>05   Identified Research Problem</a:t>
             </a:r>
           </a:p>
           <a:p>
@@ -20498,7 +20498,7 @@
                 </a:solidFill>
                 <a:latin typeface="Calibri"/>
               </a:rPr>
-              <a:t>03b   SOTA architecture (cited)</a:t>
+              <a:t>06   Research Title &amp; Aim</a:t>
             </a:r>
           </a:p>
           <a:p>
@@ -20516,7 +20516,7 @@
                 </a:solidFill>
                 <a:latin typeface="Calibri"/>
               </a:rPr>
-              <a:t>03c   Proposed ACRS architecture</a:t>
+              <a:t>07   Research Objectives</a:t>
             </a:r>
           </a:p>
           <a:p>
@@ -20534,7 +20534,7 @@
                 </a:solidFill>
                 <a:latin typeface="Calibri"/>
               </a:rPr>
-              <a:t>04   Identified Research Problem</a:t>
+              <a:t>08   Research Questions</a:t>
             </a:r>
           </a:p>
           <a:p>
@@ -20552,7 +20552,7 @@
                 </a:solidFill>
                 <a:latin typeface="Calibri"/>
               </a:rPr>
-              <a:t>05   Research Title &amp; Aim</a:t>
+              <a:t>09   Research Methodology</a:t>
             </a:r>
           </a:p>
           <a:p>
@@ -20570,331 +20570,7 @@
                 </a:solidFill>
                 <a:latin typeface="Calibri"/>
               </a:rPr>
-              <a:t>05a   Research Objectives — overall</a:t>
-            </a:r>
-          </a:p>
-          <a:p>
-            <a:pPr>
-              <a:spcAft>
-                <a:spcPts val="600"/>
-              </a:spcAft>
-              <a:buFont typeface="Arial"/>
-              <a:buChar char="•"/>
-            </a:pPr>
-            <a:r>
-              <a:rPr sz="1400">
-                <a:solidFill>
-                  <a:srgbClr val="1A1A1A"/>
-                </a:solidFill>
-                <a:latin typeface="Calibri"/>
-              </a:rPr>
-              <a:t>06   Research Objectives — individual</a:t>
-            </a:r>
-          </a:p>
-          <a:p>
-            <a:pPr>
-              <a:spcAft>
-                <a:spcPts val="600"/>
-              </a:spcAft>
-              <a:buFont typeface="Arial"/>
-              <a:buChar char="•"/>
-            </a:pPr>
-            <a:r>
-              <a:rPr sz="1400">
-                <a:solidFill>
-                  <a:srgbClr val="1A1A1A"/>
-                </a:solidFill>
-                <a:latin typeface="Calibri"/>
-              </a:rPr>
-              <a:t>06a   Objective 1 — SATR</a:t>
-            </a:r>
-          </a:p>
-          <a:p>
-            <a:pPr>
-              <a:spcAft>
-                <a:spcPts val="600"/>
-              </a:spcAft>
-              <a:buFont typeface="Arial"/>
-              <a:buChar char="•"/>
-            </a:pPr>
-            <a:r>
-              <a:rPr sz="1400">
-                <a:solidFill>
-                  <a:srgbClr val="1A1A1A"/>
-                </a:solidFill>
-                <a:latin typeface="Calibri"/>
-              </a:rPr>
-              <a:t>06b   Objective 2 — APRR</a:t>
-            </a:r>
-          </a:p>
-          <a:p>
-            <a:pPr>
-              <a:spcAft>
-                <a:spcPts val="600"/>
-              </a:spcAft>
-              <a:buFont typeface="Arial"/>
-              <a:buChar char="•"/>
-            </a:pPr>
-            <a:r>
-              <a:rPr sz="1400">
-                <a:solidFill>
-                  <a:srgbClr val="1A1A1A"/>
-                </a:solidFill>
-                <a:latin typeface="Calibri"/>
-              </a:rPr>
-              <a:t>06c   Objective 3 — MNCD</a:t>
-            </a:r>
-          </a:p>
-          <a:p>
-            <a:pPr>
-              <a:spcAft>
-                <a:spcPts val="600"/>
-              </a:spcAft>
-              <a:buFont typeface="Arial"/>
-              <a:buChar char="•"/>
-            </a:pPr>
-            <a:r>
-              <a:rPr sz="1400">
-                <a:solidFill>
-                  <a:srgbClr val="1A1A1A"/>
-                </a:solidFill>
-                <a:latin typeface="Calibri"/>
-              </a:rPr>
-              <a:t>06d   Objective 4 — FCNP</a:t>
-            </a:r>
-          </a:p>
-          <a:p>
-            <a:pPr>
-              <a:spcAft>
-                <a:spcPts val="600"/>
-              </a:spcAft>
-              <a:buFont typeface="Arial"/>
-              <a:buChar char="•"/>
-            </a:pPr>
-            <a:r>
-              <a:rPr sz="1400">
-                <a:solidFill>
-                  <a:srgbClr val="1A1A1A"/>
-                </a:solidFill>
-                <a:latin typeface="Calibri"/>
-              </a:rPr>
-              <a:t>06e   What these objectives do not claim</a:t>
-            </a:r>
-          </a:p>
-          <a:p>
-            <a:pPr>
-              <a:spcAft>
-                <a:spcPts val="600"/>
-              </a:spcAft>
-              <a:buFont typeface="Arial"/>
-              <a:buChar char="•"/>
-            </a:pPr>
-            <a:r>
-              <a:rPr sz="1400">
-                <a:solidFill>
-                  <a:srgbClr val="1A1A1A"/>
-                </a:solidFill>
-                <a:latin typeface="Calibri"/>
-              </a:rPr>
-              <a:t>07   Research Questions</a:t>
-            </a:r>
-          </a:p>
-          <a:p>
-            <a:pPr>
-              <a:spcAft>
-                <a:spcPts val="600"/>
-              </a:spcAft>
-              <a:buFont typeface="Arial"/>
-              <a:buChar char="•"/>
-            </a:pPr>
-            <a:r>
-              <a:rPr sz="1400">
-                <a:solidFill>
-                  <a:srgbClr val="1A1A1A"/>
-                </a:solidFill>
-                <a:latin typeface="Calibri"/>
-              </a:rPr>
-              <a:t>08   Research Methodology</a:t>
-            </a:r>
-          </a:p>
-          <a:p>
-            <a:pPr>
-              <a:spcAft>
-                <a:spcPts val="600"/>
-              </a:spcAft>
-              <a:buFont typeface="Arial"/>
-              <a:buChar char="•"/>
-            </a:pPr>
-            <a:r>
-              <a:rPr sz="1400">
-                <a:solidFill>
-                  <a:srgbClr val="1A1A1A"/>
-                </a:solidFill>
-                <a:latin typeface="Calibri"/>
-              </a:rPr>
-              <a:t>08a   Methodology — O1 SATR</a:t>
-            </a:r>
-          </a:p>
-          <a:p>
-            <a:pPr>
-              <a:spcAft>
-                <a:spcPts val="600"/>
-              </a:spcAft>
-              <a:buFont typeface="Arial"/>
-              <a:buChar char="•"/>
-            </a:pPr>
-            <a:r>
-              <a:rPr sz="1400">
-                <a:solidFill>
-                  <a:srgbClr val="1A1A1A"/>
-                </a:solidFill>
-                <a:latin typeface="Calibri"/>
-              </a:rPr>
-              <a:t>08b   Methodology — O2 APRR</a:t>
-            </a:r>
-          </a:p>
-          <a:p>
-            <a:pPr>
-              <a:spcAft>
-                <a:spcPts val="600"/>
-              </a:spcAft>
-              <a:buFont typeface="Arial"/>
-              <a:buChar char="•"/>
-            </a:pPr>
-            <a:r>
-              <a:rPr sz="1400">
-                <a:solidFill>
-                  <a:srgbClr val="1A1A1A"/>
-                </a:solidFill>
-                <a:latin typeface="Calibri"/>
-              </a:rPr>
-              <a:t>08c   Methodology — O3 MNCD</a:t>
-            </a:r>
-          </a:p>
-          <a:p>
-            <a:pPr>
-              <a:spcAft>
-                <a:spcPts val="600"/>
-              </a:spcAft>
-              <a:buFont typeface="Arial"/>
-              <a:buChar char="•"/>
-            </a:pPr>
-            <a:r>
-              <a:rPr sz="1400">
-                <a:solidFill>
-                  <a:srgbClr val="1A1A1A"/>
-                </a:solidFill>
-                <a:latin typeface="Calibri"/>
-              </a:rPr>
-              <a:t>08d   Methodology — O4 FCNP</a:t>
-            </a:r>
-          </a:p>
-          <a:p>
-            <a:pPr>
-              <a:spcAft>
-                <a:spcPts val="600"/>
-              </a:spcAft>
-              <a:buFont typeface="Arial"/>
-              <a:buChar char="•"/>
-            </a:pPr>
-            <a:r>
-              <a:rPr sz="1400">
-                <a:solidFill>
-                  <a:srgbClr val="1A1A1A"/>
-                </a:solidFill>
-                <a:latin typeface="Calibri"/>
-              </a:rPr>
-              <a:t>08e   Methodology — integrated loop</a:t>
-            </a:r>
-          </a:p>
-          <a:p>
-            <a:pPr>
-              <a:spcAft>
-                <a:spcPts val="600"/>
-              </a:spcAft>
-              <a:buFont typeface="Arial"/>
-              <a:buChar char="•"/>
-            </a:pPr>
-            <a:r>
-              <a:rPr sz="1400">
-                <a:solidFill>
-                  <a:srgbClr val="1A1A1A"/>
-                </a:solidFill>
-                <a:latin typeface="Calibri"/>
-              </a:rPr>
-              <a:t>08f   Methodology — implementation formulas</a:t>
-            </a:r>
-          </a:p>
-          <a:p>
-            <a:pPr>
-              <a:spcAft>
-                <a:spcPts val="600"/>
-              </a:spcAft>
-              <a:buFont typeface="Arial"/>
-              <a:buChar char="•"/>
-            </a:pPr>
-            <a:r>
-              <a:rPr sz="1400">
-                <a:solidFill>
-                  <a:srgbClr val="1A1A1A"/>
-                </a:solidFill>
-                <a:latin typeface="Calibri"/>
-              </a:rPr>
-              <a:t>08g   Methodology — implemented algorithms</a:t>
-            </a:r>
-          </a:p>
-          <a:p>
-            <a:pPr>
-              <a:spcAft>
-                <a:spcPts val="600"/>
-              </a:spcAft>
-              <a:buFont typeface="Arial"/>
-              <a:buChar char="•"/>
-            </a:pPr>
-            <a:r>
-              <a:rPr sz="1400">
-                <a:solidFill>
-                  <a:srgbClr val="1A1A1A"/>
-                </a:solidFill>
-                <a:latin typeface="Calibri"/>
-              </a:rPr>
-              <a:t>08h   Methodology — ToolBench walkthrough</a:t>
-            </a:r>
-          </a:p>
-          <a:p>
-            <a:pPr>
-              <a:spcAft>
-                <a:spcPts val="600"/>
-              </a:spcAft>
-              <a:buFont typeface="Arial"/>
-              <a:buChar char="•"/>
-            </a:pPr>
-            <a:r>
-              <a:rPr sz="1400">
-                <a:solidFill>
-                  <a:srgbClr val="1A1A1A"/>
-                </a:solidFill>
-                <a:latin typeface="Calibri"/>
-              </a:rPr>
-              <a:t>08i   Methodology — data.gov.in walkthrough</a:t>
-            </a:r>
-          </a:p>
-          <a:p>
-            <a:pPr>
-              <a:spcAft>
-                <a:spcPts val="600"/>
-              </a:spcAft>
-              <a:buFont typeface="Arial"/>
-              <a:buChar char="•"/>
-            </a:pPr>
-            <a:r>
-              <a:rPr sz="1400">
-                <a:solidFill>
-                  <a:srgbClr val="1A1A1A"/>
-                </a:solidFill>
-                <a:latin typeface="Calibri"/>
-              </a:rPr>
-              <a:t>09   Conclusion</a:t>
+              <a:t>10   Conclusion</a:t>
             </a:r>
           </a:p>
         </p:txBody>
@@ -20920,7 +20596,7 @@
           <a:lstStyle/>
           <a:p>
             <a:pPr algn="l"/>
-            <a:fld id="{32385244-3427-4c7e-8834-7daf16cf18c9}" type="datetime3">
+            <a:fld id="{c9b5bbf1-9ff5-4ecc-8eb0-1bbadfd40743}" type="datetime3">
               <a:rPr lang="en-GB" sz="1000" dirty="0">
                 <a:solidFill>
                   <a:srgbClr val="9AA3AE"/>
@@ -20954,7 +20630,7 @@
           <a:lstStyle/>
           <a:p>
             <a:pPr algn="ctr"/>
-            <a:fld id="{f4a97765-a6d4-4b9e-9a8e-e7f78076d823}" type="slidenum">
+            <a:fld id="{2de584aa-d926-4c4d-bb77-895d8e64bbd8}" type="slidenum">
               <a:rPr lang="en-GB" sz="1200" b="1" dirty="0">
                 <a:solidFill>
                   <a:srgbClr val="FFFFFF"/>
@@ -21853,7 +21529,7 @@
           <a:lstStyle/>
           <a:p>
             <a:pPr algn="l"/>
-            <a:fld id="{3ec631de-eb5f-44f7-9aa6-cbb274312059}" type="datetime3">
+            <a:fld id="{3ec8776c-7df9-4bab-b909-021eb0df5df4}" type="datetime3">
               <a:rPr lang="en-GB" sz="1000" dirty="0">
                 <a:solidFill>
                   <a:srgbClr val="9AA3AE"/>
@@ -21887,7 +21563,7 @@
           <a:lstStyle/>
           <a:p>
             <a:pPr algn="ctr"/>
-            <a:fld id="{9da2d52a-d53f-41b9-b1b0-625f1169e231}" type="slidenum">
+            <a:fld id="{cffabc69-9f4f-4d20-99e0-8667a738cd75}" type="slidenum">
               <a:rPr lang="en-GB" sz="1200" b="1" dirty="0">
                 <a:solidFill>
                   <a:srgbClr val="FFFFFF"/>
@@ -22696,7 +22372,7 @@
           <a:lstStyle/>
           <a:p>
             <a:pPr algn="l"/>
-            <a:fld id="{c156026f-3f5b-4b4a-bfa8-739694d18f75}" type="datetime3">
+            <a:fld id="{d97a6af6-c169-401f-b9ab-4e314d680a80}" type="datetime3">
               <a:rPr lang="en-GB" sz="1000" dirty="0">
                 <a:solidFill>
                   <a:srgbClr val="9AA3AE"/>
@@ -22730,7 +22406,7 @@
           <a:lstStyle/>
           <a:p>
             <a:pPr algn="ctr"/>
-            <a:fld id="{fe0f5901-0e1d-4aac-8e67-40c57472869b}" type="slidenum">
+            <a:fld id="{763bce3a-3db5-4258-ab62-c39887c16aea}" type="slidenum">
               <a:rPr lang="en-GB" sz="1200" b="1" dirty="0">
                 <a:solidFill>
                   <a:srgbClr val="FFFFFF"/>
@@ -23485,7 +23161,7 @@
           <a:lstStyle/>
           <a:p>
             <a:pPr algn="l"/>
-            <a:fld id="{69ce812d-24ac-4eed-9748-6c8de2dd5f6c}" type="datetime3">
+            <a:fld id="{7eb8c979-1550-403b-8a10-cb9e0e26f8eb}" type="datetime3">
               <a:rPr lang="en-GB" sz="1000" dirty="0">
                 <a:solidFill>
                   <a:srgbClr val="9AA3AE"/>
@@ -23519,7 +23195,7 @@
           <a:lstStyle/>
           <a:p>
             <a:pPr algn="ctr"/>
-            <a:fld id="{2ceb3b18-5a91-4705-ac82-bd8b44bfd4ab}" type="slidenum">
+            <a:fld id="{b46b826d-abcf-4272-a51c-646f5ecd8ca7}" type="slidenum">
               <a:rPr lang="en-GB" sz="1200" b="1" dirty="0">
                 <a:solidFill>
                   <a:srgbClr val="FFFFFF"/>
@@ -24328,7 +24004,7 @@
           <a:lstStyle/>
           <a:p>
             <a:pPr algn="l"/>
-            <a:fld id="{c30b1abb-a8db-4d74-ab34-ebc9a02dfcb8}" type="datetime3">
+            <a:fld id="{f0691323-10fc-4f5b-87eb-d5dae5551ed4}" type="datetime3">
               <a:rPr lang="en-GB" sz="1000" dirty="0">
                 <a:solidFill>
                   <a:srgbClr val="9AA3AE"/>
@@ -24362,7 +24038,7 @@
           <a:lstStyle/>
           <a:p>
             <a:pPr algn="ctr"/>
-            <a:fld id="{3a5756fb-84e5-45c3-be91-9cb02dbfe230}" type="slidenum">
+            <a:fld id="{addfa192-88ff-4118-9e9d-8f9c3b306b6c}" type="slidenum">
               <a:rPr lang="en-GB" sz="1200" b="1" dirty="0">
                 <a:solidFill>
                   <a:srgbClr val="FFFFFF"/>
@@ -25206,7 +24882,7 @@
           <a:lstStyle/>
           <a:p>
             <a:pPr algn="l"/>
-            <a:fld id="{fa79ffc5-3e98-48a6-803e-192542bbe6ac}" type="datetime3">
+            <a:fld id="{43eef4b5-c581-459f-9e20-39875c2d394b}" type="datetime3">
               <a:rPr lang="en-GB" sz="1000" dirty="0">
                 <a:solidFill>
                   <a:srgbClr val="9AA3AE"/>
@@ -25240,7 +24916,7 @@
           <a:lstStyle/>
           <a:p>
             <a:pPr algn="ctr"/>
-            <a:fld id="{e93ae0ab-e345-4e35-96d2-0bb61d5d5818}" type="slidenum">
+            <a:fld id="{280a0534-87bf-4c54-b1fb-5c0087793c4d}" type="slidenum">
               <a:rPr lang="en-GB" sz="1200" b="1" dirty="0">
                 <a:solidFill>
                   <a:srgbClr val="FFFFFF"/>
@@ -25926,7 +25602,7 @@
           <a:lstStyle/>
           <a:p>
             <a:pPr algn="l"/>
-            <a:fld id="{97ad2783-5060-43b5-9f38-72df418805cc}" type="datetime3">
+            <a:fld id="{c68d867b-842b-47dd-9467-4fc2c735f78a}" type="datetime3">
               <a:rPr lang="en-GB" sz="1000" dirty="0">
                 <a:solidFill>
                   <a:srgbClr val="9AA3AE"/>
@@ -25960,7 +25636,7 @@
           <a:lstStyle/>
           <a:p>
             <a:pPr algn="ctr"/>
-            <a:fld id="{fa65d0b8-8a48-4eca-ab5b-f1db98800540}" type="slidenum">
+            <a:fld id="{10795d22-a825-4c38-91ee-2c2d51cfe6c4}" type="slidenum">
               <a:rPr lang="en-GB" sz="1200" b="1" dirty="0">
                 <a:solidFill>
                   <a:srgbClr val="FFFFFF"/>
@@ -26769,7 +26445,7 @@
           <a:lstStyle/>
           <a:p>
             <a:pPr algn="l"/>
-            <a:fld id="{8114bfea-bc94-452f-89c4-a7ce2fa7b24b}" type="datetime3">
+            <a:fld id="{dd8bed28-7843-4dec-a556-7ec4b3f1892a}" type="datetime3">
               <a:rPr lang="en-GB" sz="1000" dirty="0">
                 <a:solidFill>
                   <a:srgbClr val="9AA3AE"/>
@@ -26803,7 +26479,7 @@
           <a:lstStyle/>
           <a:p>
             <a:pPr algn="ctr"/>
-            <a:fld id="{d0c4cd2e-f0de-4452-a6a8-bf5a2f30889f}" type="slidenum">
+            <a:fld id="{c86ce468-cd05-4878-8151-f728b5bcd2bc}" type="slidenum">
               <a:rPr lang="en-GB" sz="1200" b="1" dirty="0">
                 <a:solidFill>
                   <a:srgbClr val="FFFFFF"/>
@@ -27270,7 +26946,7 @@
           <a:lstStyle/>
           <a:p>
             <a:pPr algn="l"/>
-            <a:fld id="{b2f7452c-08f5-4ebd-b73a-92b9f4e6852e}" type="datetime3">
+            <a:fld id="{58bbaa6c-ca9f-452d-8832-bc25a3ea8c58}" type="datetime3">
               <a:rPr lang="en-GB" sz="1000" dirty="0">
                 <a:solidFill>
                   <a:srgbClr val="9AA3AE"/>
@@ -27304,7 +26980,7 @@
           <a:lstStyle/>
           <a:p>
             <a:pPr algn="ctr"/>
-            <a:fld id="{72149f37-bbc9-47c0-b418-d92031c4f1d8}" type="slidenum">
+            <a:fld id="{3862bf4c-9395-443e-b1d7-06bcbe257b48}" type="slidenum">
               <a:rPr lang="en-GB" sz="1200" b="1" dirty="0">
                 <a:solidFill>
                   <a:srgbClr val="FFFFFF"/>
@@ -27771,7 +27447,7 @@
           <a:lstStyle/>
           <a:p>
             <a:pPr algn="l"/>
-            <a:fld id="{08a98e85-9c97-492d-a93d-3ffea1497383}" type="datetime3">
+            <a:fld id="{42127834-62e5-4053-b51f-1c64027f40f5}" type="datetime3">
               <a:rPr lang="en-GB" sz="1000" dirty="0">
                 <a:solidFill>
                   <a:srgbClr val="9AA3AE"/>
@@ -27805,7 +27481,7 @@
           <a:lstStyle/>
           <a:p>
             <a:pPr algn="ctr"/>
-            <a:fld id="{a07c51c3-c359-4d3d-a1fa-23702ab3e633}" type="slidenum">
+            <a:fld id="{34b9de27-a998-464a-bc17-e7796d633a83}" type="slidenum">
               <a:rPr lang="en-GB" sz="1200" b="1" dirty="0">
                 <a:solidFill>
                   <a:srgbClr val="FFFFFF"/>
@@ -28237,7 +27913,7 @@
           <a:lstStyle/>
           <a:p>
             <a:pPr algn="l"/>
-            <a:fld id="{72a1ac19-0033-4336-9260-3f01f5fc5af9}" type="datetime3">
+            <a:fld id="{7e999e89-b92f-49fa-9b3c-a0d8688ec1ff}" type="datetime3">
               <a:rPr lang="en-GB" sz="1000" dirty="0">
                 <a:solidFill>
                   <a:srgbClr val="9AA3AE"/>
@@ -28271,7 +27947,7 @@
           <a:lstStyle/>
           <a:p>
             <a:pPr algn="ctr"/>
-            <a:fld id="{ef4de457-fd2c-4ce2-91df-372a74cfc102}" type="slidenum">
+            <a:fld id="{45d09752-a792-468f-903f-18155740c185}" type="slidenum">
               <a:rPr lang="en-GB" sz="1200" b="1" dirty="0">
                 <a:solidFill>
                   <a:srgbClr val="FFFFFF"/>
@@ -28703,7 +28379,7 @@
           <a:lstStyle/>
           <a:p>
             <a:pPr algn="l"/>
-            <a:fld id="{dd91ca7b-d592-4dce-9d20-a2311ab4ff16}" type="datetime3">
+            <a:fld id="{da43f502-d964-4081-8b04-35951a6cf18c}" type="datetime3">
               <a:rPr lang="en-GB" sz="1000" dirty="0">
                 <a:solidFill>
                   <a:srgbClr val="9AA3AE"/>
@@ -28737,7 +28413,7 @@
           <a:lstStyle/>
           <a:p>
             <a:pPr algn="ctr"/>
-            <a:fld id="{02ef7acd-e93e-4fd7-9bba-bcb29a63f609}" type="slidenum">
+            <a:fld id="{e6ab1be0-1611-4f34-b529-35b35f171ffb}" type="slidenum">
               <a:rPr lang="en-GB" sz="1200" b="1" dirty="0">
                 <a:solidFill>
                   <a:srgbClr val="FFFFFF"/>
@@ -29188,7 +28864,7 @@
           <a:lstStyle/>
           <a:p>
             <a:pPr algn="l"/>
-            <a:fld id="{52565ccd-1c6d-4c38-8f99-461aed8aa2dc}" type="datetime3">
+            <a:fld id="{213fdf83-91e9-4453-824d-e121d5225863}" type="datetime3">
               <a:rPr lang="en-GB" sz="1000" dirty="0">
                 <a:solidFill>
                   <a:srgbClr val="9AA3AE"/>
@@ -29222,7 +28898,7 @@
           <a:lstStyle/>
           <a:p>
             <a:pPr algn="ctr"/>
-            <a:fld id="{4eba2141-5c55-4d1d-ac06-a3779e0a4eef}" type="slidenum">
+            <a:fld id="{9e195598-bad0-4b8c-b9e8-d0e570250b67}" type="slidenum">
               <a:rPr lang="en-GB" sz="1200" b="1" dirty="0">
                 <a:solidFill>
                   <a:srgbClr val="FFFFFF"/>
@@ -29673,7 +29349,7 @@
           <a:lstStyle/>
           <a:p>
             <a:pPr algn="l"/>
-            <a:fld id="{b4fb15d4-85c5-45ca-b258-d0ecc06565ce}" type="datetime3">
+            <a:fld id="{7e8a1db6-538c-4746-a8f0-3613d703205a}" type="datetime3">
               <a:rPr lang="en-GB" sz="1000" dirty="0">
                 <a:solidFill>
                   <a:srgbClr val="9AA3AE"/>
@@ -29707,7 +29383,7 @@
           <a:lstStyle/>
           <a:p>
             <a:pPr algn="ctr"/>
-            <a:fld id="{26c70437-0c43-42ff-96d1-e95f9644b05e}" type="slidenum">
+            <a:fld id="{a778664c-4e2f-4304-a1d1-1b41ca886a29}" type="slidenum">
               <a:rPr lang="en-GB" sz="1200" b="1" dirty="0">
                 <a:solidFill>
                   <a:srgbClr val="FFFFFF"/>
@@ -30193,7 +29869,7 @@
           <a:lstStyle/>
           <a:p>
             <a:pPr algn="l"/>
-            <a:fld id="{d1fdf01e-6e1c-4906-b1ff-d63eea1425ea}" type="datetime3">
+            <a:fld id="{436f79fe-72ab-4076-817d-a358770bc661}" type="datetime3">
               <a:rPr lang="en-GB" sz="1000" dirty="0">
                 <a:solidFill>
                   <a:srgbClr val="9AA3AE"/>
@@ -30227,7 +29903,7 @@
           <a:lstStyle/>
           <a:p>
             <a:pPr algn="ctr"/>
-            <a:fld id="{6afae7ec-76e6-49f2-a73f-f526a4e8a015}" type="slidenum">
+            <a:fld id="{f2eb8670-49d6-40ee-9fea-f1fd65e0a18c}" type="slidenum">
               <a:rPr lang="en-GB" sz="1200" b="1" dirty="0">
                 <a:solidFill>
                   <a:srgbClr val="FFFFFF"/>
@@ -30677,7 +30353,7 @@
           <a:lstStyle/>
           <a:p>
             <a:pPr algn="l"/>
-            <a:fld id="{6b247c57-b302-45fe-b482-20e47e4edacd}" type="datetime3">
+            <a:fld id="{634aae4a-53cc-485b-bb21-2b1de8a83c43}" type="datetime3">
               <a:rPr lang="en-GB" sz="1000" dirty="0">
                 <a:solidFill>
                   <a:srgbClr val="9AA3AE"/>
@@ -30711,7 +30387,7 @@
           <a:lstStyle/>
           <a:p>
             <a:pPr algn="ctr"/>
-            <a:fld id="{1f90fc3c-92a7-4527-b5a1-ab450fd08994}" type="slidenum">
+            <a:fld id="{38f2bb69-bd8f-403a-8f0e-8f1fa088ecb3}" type="slidenum">
               <a:rPr lang="en-GB" sz="1200" b="1" dirty="0">
                 <a:solidFill>
                   <a:srgbClr val="FFFFFF"/>
@@ -31178,7 +30854,7 @@
           <a:lstStyle/>
           <a:p>
             <a:pPr algn="l"/>
-            <a:fld id="{118e3413-55c7-447b-8143-9253f6a99c79}" type="datetime3">
+            <a:fld id="{27274a5d-ec3b-4cbb-a5ff-ef873ac0f039}" type="datetime3">
               <a:rPr lang="en-GB" sz="1000" dirty="0">
                 <a:solidFill>
                   <a:srgbClr val="9AA3AE"/>
@@ -31212,7 +30888,7 @@
           <a:lstStyle/>
           <a:p>
             <a:pPr algn="ctr"/>
-            <a:fld id="{d9f40755-1948-4db9-927c-a59d5c998481}" type="slidenum">
+            <a:fld id="{b8371c9e-8313-40c1-8185-ca56d26f56a0}" type="slidenum">
               <a:rPr lang="en-GB" sz="1200" b="1" dirty="0">
                 <a:solidFill>
                   <a:srgbClr val="FFFFFF"/>
@@ -32139,7 +31815,7 @@
           <a:lstStyle/>
           <a:p>
             <a:pPr algn="l"/>
-            <a:fld id="{ccf7cc15-a7a3-440e-9951-1c284292bdf7}" type="datetime3">
+            <a:fld id="{f3ab26a6-3f37-4d58-8133-c822b45bab1d}" type="datetime3">
               <a:rPr lang="en-GB" sz="1000" dirty="0">
                 <a:solidFill>
                   <a:srgbClr val="9AA3AE"/>
@@ -32173,7 +31849,7 @@
           <a:lstStyle/>
           <a:p>
             <a:pPr algn="ctr"/>
-            <a:fld id="{2d0380dd-eadb-48f3-94eb-74d003b64ba4}" type="slidenum">
+            <a:fld id="{7454e94f-fa10-48e4-8320-07632ecf9a71}" type="slidenum">
               <a:rPr lang="en-GB" sz="1200" b="1" dirty="0">
                 <a:solidFill>
                   <a:srgbClr val="FFFFFF"/>
@@ -33100,7 +32776,7 @@
           <a:lstStyle/>
           <a:p>
             <a:pPr algn="l"/>
-            <a:fld id="{143231b1-bb59-483b-b894-29b3150de939}" type="datetime3">
+            <a:fld id="{20b66ea6-b922-4173-bb50-9bdf3c601f4d}" type="datetime3">
               <a:rPr lang="en-GB" sz="1000" dirty="0">
                 <a:solidFill>
                   <a:srgbClr val="9AA3AE"/>
@@ -33134,7 +32810,7 @@
           <a:lstStyle/>
           <a:p>
             <a:pPr algn="ctr"/>
-            <a:fld id="{6f99ff2e-2f4e-4e70-85e3-7f6fc9ccf21b}" type="slidenum">
+            <a:fld id="{702f82c1-f4e2-415f-9f1f-c4bd7cd13a02}" type="slidenum">
               <a:rPr lang="en-GB" sz="1200" b="1" dirty="0">
                 <a:solidFill>
                   <a:srgbClr val="FFFFFF"/>
@@ -34061,7 +33737,7 @@
           <a:lstStyle/>
           <a:p>
             <a:pPr algn="l"/>
-            <a:fld id="{de1bd0d8-a310-46e3-ba5f-b845bb42f4f6}" type="datetime3">
+            <a:fld id="{3a63f844-f669-42ec-a906-42d6f173762e}" type="datetime3">
               <a:rPr lang="en-GB" sz="1000" dirty="0">
                 <a:solidFill>
                   <a:srgbClr val="9AA3AE"/>
@@ -34095,7 +33771,7 @@
           <a:lstStyle/>
           <a:p>
             <a:pPr algn="ctr"/>
-            <a:fld id="{5afa98a4-8525-4d8f-84bd-74ee381e75c5}" type="slidenum">
+            <a:fld id="{fbdc83b9-9779-4c62-b688-49aa9efd83aa}" type="slidenum">
               <a:rPr lang="en-GB" sz="1200" b="1" dirty="0">
                 <a:solidFill>
                   <a:srgbClr val="FFFFFF"/>
@@ -35022,7 +34698,7 @@
           <a:lstStyle/>
           <a:p>
             <a:pPr algn="l"/>
-            <a:fld id="{19ea6cb2-e778-4890-842b-9627c62f311a}" type="datetime3">
+            <a:fld id="{7284679d-3c1c-4f46-a899-eac1bed4c9ee}" type="datetime3">
               <a:rPr lang="en-GB" sz="1000" dirty="0">
                 <a:solidFill>
                   <a:srgbClr val="9AA3AE"/>
@@ -35056,7 +34732,7 @@
           <a:lstStyle/>
           <a:p>
             <a:pPr algn="ctr"/>
-            <a:fld id="{f55a4476-c437-41a2-83c0-a196fc8b1626}" type="slidenum">
+            <a:fld id="{ffc3683d-054f-430c-bc4a-3a55c2db559e}" type="slidenum">
               <a:rPr lang="en-GB" sz="1200" b="1" dirty="0">
                 <a:solidFill>
                   <a:srgbClr val="FFFFFF"/>

</xml_diff>

<commit_message>
Number the bibliography, add References to Contents, and link DOIs.
Evidence n is citation [n]. Each Crossref DOI opens https://doi.org/….
</commit_message>
<xml_diff>
--- a/ACRS_PhD_Proposal_JenishaT_24ETRP720001.pptx
+++ b/ACRS_PhD_Proposal_JenishaT_24ETRP720001.pptx
@@ -3835,7 +3835,7 @@
           <a:lstStyle/>
           <a:p>
             <a:pPr algn="l"/>
-            <a:fld id="{79bc40c5-0f19-449d-bbc3-50e058a4d530}" type="datetime3">
+            <a:fld id="{654358f5-caf0-4de5-b717-88ffe6f87151}" type="datetime3">
               <a:rPr lang="en-GB" sz="1000" dirty="0">
                 <a:solidFill>
                   <a:srgbClr val="9AA3AE"/>
@@ -3869,7 +3869,7 @@
           <a:lstStyle/>
           <a:p>
             <a:pPr algn="ctr"/>
-            <a:fld id="{6b7ce373-bd35-4a2d-8481-a46c88d74846}" type="slidenum">
+            <a:fld id="{842b063f-fb15-41c6-9987-3afaf94517f3}" type="slidenum">
               <a:rPr lang="en-GB" sz="1200" b="1" dirty="0">
                 <a:solidFill>
                   <a:srgbClr val="FFFFFF"/>
@@ -4796,7 +4796,7 @@
           <a:lstStyle/>
           <a:p>
             <a:pPr algn="l"/>
-            <a:fld id="{5d61c29b-9830-4696-b7f2-55af113138e5}" type="datetime3">
+            <a:fld id="{efce820b-539a-45fb-b9b8-dc9d778614c7}" type="datetime3">
               <a:rPr lang="en-GB" sz="1000" dirty="0">
                 <a:solidFill>
                   <a:srgbClr val="9AA3AE"/>
@@ -4830,7 +4830,7 @@
           <a:lstStyle/>
           <a:p>
             <a:pPr algn="ctr"/>
-            <a:fld id="{a239dbfe-d22a-4c1f-a938-ce1573dc5f73}" type="slidenum">
+            <a:fld id="{c060fcbc-7b94-412d-8c6b-aef9ace5044a}" type="slidenum">
               <a:rPr lang="en-GB" sz="1200" b="1" dirty="0">
                 <a:solidFill>
                   <a:srgbClr val="FFFFFF"/>
@@ -5757,7 +5757,7 @@
           <a:lstStyle/>
           <a:p>
             <a:pPr algn="l"/>
-            <a:fld id="{4e82ab66-753e-41e3-bff6-968c41d4ab38}" type="datetime3">
+            <a:fld id="{aab8fbd1-bfde-47c9-b638-7411440db527}" type="datetime3">
               <a:rPr lang="en-GB" sz="1000" dirty="0">
                 <a:solidFill>
                   <a:srgbClr val="9AA3AE"/>
@@ -5791,7 +5791,7 @@
           <a:lstStyle/>
           <a:p>
             <a:pPr algn="ctr"/>
-            <a:fld id="{403f6587-f939-45f1-9c68-d81dc51c06fa}" type="slidenum">
+            <a:fld id="{201a12ea-9761-4640-a88f-b80086493f30}" type="slidenum">
               <a:rPr lang="en-GB" sz="1200" b="1" dirty="0">
                 <a:solidFill>
                   <a:srgbClr val="FFFFFF"/>
@@ -6718,7 +6718,7 @@
           <a:lstStyle/>
           <a:p>
             <a:pPr algn="l"/>
-            <a:fld id="{4685405d-e35e-47bf-afcd-b8d9e805f68d}" type="datetime3">
+            <a:fld id="{6805c05c-8356-4e91-9f93-b1add282f55c}" type="datetime3">
               <a:rPr lang="en-GB" sz="1000" dirty="0">
                 <a:solidFill>
                   <a:srgbClr val="9AA3AE"/>
@@ -6752,7 +6752,7 @@
           <a:lstStyle/>
           <a:p>
             <a:pPr algn="ctr"/>
-            <a:fld id="{7cb31cd2-e21f-43c7-a9c6-e393b35c427f}" type="slidenum">
+            <a:fld id="{7c4f265e-a1c6-4e70-93cb-35b900c3a795}" type="slidenum">
               <a:rPr lang="en-GB" sz="1200" b="1" dirty="0">
                 <a:solidFill>
                   <a:srgbClr val="FFFFFF"/>
@@ -7679,7 +7679,7 @@
           <a:lstStyle/>
           <a:p>
             <a:pPr algn="l"/>
-            <a:fld id="{3f602372-ae1c-470e-902b-fa58489d3680}" type="datetime3">
+            <a:fld id="{858c5eee-216e-4933-95b9-425d93cb2369}" type="datetime3">
               <a:rPr lang="en-GB" sz="1000" dirty="0">
                 <a:solidFill>
                   <a:srgbClr val="9AA3AE"/>
@@ -7713,7 +7713,7 @@
           <a:lstStyle/>
           <a:p>
             <a:pPr algn="ctr"/>
-            <a:fld id="{7ec21884-11b9-4c5d-ba19-b0a03c53c444}" type="slidenum">
+            <a:fld id="{67870495-24d6-4fd3-a022-dc5624eb1d95}" type="slidenum">
               <a:rPr lang="en-GB" sz="1200" b="1" dirty="0">
                 <a:solidFill>
                   <a:srgbClr val="FFFFFF"/>
@@ -8640,7 +8640,7 @@
           <a:lstStyle/>
           <a:p>
             <a:pPr algn="l"/>
-            <a:fld id="{f46035cb-1ce0-4cbc-be49-3df87982d6f9}" type="datetime3">
+            <a:fld id="{092f85d5-a198-4b9e-b88d-fe748299f529}" type="datetime3">
               <a:rPr lang="en-GB" sz="1000" dirty="0">
                 <a:solidFill>
                   <a:srgbClr val="9AA3AE"/>
@@ -8674,7 +8674,7 @@
           <a:lstStyle/>
           <a:p>
             <a:pPr algn="ctr"/>
-            <a:fld id="{ecb0d392-1e74-4f6a-a784-e106f292d46f}" type="slidenum">
+            <a:fld id="{5d0c0902-0676-48ed-87be-7af188518854}" type="slidenum">
               <a:rPr lang="en-GB" sz="1200" b="1" dirty="0">
                 <a:solidFill>
                   <a:srgbClr val="FFFFFF"/>
@@ -9496,7 +9496,7 @@
           <a:lstStyle/>
           <a:p>
             <a:pPr algn="l"/>
-            <a:fld id="{5cc98f82-ce20-43ba-a532-78aea2d81f7b}" type="datetime3">
+            <a:fld id="{9c57c411-0883-4a3e-8186-427fbb0e5e11}" type="datetime3">
               <a:rPr lang="en-GB" sz="1000" dirty="0">
                 <a:solidFill>
                   <a:srgbClr val="9AA3AE"/>
@@ -9530,7 +9530,7 @@
           <a:lstStyle/>
           <a:p>
             <a:pPr algn="ctr"/>
-            <a:fld id="{9638127b-1133-4198-92f0-9f93a64d5561}" type="slidenum">
+            <a:fld id="{45475850-6966-4d0f-ad09-acf9ef68d1b4}" type="slidenum">
               <a:rPr lang="en-GB" sz="1200" b="1" dirty="0">
                 <a:solidFill>
                   <a:srgbClr val="FFFFFF"/>
@@ -10284,7 +10284,7 @@
           <a:lstStyle/>
           <a:p>
             <a:pPr algn="l"/>
-            <a:fld id="{19e6085b-48e5-49e5-95c5-3401909deebf}" type="datetime3">
+            <a:fld id="{97385b77-8060-439c-b2ab-a421c9ea7f2a}" type="datetime3">
               <a:rPr lang="en-GB" sz="1000" dirty="0">
                 <a:solidFill>
                   <a:srgbClr val="9AA3AE"/>
@@ -10318,7 +10318,7 @@
           <a:lstStyle/>
           <a:p>
             <a:pPr algn="ctr"/>
-            <a:fld id="{0d00fb5a-fd5d-43c4-8b88-6e85cc9d1175}" type="slidenum">
+            <a:fld id="{528a2512-f73e-45d2-9697-f314c3662cd7}" type="slidenum">
               <a:rPr lang="en-GB" sz="1200" b="1" dirty="0">
                 <a:solidFill>
                   <a:srgbClr val="FFFFFF"/>
@@ -11018,7 +11018,7 @@
           <a:lstStyle/>
           <a:p>
             <a:pPr algn="l"/>
-            <a:fld id="{cd1f5dea-ced5-48b3-b240-d3d7ae7a38df}" type="datetime3">
+            <a:fld id="{15551e35-2fb6-444e-8fc7-a95714db58a4}" type="datetime3">
               <a:rPr lang="en-GB" sz="1000" dirty="0">
                 <a:solidFill>
                   <a:srgbClr val="9AA3AE"/>
@@ -11052,7 +11052,7 @@
           <a:lstStyle/>
           <a:p>
             <a:pPr algn="ctr"/>
-            <a:fld id="{a62a0ee5-96f8-41b5-a0ab-5b15dd7fde06}" type="slidenum">
+            <a:fld id="{8be17b33-8142-46e8-987a-38cec05b34d2}" type="slidenum">
               <a:rPr lang="en-GB" sz="1200" b="1" dirty="0">
                 <a:solidFill>
                   <a:srgbClr val="FFFFFF"/>
@@ -11860,7 +11860,7 @@
           <a:lstStyle/>
           <a:p>
             <a:pPr algn="l"/>
-            <a:fld id="{839a08de-57a2-4e4f-8e03-c239c89d69f9}" type="datetime3">
+            <a:fld id="{b9d4b552-97ea-4070-88c0-f31d3be54d5d}" type="datetime3">
               <a:rPr lang="en-GB" sz="1000" dirty="0">
                 <a:solidFill>
                   <a:srgbClr val="9AA3AE"/>
@@ -11894,7 +11894,7 @@
           <a:lstStyle/>
           <a:p>
             <a:pPr algn="ctr"/>
-            <a:fld id="{45c5cbb9-4351-41f9-a116-50f7bf46e5fd}" type="slidenum">
+            <a:fld id="{c2f18ce8-5aa8-4221-ab1b-12cc89bf0f73}" type="slidenum">
               <a:rPr lang="en-GB" sz="1200" b="1" dirty="0">
                 <a:solidFill>
                   <a:srgbClr val="FFFFFF"/>
@@ -12361,7 +12361,7 @@
           <a:lstStyle/>
           <a:p>
             <a:pPr algn="l"/>
-            <a:fld id="{063b7edd-66ed-4887-8183-e2d2e7d909db}" type="datetime3">
+            <a:fld id="{c7a068e7-d6d0-4e60-b057-a929e422c05a}" type="datetime3">
               <a:rPr lang="en-GB" sz="1000" dirty="0">
                 <a:solidFill>
                   <a:srgbClr val="9AA3AE"/>
@@ -12395,7 +12395,7 @@
           <a:lstStyle/>
           <a:p>
             <a:pPr algn="ctr"/>
-            <a:fld id="{dca317f8-e0b0-4f95-be4b-7ee47a33072a}" type="slidenum">
+            <a:fld id="{fc964bca-1c64-4292-af05-f907f1da1a16}" type="slidenum">
               <a:rPr lang="en-GB" sz="1200" b="1" dirty="0">
                 <a:solidFill>
                   <a:srgbClr val="FFFFFF"/>
@@ -13247,7 +13247,7 @@
           <a:lstStyle/>
           <a:p>
             <a:pPr algn="l"/>
-            <a:fld id="{b2c918a2-3c26-4fa6-b05b-f8025c3d1b96}" type="datetime3">
+            <a:fld id="{5cebbbd2-6c67-4d00-afb9-6e9b8d063cad}" type="datetime3">
               <a:rPr lang="en-GB" sz="1000" dirty="0">
                 <a:solidFill>
                   <a:srgbClr val="9AA3AE"/>
@@ -13281,7 +13281,7 @@
           <a:lstStyle/>
           <a:p>
             <a:pPr algn="ctr"/>
-            <a:fld id="{67feafdc-8afe-468e-bf04-8c4c9bcbc2a1}" type="slidenum">
+            <a:fld id="{bd686c24-efd6-456a-80d8-c83d630cbac8}" type="slidenum">
               <a:rPr lang="en-GB" sz="1200" b="1" dirty="0">
                 <a:solidFill>
                   <a:srgbClr val="FFFFFF"/>
@@ -13713,7 +13713,7 @@
           <a:lstStyle/>
           <a:p>
             <a:pPr algn="l"/>
-            <a:fld id="{9c26b402-3eaf-4551-8bd3-130ac0adbb17}" type="datetime3">
+            <a:fld id="{18166bff-3499-4efc-b65c-d6787322171d}" type="datetime3">
               <a:rPr lang="en-GB" sz="1000" dirty="0">
                 <a:solidFill>
                   <a:srgbClr val="9AA3AE"/>
@@ -13747,7 +13747,7 @@
           <a:lstStyle/>
           <a:p>
             <a:pPr algn="ctr"/>
-            <a:fld id="{03e010f6-919f-458d-8d76-532d43b23070}" type="slidenum">
+            <a:fld id="{bd00e1bf-8e84-4fcd-a05d-f797eeb1fccb}" type="slidenum">
               <a:rPr lang="en-GB" sz="1200" b="1" dirty="0">
                 <a:solidFill>
                   <a:srgbClr val="FFFFFF"/>
@@ -14196,7 +14196,7 @@
           <a:lstStyle/>
           <a:p>
             <a:pPr algn="l"/>
-            <a:fld id="{7485621a-bc46-4f9e-a50b-684f8da1a82c}" type="datetime3">
+            <a:fld id="{ea69f39e-f29b-4c3f-8cbc-62e9e82b7399}" type="datetime3">
               <a:rPr lang="en-GB" sz="1000" dirty="0">
                 <a:solidFill>
                   <a:srgbClr val="9AA3AE"/>
@@ -14230,7 +14230,7 @@
           <a:lstStyle/>
           <a:p>
             <a:pPr algn="ctr"/>
-            <a:fld id="{5797ff8d-9003-4c9c-a48b-43c032073e86}" type="slidenum">
+            <a:fld id="{7dacb714-e7f8-427b-a399-e7080fe911c3}" type="slidenum">
               <a:rPr lang="en-GB" sz="1200" b="1" dirty="0">
                 <a:solidFill>
                   <a:srgbClr val="FFFFFF"/>
@@ -14916,7 +14916,7 @@
           <a:lstStyle/>
           <a:p>
             <a:pPr algn="l"/>
-            <a:fld id="{1a1f67f3-5396-4dad-b135-654733e278ed}" type="datetime3">
+            <a:fld id="{eec7e33d-013b-49c6-94b4-338431b5f90b}" type="datetime3">
               <a:rPr lang="en-GB" sz="1000" dirty="0">
                 <a:solidFill>
                   <a:srgbClr val="9AA3AE"/>
@@ -14950,7 +14950,7 @@
           <a:lstStyle/>
           <a:p>
             <a:pPr algn="ctr"/>
-            <a:fld id="{ab615862-4615-46fe-921f-f34b14840e8d}" type="slidenum">
+            <a:fld id="{a4243361-14c3-4ae7-8b84-8558713ea92c}" type="slidenum">
               <a:rPr lang="en-GB" sz="1200" b="1" dirty="0">
                 <a:solidFill>
                   <a:srgbClr val="FFFFFF"/>
@@ -15848,7 +15848,7 @@
           <a:lstStyle/>
           <a:p>
             <a:pPr algn="l"/>
-            <a:fld id="{51d99c80-f9d8-4146-bb03-48b1a4ce8f82}" type="datetime3">
+            <a:fld id="{2e3a5bb4-04d9-4ad6-ad5b-6ddef876a285}" type="datetime3">
               <a:rPr lang="en-GB" sz="1000" dirty="0">
                 <a:solidFill>
                   <a:srgbClr val="9AA3AE"/>
@@ -15882,7 +15882,7 @@
           <a:lstStyle/>
           <a:p>
             <a:pPr algn="ctr"/>
-            <a:fld id="{3f85f916-1749-49d5-81cb-d89044e6c756}" type="slidenum">
+            <a:fld id="{73be9799-60e9-41f7-9fbc-676c491ba1ad}" type="slidenum">
               <a:rPr lang="en-GB" sz="1200" b="1" dirty="0">
                 <a:solidFill>
                   <a:srgbClr val="FFFFFF"/>
@@ -16672,7 +16672,7 @@
           <a:lstStyle/>
           <a:p>
             <a:pPr algn="l"/>
-            <a:fld id="{9c41a283-6aa9-4f59-8a79-696a3d674058}" type="datetime3">
+            <a:fld id="{a1ccffb8-84f5-4789-a02b-fe1e8f203126}" type="datetime3">
               <a:rPr lang="en-GB" sz="1000" dirty="0">
                 <a:solidFill>
                   <a:srgbClr val="9AA3AE"/>
@@ -16706,7 +16706,7 @@
           <a:lstStyle/>
           <a:p>
             <a:pPr algn="ctr"/>
-            <a:fld id="{b9ece9b5-87d0-48e9-b193-0719d6f83b78}" type="slidenum">
+            <a:fld id="{37b7d82a-5b9a-431c-bf7d-48e2dfd428fe}" type="slidenum">
               <a:rPr lang="en-GB" sz="1200" b="1" dirty="0">
                 <a:solidFill>
                   <a:srgbClr val="FFFFFF"/>
@@ -17442,7 +17442,7 @@
           <a:lstStyle/>
           <a:p>
             <a:pPr algn="l"/>
-            <a:fld id="{8b089f03-993f-45b4-aff3-05a1331f2598}" type="datetime3">
+            <a:fld id="{ef65ddd9-b05a-4ea9-a9c0-493c5a39d286}" type="datetime3">
               <a:rPr lang="en-GB" sz="1000" dirty="0">
                 <a:solidFill>
                   <a:srgbClr val="9AA3AE"/>
@@ -17476,7 +17476,7 @@
           <a:lstStyle/>
           <a:p>
             <a:pPr algn="ctr"/>
-            <a:fld id="{3fac42c5-9437-4b88-9a3d-cc74bf6ebd9f}" type="slidenum">
+            <a:fld id="{f2d3b9b3-2822-44b7-a399-a0f3c1997c71}" type="slidenum">
               <a:rPr lang="en-GB" sz="1200" b="1" dirty="0">
                 <a:solidFill>
                   <a:srgbClr val="FFFFFF"/>
@@ -18266,7 +18266,7 @@
           <a:lstStyle/>
           <a:p>
             <a:pPr algn="l"/>
-            <a:fld id="{1b64cfe2-8505-4818-948b-50850dc318f5}" type="datetime3">
+            <a:fld id="{4b54cf07-d71f-4a24-a03b-2f0ff9fad3f1}" type="datetime3">
               <a:rPr lang="en-GB" sz="1000" dirty="0">
                 <a:solidFill>
                   <a:srgbClr val="9AA3AE"/>
@@ -18300,7 +18300,7 @@
           <a:lstStyle/>
           <a:p>
             <a:pPr algn="ctr"/>
-            <a:fld id="{9b0cbcdf-35d3-4f4a-b2b7-f08869c66faa}" type="slidenum">
+            <a:fld id="{2efa6f34-bc09-4d7e-b20b-26e441f4285e}" type="slidenum">
               <a:rPr lang="en-GB" sz="1200" b="1" dirty="0">
                 <a:solidFill>
                   <a:srgbClr val="FFFFFF"/>
@@ -18731,7 +18731,7 @@
           <a:lstStyle/>
           <a:p>
             <a:pPr algn="l"/>
-            <a:fld id="{3afb6d49-9ce3-40f2-89f9-ac188f238c43}" type="datetime3">
+            <a:fld id="{f9b91bfa-44d3-41c6-9167-766f59736625}" type="datetime3">
               <a:rPr lang="en-GB" sz="1000" dirty="0">
                 <a:solidFill>
                   <a:srgbClr val="9AA3AE"/>
@@ -18765,7 +18765,7 @@
           <a:lstStyle/>
           <a:p>
             <a:pPr algn="ctr"/>
-            <a:fld id="{34f27d28-ab41-47a9-b327-015fdf112844}" type="slidenum">
+            <a:fld id="{c2ec321e-a8fa-4e7a-8151-787e8a0beb7f}" type="slidenum">
               <a:rPr lang="en-GB" sz="1200" b="1" dirty="0">
                 <a:solidFill>
                   <a:srgbClr val="FFFFFF"/>
@@ -19179,7 +19179,7 @@
           <a:lstStyle/>
           <a:p>
             <a:pPr algn="l"/>
-            <a:fld id="{50e05be2-8efb-42d9-a256-8c00ad199e14}" type="datetime3">
+            <a:fld id="{6fb1371d-b2b8-4877-a6cc-a7a7796aa15a}" type="datetime3">
               <a:rPr lang="en-GB" sz="1000" dirty="0">
                 <a:solidFill>
                   <a:srgbClr val="9AA3AE"/>
@@ -19213,7 +19213,7 @@
           <a:lstStyle/>
           <a:p>
             <a:pPr algn="ctr"/>
-            <a:fld id="{3c091813-8e18-4b6a-915c-e767aef831eb}" type="slidenum">
+            <a:fld id="{b702aaa2-489e-46cd-a1c0-88cd8b81bb6e}" type="slidenum">
               <a:rPr lang="en-GB" sz="1200" b="1" dirty="0">
                 <a:solidFill>
                   <a:srgbClr val="FFFFFF"/>
@@ -20040,7 +20040,7 @@
           <a:lstStyle/>
           <a:p>
             <a:pPr algn="l"/>
-            <a:fld id="{44c42270-9f08-4dfe-b1eb-21819604775d}" type="datetime3">
+            <a:fld id="{71fbee0f-f2c1-430d-bc69-7811a8b3ed8d}" type="datetime3">
               <a:rPr lang="en-GB" sz="1000" dirty="0">
                 <a:solidFill>
                   <a:srgbClr val="9AA3AE"/>
@@ -20074,7 +20074,7 @@
           <a:lstStyle/>
           <a:p>
             <a:pPr algn="ctr"/>
-            <a:fld id="{92580bb5-0d92-4382-a024-492ccd376510}" type="slidenum">
+            <a:fld id="{b65170d4-0886-49bb-8108-19a0887fc549}" type="slidenum">
               <a:rPr lang="en-GB" sz="1200" b="1" dirty="0">
                 <a:solidFill>
                   <a:srgbClr val="FFFFFF"/>
@@ -20367,7 +20367,7 @@
                 </a:solidFill>
                 <a:latin typeface="Calibri"/>
               </a:rPr>
-              <a:t>Main FET sections only. Motivation, architecture figures, O1–O4, and methodology detail remain in the deck under these headings; they are not listed as sub-sections here.</a:t>
+              <a:t>Main FET sections, then numbered References. Motivation, architecture figures, O1–O4, and methodology detail stay in the deck under these headings. Click 11 References for citations [1]–[24] with DOI links.</a:t>
             </a:r>
           </a:p>
         </p:txBody>
@@ -20573,6 +20573,24 @@
               <a:t>10   Conclusion</a:t>
             </a:r>
           </a:p>
+          <a:p>
+            <a:pPr>
+              <a:spcAft>
+                <a:spcPts val="600"/>
+              </a:spcAft>
+              <a:buFont typeface="Arial"/>
+              <a:buChar char="•"/>
+            </a:pPr>
+            <a:r>
+              <a:rPr sz="1400">
+                <a:solidFill>
+                  <a:srgbClr val="1A1A1A"/>
+                </a:solidFill>
+                <a:latin typeface="Calibri"/>
+              </a:rPr>
+              <a:t>11   References</a:t>
+            </a:r>
+          </a:p>
         </p:txBody>
       </p:sp>
       <p:sp>
@@ -20596,7 +20614,7 @@
           <a:lstStyle/>
           <a:p>
             <a:pPr algn="l"/>
-            <a:fld id="{c9b5bbf1-9ff5-4ecc-8eb0-1bbadfd40743}" type="datetime3">
+            <a:fld id="{7859b740-a759-4604-b3fb-96a0efd38d18}" type="datetime3">
               <a:rPr lang="en-GB" sz="1000" dirty="0">
                 <a:solidFill>
                   <a:srgbClr val="9AA3AE"/>
@@ -20630,7 +20648,7 @@
           <a:lstStyle/>
           <a:p>
             <a:pPr algn="ctr"/>
-            <a:fld id="{2de584aa-d926-4c4d-bb77-895d8e64bbd8}" type="slidenum">
+            <a:fld id="{cdf40f45-aa04-4ac8-98fb-3085c02a8d85}" type="slidenum">
               <a:rPr lang="en-GB" sz="1200" b="1" dirty="0">
                 <a:solidFill>
                   <a:srgbClr val="FFFFFF"/>
@@ -21529,7 +21547,7 @@
           <a:lstStyle/>
           <a:p>
             <a:pPr algn="l"/>
-            <a:fld id="{3ec8776c-7df9-4bab-b909-021eb0df5df4}" type="datetime3">
+            <a:fld id="{2591b51b-1791-48c5-bbd0-02bfd535df53}" type="datetime3">
               <a:rPr lang="en-GB" sz="1000" dirty="0">
                 <a:solidFill>
                   <a:srgbClr val="9AA3AE"/>
@@ -21563,7 +21581,7 @@
           <a:lstStyle/>
           <a:p>
             <a:pPr algn="ctr"/>
-            <a:fld id="{cffabc69-9f4f-4d20-99e0-8667a738cd75}" type="slidenum">
+            <a:fld id="{d1598ad5-973e-4db3-912a-1d5ac5bff2dd}" type="slidenum">
               <a:rPr lang="en-GB" sz="1200" b="1" dirty="0">
                 <a:solidFill>
                   <a:srgbClr val="FFFFFF"/>
@@ -22372,7 +22390,7 @@
           <a:lstStyle/>
           <a:p>
             <a:pPr algn="l"/>
-            <a:fld id="{d97a6af6-c169-401f-b9ab-4e314d680a80}" type="datetime3">
+            <a:fld id="{8ae7e35e-e16d-4576-94c0-e04b4d110eff}" type="datetime3">
               <a:rPr lang="en-GB" sz="1000" dirty="0">
                 <a:solidFill>
                   <a:srgbClr val="9AA3AE"/>
@@ -22406,7 +22424,7 @@
           <a:lstStyle/>
           <a:p>
             <a:pPr algn="ctr"/>
-            <a:fld id="{763bce3a-3db5-4258-ab62-c39887c16aea}" type="slidenum">
+            <a:fld id="{87861bc8-be9a-4c81-8a21-8bf6328ba936}" type="slidenum">
               <a:rPr lang="en-GB" sz="1200" b="1" dirty="0">
                 <a:solidFill>
                   <a:srgbClr val="FFFFFF"/>
@@ -23161,7 +23179,7 @@
           <a:lstStyle/>
           <a:p>
             <a:pPr algn="l"/>
-            <a:fld id="{7eb8c979-1550-403b-8a10-cb9e0e26f8eb}" type="datetime3">
+            <a:fld id="{13204ec2-ee1b-489e-896a-9b4cc96b7428}" type="datetime3">
               <a:rPr lang="en-GB" sz="1000" dirty="0">
                 <a:solidFill>
                   <a:srgbClr val="9AA3AE"/>
@@ -23195,7 +23213,7 @@
           <a:lstStyle/>
           <a:p>
             <a:pPr algn="ctr"/>
-            <a:fld id="{b46b826d-abcf-4272-a51c-646f5ecd8ca7}" type="slidenum">
+            <a:fld id="{b9d6b2ec-2735-401e-b886-4638b2472131}" type="slidenum">
               <a:rPr lang="en-GB" sz="1200" b="1" dirty="0">
                 <a:solidFill>
                   <a:srgbClr val="FFFFFF"/>
@@ -24004,7 +24022,7 @@
           <a:lstStyle/>
           <a:p>
             <a:pPr algn="l"/>
-            <a:fld id="{f0691323-10fc-4f5b-87eb-d5dae5551ed4}" type="datetime3">
+            <a:fld id="{a3bbff6e-1344-4b9c-9a77-f6a19aea3b29}" type="datetime3">
               <a:rPr lang="en-GB" sz="1000" dirty="0">
                 <a:solidFill>
                   <a:srgbClr val="9AA3AE"/>
@@ -24038,7 +24056,7 @@
           <a:lstStyle/>
           <a:p>
             <a:pPr algn="ctr"/>
-            <a:fld id="{addfa192-88ff-4118-9e9d-8f9c3b306b6c}" type="slidenum">
+            <a:fld id="{319f7a6c-9f71-4841-951f-dad096e313fb}" type="slidenum">
               <a:rPr lang="en-GB" sz="1200" b="1" dirty="0">
                 <a:solidFill>
                   <a:srgbClr val="FFFFFF"/>
@@ -24882,7 +24900,7 @@
           <a:lstStyle/>
           <a:p>
             <a:pPr algn="l"/>
-            <a:fld id="{43eef4b5-c581-459f-9e20-39875c2d394b}" type="datetime3">
+            <a:fld id="{8f20f1f2-bea4-4c65-a8a7-9be1dc71db9c}" type="datetime3">
               <a:rPr lang="en-GB" sz="1000" dirty="0">
                 <a:solidFill>
                   <a:srgbClr val="9AA3AE"/>
@@ -24916,7 +24934,7 @@
           <a:lstStyle/>
           <a:p>
             <a:pPr algn="ctr"/>
-            <a:fld id="{280a0534-87bf-4c54-b1fb-5c0087793c4d}" type="slidenum">
+            <a:fld id="{7e854e8e-ae93-425c-8af1-3ae78dde2f51}" type="slidenum">
               <a:rPr lang="en-GB" sz="1200" b="1" dirty="0">
                 <a:solidFill>
                   <a:srgbClr val="FFFFFF"/>
@@ -25602,7 +25620,7 @@
           <a:lstStyle/>
           <a:p>
             <a:pPr algn="l"/>
-            <a:fld id="{c68d867b-842b-47dd-9467-4fc2c735f78a}" type="datetime3">
+            <a:fld id="{24d44e44-41d5-4890-802c-1c0d5ee70455}" type="datetime3">
               <a:rPr lang="en-GB" sz="1000" dirty="0">
                 <a:solidFill>
                   <a:srgbClr val="9AA3AE"/>
@@ -25636,7 +25654,7 @@
           <a:lstStyle/>
           <a:p>
             <a:pPr algn="ctr"/>
-            <a:fld id="{10795d22-a825-4c38-91ee-2c2d51cfe6c4}" type="slidenum">
+            <a:fld id="{637a9b8e-9a95-48de-bf8b-293dd81a845e}" type="slidenum">
               <a:rPr lang="en-GB" sz="1200" b="1" dirty="0">
                 <a:solidFill>
                   <a:srgbClr val="FFFFFF"/>
@@ -26445,7 +26463,7 @@
           <a:lstStyle/>
           <a:p>
             <a:pPr algn="l"/>
-            <a:fld id="{dd8bed28-7843-4dec-a556-7ec4b3f1892a}" type="datetime3">
+            <a:fld id="{d0f58af1-fb50-44d3-91e3-1718154a66d5}" type="datetime3">
               <a:rPr lang="en-GB" sz="1000" dirty="0">
                 <a:solidFill>
                   <a:srgbClr val="9AA3AE"/>
@@ -26479,7 +26497,7 @@
           <a:lstStyle/>
           <a:p>
             <a:pPr algn="ctr"/>
-            <a:fld id="{c86ce468-cd05-4878-8151-f728b5bcd2bc}" type="slidenum">
+            <a:fld id="{9739bd2b-8084-4e55-8078-3180baba6750}" type="slidenum">
               <a:rPr lang="en-GB" sz="1200" b="1" dirty="0">
                 <a:solidFill>
                   <a:srgbClr val="FFFFFF"/>
@@ -26946,7 +26964,7 @@
           <a:lstStyle/>
           <a:p>
             <a:pPr algn="l"/>
-            <a:fld id="{58bbaa6c-ca9f-452d-8832-bc25a3ea8c58}" type="datetime3">
+            <a:fld id="{d7cd5aed-027e-49c0-9a8a-9607d70ff275}" type="datetime3">
               <a:rPr lang="en-GB" sz="1000" dirty="0">
                 <a:solidFill>
                   <a:srgbClr val="9AA3AE"/>
@@ -26980,7 +26998,7 @@
           <a:lstStyle/>
           <a:p>
             <a:pPr algn="ctr"/>
-            <a:fld id="{3862bf4c-9395-443e-b1d7-06bcbe257b48}" type="slidenum">
+            <a:fld id="{86400a96-0f23-4c67-96f1-052ea3d591d9}" type="slidenum">
               <a:rPr lang="en-GB" sz="1200" b="1" dirty="0">
                 <a:solidFill>
                   <a:srgbClr val="FFFFFF"/>
@@ -27447,7 +27465,7 @@
           <a:lstStyle/>
           <a:p>
             <a:pPr algn="l"/>
-            <a:fld id="{42127834-62e5-4053-b51f-1c64027f40f5}" type="datetime3">
+            <a:fld id="{71dc09de-9c00-4119-b05d-64b58418ff07}" type="datetime3">
               <a:rPr lang="en-GB" sz="1000" dirty="0">
                 <a:solidFill>
                   <a:srgbClr val="9AA3AE"/>
@@ -27481,7 +27499,7 @@
           <a:lstStyle/>
           <a:p>
             <a:pPr algn="ctr"/>
-            <a:fld id="{34b9de27-a998-464a-bc17-e7796d633a83}" type="slidenum">
+            <a:fld id="{900bef93-1106-4e85-9d71-610a5e86cf73}" type="slidenum">
               <a:rPr lang="en-GB" sz="1200" b="1" dirty="0">
                 <a:solidFill>
                   <a:srgbClr val="FFFFFF"/>
@@ -27913,7 +27931,7 @@
           <a:lstStyle/>
           <a:p>
             <a:pPr algn="l"/>
-            <a:fld id="{7e999e89-b92f-49fa-9b3c-a0d8688ec1ff}" type="datetime3">
+            <a:fld id="{5592e224-0cbd-4808-b3d2-d79578b5fc48}" type="datetime3">
               <a:rPr lang="en-GB" sz="1000" dirty="0">
                 <a:solidFill>
                   <a:srgbClr val="9AA3AE"/>
@@ -27947,7 +27965,7 @@
           <a:lstStyle/>
           <a:p>
             <a:pPr algn="ctr"/>
-            <a:fld id="{45d09752-a792-468f-903f-18155740c185}" type="slidenum">
+            <a:fld id="{05db1baf-ddcf-49aa-8373-4e106c833c21}" type="slidenum">
               <a:rPr lang="en-GB" sz="1200" b="1" dirty="0">
                 <a:solidFill>
                   <a:srgbClr val="FFFFFF"/>
@@ -28379,7 +28397,7 @@
           <a:lstStyle/>
           <a:p>
             <a:pPr algn="l"/>
-            <a:fld id="{da43f502-d964-4081-8b04-35951a6cf18c}" type="datetime3">
+            <a:fld id="{372d5901-2295-4bca-ade1-32613dde5d04}" type="datetime3">
               <a:rPr lang="en-GB" sz="1000" dirty="0">
                 <a:solidFill>
                   <a:srgbClr val="9AA3AE"/>
@@ -28413,7 +28431,7 @@
           <a:lstStyle/>
           <a:p>
             <a:pPr algn="ctr"/>
-            <a:fld id="{e6ab1be0-1611-4f34-b529-35b35f171ffb}" type="slidenum">
+            <a:fld id="{b99bc3cc-ee97-481e-914d-57fa2c1f680c}" type="slidenum">
               <a:rPr lang="en-GB" sz="1200" b="1" dirty="0">
                 <a:solidFill>
                   <a:srgbClr val="FFFFFF"/>
@@ -28628,7 +28646,7 @@
                 </a:solidFill>
                 <a:latin typeface="Calibri"/>
               </a:rPr>
-              <a:t>References (1/3) — multi-agent orchestration (journals and flagship proceedings)</a:t>
+              <a:t>References</a:t>
             </a:r>
           </a:p>
         </p:txBody>
@@ -28685,6 +28703,41 @@
         <p:spPr>
           <a:xfrm>
             <a:off x="365760" y="1051560"/>
+            <a:ext cx="11430000" cy="384048"/>
+          </a:xfrm>
+          <a:prstGeom prst="rect">
+            <a:avLst/>
+          </a:prstGeom>
+          <a:noFill/>
+        </p:spPr>
+        <p:txBody>
+          <a:bodyPr wrap="square">
+            <a:spAutoFit/>
+          </a:bodyPr>
+          <a:lstStyle/>
+          <a:p>
+            <a:pPr algn="l"/>
+            <a:r>
+              <a:rPr sz="1300" b="0">
+                <a:solidFill>
+                  <a:srgbClr val="5A5A5A"/>
+                </a:solidFill>
+                <a:latin typeface="Calibri"/>
+              </a:rPr>
+              <a:t>Numbered bibliography. Evidence 1–18 use the same numbers as citations [1]–[18]. A DOI is a link to https://doi.org/…. Papers without a Crossref DOI stay numbered and unlinked.</a:t>
+            </a:r>
+          </a:p>
+        </p:txBody>
+      </p:sp>
+      <p:sp>
+        <p:nvSpPr>
+          <p:cNvPr id="9" name="TextBox 8"/>
+          <p:cNvSpPr txBox="1"/>
+          <p:nvPr/>
+        </p:nvSpPr>
+        <p:spPr>
+          <a:xfrm>
+            <a:off x="365760" y="1572768"/>
             <a:ext cx="11430000" cy="4160520"/>
           </a:xfrm>
           <a:prstGeom prst="rect">
@@ -28712,7 +28765,7 @@
                 </a:solidFill>
                 <a:latin typeface="Calibri"/>
               </a:rPr>
-              <a:t>Wang, L., Ma, C., Feng, X., Zhang, Z., Yang, H., Zhang, J., Chen, Z., Tang, J., Chen, X., Lin, Y., Zhao, W. X., Wei, Z., and Wen, J. A survey on large language model based autonomous agents. Frontiers of Computer Science, 18, article 186345 (2024). doi:10.1007/s11704-024-40231-1.</a:t>
+              <a:t>[1] Wang, L., Ma, C., Feng, X., Zhang, Z., Yang, H., Zhang, J., Chen, Z., Tang, J., Chen, X., Lin, Y., Zhao, W. X., Wei, Z., and Wen, J. A survey on large language model based autonomous agents. Frontiers of Computer Science, 18, article 186345 (2024). doi:10.1007/s11704-024-40231-1.</a:t>
             </a:r>
           </a:p>
           <a:p>
@@ -28730,7 +28783,7 @@
                 </a:solidFill>
                 <a:latin typeface="Calibri"/>
               </a:rPr>
-              <a:t>He, J., Treude, C., and Lo, D. LLM-Based Multi-Agent Systems for Software Engineering: Literature Review, Vision, and the Road Ahead. ACM Transactions on Software Engineering and Methodology, 34(5), May 2025. doi:10.1145/3712003.</a:t>
+              <a:t>[2] He, J., Treude, C., and Lo, D. LLM-Based Multi-Agent Systems for Software Engineering: Literature Review, Vision, and the Road Ahead. ACM Transactions on Software Engineering and Methodology, 34(5), May 2025. doi:10.1145/3712003.</a:t>
             </a:r>
           </a:p>
           <a:p>
@@ -28748,7 +28801,7 @@
                 </a:solidFill>
                 <a:latin typeface="Calibri"/>
               </a:rPr>
-              <a:t>Guo, T., Chen, X., Wang, Y., Chang, R., Pei, S., Chawla, N. V., Wiest, O., and Zhang, X. Large Language Model based Multi-Agents: A Survey of Progress and Challenges. Proceedings of the Thirty-Third International Joint Conference on Artificial Intelligence (IJCAI-24), Survey Track, pages 8048–8057. doi:10.24963/ijcai.2024/890.</a:t>
+              <a:t>[3] Guo, T., Chen, X., Wang, Y., Chang, R., Pei, S., Chawla, N. V., Wiest, O., and Zhang, X. Large Language Model based Multi-Agents: A Survey of Progress and Challenges. Proceedings of the Thirty-Third International Joint Conference on Artificial Intelligence (IJCAI-24), Survey Track, pages 8048–8057. doi:10.24963/ijcai.2024/890.</a:t>
             </a:r>
           </a:p>
           <a:p>
@@ -28766,7 +28819,7 @@
                 </a:solidFill>
                 <a:latin typeface="Calibri"/>
               </a:rPr>
-              <a:t>Chang, E. Y., and Geng, L. SagaLLM: Context Management, Validation, and Transaction Guarantees for Multi-Agent LLM Planning. Proceedings of the VLDB Endowment (PVLDB), 18(12):4874–4886, 2025. doi:10.14778/3750601.3750611.</a:t>
+              <a:t>[4] Chang, E. Y., and Geng, L. SagaLLM: Context Management, Validation, and Transaction Guarantees for Multi-Agent LLM Planning. Proceedings of the VLDB Endowment (PVLDB), 18(12):4874–4886, 2025. doi:10.14778/3750601.3750611.</a:t>
             </a:r>
           </a:p>
           <a:p>
@@ -28784,7 +28837,7 @@
                 </a:solidFill>
                 <a:latin typeface="Calibri"/>
               </a:rPr>
-              <a:t>Wu, Q., Bansal, G., Zhang, J., Wu, Y., Li, B., Zhu, E., Jiang, L., Zhang, X., Zhang, S., Liu, J., Awadallah, A. H., White, R. W., Burger, D., and Wang, C. AutoGen: Enabling Next-Gen LLM Applications via Multi-Agent Conversations. Proceedings of the First Conference on Language Modeling (COLM 2024).</a:t>
+              <a:t>[5] Wu, Q., Bansal, G., Zhang, J., Wu, Y., Li, B., Zhu, E., Jiang, L., Zhang, X., Zhang, S., Liu, J., Awadallah, A. H., White, R. W., Burger, D., and Wang, C. AutoGen: Enabling Next-Gen LLM Applications via Multi-Agent Conversations. Proceedings of the First Conference on Language Modeling (COLM 2024).</a:t>
             </a:r>
           </a:p>
           <a:p>
@@ -28802,7 +28855,7 @@
                 </a:solidFill>
                 <a:latin typeface="Calibri"/>
               </a:rPr>
-              <a:t>Hong, S., Zhuge, M., Chen, J., Zheng, X., Cheng, Y., Wang, J., Zhang, C., Wang, Z., Yau, S. K. S., Lin, Z., Zhou, L., Ran, C., Xiao, L., Wu, C., and Schmidhuber, J. MetaGPT: Meta Programming for A Multi-Agent Collaborative Framework. Proceedings of the Twelfth International Conference on Learning Representations (ICLR 2024).</a:t>
+              <a:t>[6] Hong, S., Zhuge, M., Chen, J., Zheng, X., Cheng, Y., Wang, J., Zhang, C., Wang, Z., Yau, S. K. S., Lin, Z., Zhou, L., Ran, C., Xiao, L., Wu, C., and Schmidhuber, J. MetaGPT: Meta Programming for A Multi-Agent Collaborative Framework. Proceedings of the Twelfth International Conference on Learning Representations (ICLR 2024).</a:t>
             </a:r>
           </a:p>
           <a:p>
@@ -28820,7 +28873,7 @@
                 </a:solidFill>
                 <a:latin typeface="Calibri"/>
               </a:rPr>
-              <a:t>Li, G., Hammoud, H. A. A. K., Itani, H., Khizbullin, D., and Ghanem, B. CAMEL: Communicative Agents for “Mind” Exploration of Large Language Model Society. Advances in Neural Information Processing Systems 36 (NeurIPS 2023).</a:t>
+              <a:t>[7] Qian, C., Liu, W., Liu, H., Chen, N., Dang, Y., Li, J., Yang, C., Chen, W., Su, Y., Cong, X., Xu, J., Li, D., Liu, Z., and Sun, M. ChatDev: Communicative Agents for Software Development. Proceedings of the 62nd Annual Meeting of the Association for Computational Linguistics (Volume 1: Long Papers), pages 15174–15186. doi:10.18653/v1/2024.acl-long.810.</a:t>
             </a:r>
           </a:p>
           <a:p>
@@ -28838,7 +28891,42 @@
                 </a:solidFill>
                 <a:latin typeface="Calibri"/>
               </a:rPr>
-              <a:t>Qian, C., Liu, W., Liu, H., Chen, N., Dang, Y., Li, J., Yang, C., Chen, W., Su, Y., Cong, X., Xu, J., Li, D., Liu, Z., and Sun, M. ChatDev: Communicative Agents for Software Development. Proceedings of the 62nd Annual Meeting of the Association for Computational Linguistics (Volume 1: Long Papers), pages 15174–15186. doi:10.18653/v1/2024.acl-long.810.</a:t>
+              <a:t>[8] Li, G., Hammoud, H. A. A. K., Itani, H., Khizbullin, D., and Ghanem, B. CAMEL: Communicative Agents for “Mind” Exploration of Large Language Model Society. Advances in Neural Information Processing Systems 36 (NeurIPS 2023).</a:t>
+            </a:r>
+          </a:p>
+        </p:txBody>
+      </p:sp>
+      <p:sp>
+        <p:nvSpPr>
+          <p:cNvPr id="10" name="TextBox 9"/>
+          <p:cNvSpPr txBox="1"/>
+          <p:nvPr/>
+        </p:nvSpPr>
+        <p:spPr>
+          <a:xfrm>
+            <a:off x="365760" y="6144768"/>
+            <a:ext cx="11430000" cy="256032"/>
+          </a:xfrm>
+          <a:prstGeom prst="rect">
+            <a:avLst/>
+          </a:prstGeom>
+          <a:noFill/>
+        </p:spPr>
+        <p:txBody>
+          <a:bodyPr wrap="square">
+            <a:spAutoFit/>
+          </a:bodyPr>
+          <a:lstStyle/>
+          <a:p>
+            <a:pPr algn="l"/>
+            <a:r>
+              <a:rPr sz="1000" b="0">
+                <a:solidFill>
+                  <a:srgbClr val="5A5A5A"/>
+                </a:solidFill>
+                <a:latin typeface="Calibri"/>
+              </a:rPr>
+              <a:t>Contents item 11. CrewAI is an engineering framework without a flagship peer-reviewed paper in this list.</a:t>
             </a:r>
           </a:p>
         </p:txBody>
@@ -28864,7 +28952,7 @@
           <a:lstStyle/>
           <a:p>
             <a:pPr algn="l"/>
-            <a:fld id="{213fdf83-91e9-4453-824d-e121d5225863}" type="datetime3">
+            <a:fld id="{9b413a79-2a85-47b7-85a4-1e5e0787af6d}" type="datetime3">
               <a:rPr lang="en-GB" sz="1000" dirty="0">
                 <a:solidFill>
                   <a:srgbClr val="9AA3AE"/>
@@ -28898,7 +28986,7 @@
           <a:lstStyle/>
           <a:p>
             <a:pPr algn="ctr"/>
-            <a:fld id="{9e195598-bad0-4b8c-b9e8-d0e570250b67}" type="slidenum">
+            <a:fld id="{7270f86b-1c08-4d4d-bc67-e6d47def8ca1}" type="slidenum">
               <a:rPr lang="en-GB" sz="1200" b="1" dirty="0">
                 <a:solidFill>
                   <a:srgbClr val="FFFFFF"/>
@@ -29113,7 +29201,7 @@
                 </a:solidFill>
                 <a:latin typeface="Calibri"/>
               </a:rPr>
-              <a:t>References (2/3) — tools, routing, compression, reasoning</a:t>
+              <a:t>References — [9]–[16]</a:t>
             </a:r>
           </a:p>
         </p:txBody>
@@ -29170,6 +29258,41 @@
         <p:spPr>
           <a:xfrm>
             <a:off x="365760" y="1051560"/>
+            <a:ext cx="11430000" cy="384048"/>
+          </a:xfrm>
+          <a:prstGeom prst="rect">
+            <a:avLst/>
+          </a:prstGeom>
+          <a:noFill/>
+        </p:spPr>
+        <p:txBody>
+          <a:bodyPr wrap="square">
+            <a:spAutoFit/>
+          </a:bodyPr>
+          <a:lstStyle/>
+          <a:p>
+            <a:pPr algn="l"/>
+            <a:r>
+              <a:rPr sz="1300" b="0">
+                <a:solidFill>
+                  <a:srgbClr val="5A5A5A"/>
+                </a:solidFill>
+                <a:latin typeface="Calibri"/>
+              </a:rPr>
+              <a:t>Continuation. Citations [9]–[16]. Click a DOI to open the publisher record.</a:t>
+            </a:r>
+          </a:p>
+        </p:txBody>
+      </p:sp>
+      <p:sp>
+        <p:nvSpPr>
+          <p:cNvPr id="9" name="TextBox 8"/>
+          <p:cNvSpPr txBox="1"/>
+          <p:nvPr/>
+        </p:nvSpPr>
+        <p:spPr>
+          <a:xfrm>
+            <a:off x="365760" y="1572768"/>
             <a:ext cx="11430000" cy="4160520"/>
           </a:xfrm>
           <a:prstGeom prst="rect">
@@ -29197,7 +29320,7 @@
                 </a:solidFill>
                 <a:latin typeface="Calibri"/>
               </a:rPr>
-              <a:t>Qin, Y., Liang, S., Ye, Y., Zhu, K., Yan, L., Lu, Y., Lin, Y., Cong, X., Tang, X., Qian, B., Zhao, S., Hong, L., Tian, R., Xie, R., Zhou, J., Gerstein, M., Li, D., Liu, Z., and Sun, M. ToolLLM: Facilitating Large Language Models to Master 16000+ Real-world APIs. Proceedings of the Twelfth International Conference on Learning Representations (ICLR 2024).</a:t>
+              <a:t>[9] Qin, Y., Liang, S., Ye, Y., Zhu, K., Yan, L., Lu, Y., Lin, Y., Cong, X., Tang, X., Qian, B., Zhao, S., Hong, L., Tian, R., Xie, R., Zhou, J., Gerstein, M., Li, D., Liu, Z., and Sun, M. ToolLLM: Facilitating Large Language Models to Master 16000+ Real-world APIs. Proceedings of the Twelfth International Conference on Learning Representations (ICLR 2024).</a:t>
             </a:r>
           </a:p>
           <a:p>
@@ -29215,7 +29338,7 @@
                 </a:solidFill>
                 <a:latin typeface="Calibri"/>
               </a:rPr>
-              <a:t>Zheng, Y., Li, P., Liu, W., Liu, Y., Luan, J., and Wang, B. ToolRerank: Adaptive and Hierarchy-Aware Reranking for Tool Retrieval. Proceedings of the 2024 Joint International Conference on Computational Linguistics, Language Resources and Evaluation (LREC-COLING 2024), pages 16263–16273. ACL Anthology 2024.lrec-main.1413.</a:t>
+              <a:t>[10] Zheng, Y., Li, P., Liu, W., Liu, Y., Luan, J., and Wang, B. ToolRerank: Adaptive and Hierarchy-Aware Reranking for Tool Retrieval. Proceedings of the 2024 Joint International Conference on Computational Linguistics, Language Resources and Evaluation (LREC-COLING 2024), pages 16263–16273. ACL Anthology 2024.lrec-main.1413.</a:t>
             </a:r>
           </a:p>
           <a:p>
@@ -29233,7 +29356,7 @@
                 </a:solidFill>
                 <a:latin typeface="Calibri"/>
               </a:rPr>
-              <a:t>Ong, I., Almahairi, A., Wu, V., Chiang, W.-L., Wu, T., Gonzalez, J. E., Kadous, M. W., and Stoica, I. RouteLLM: Learning to Route LLMs from Preference Data. Proceedings of the Thirteenth International Conference on Learning Representations (ICLR 2025).</a:t>
+              <a:t>[11] Ong, I., Almahairi, A., Wu, V., Chiang, W.-L., Wu, T., Gonzalez, J. E., Kadous, M. W., and Stoica, I. RouteLLM: Learning to Route LLMs from Preference Data. Proceedings of the Thirteenth International Conference on Learning Representations (ICLR 2025).</a:t>
             </a:r>
           </a:p>
           <a:p>
@@ -29251,7 +29374,7 @@
                 </a:solidFill>
                 <a:latin typeface="Calibri"/>
               </a:rPr>
-              <a:t>Panda, P., Magazine, R., Devaguptapu, C., Takemori, S., and Sharma, V. Adaptive LLM Routing under Budget Constraints. Findings of the Association for Computational Linguistics: EMNLP 2025, pages 23934–23949. doi:10.18653/v1/2025.findings-emnlp.1301.</a:t>
+              <a:t>[12] Yue, Y., Zhang, G., Liu, B., Wan, G., Wang, K., Cheng, D., and Qi, Y. MasRouter: Learning to Route LLMs for Multi-Agent Systems. Proceedings of the 63rd Annual Meeting of the Association for Computational Linguistics (Volume 1: Long Papers), pages 15549–15572. doi:10.18653/v1/2025.acl-long.757.</a:t>
             </a:r>
           </a:p>
           <a:p>
@@ -29269,7 +29392,7 @@
                 </a:solidFill>
                 <a:latin typeface="Calibri"/>
               </a:rPr>
-              <a:t>Yue, Y., Zhang, G., Liu, B., Wan, G., Wang, K., Cheng, D., and Qi, Y. MasRouter: Learning to Route LLMs for Multi-Agent Systems. Proceedings of the 63rd Annual Meeting of the Association for Computational Linguistics (Volume 1: Long Papers), pages 15549–15572. doi:10.18653/v1/2025.acl-long.757.</a:t>
+              <a:t>[13] Panda, P., Magazine, R., Devaguptapu, C., Takemori, S., and Sharma, V. Adaptive LLM Routing under Budget Constraints. Findings of the Association for Computational Linguistics: EMNLP 2025, pages 23934–23949. doi:10.18653/v1/2025.findings-emnlp.1301. Method name: PILOT (Preference-prior Informed LinUCB).</a:t>
             </a:r>
           </a:p>
           <a:p>
@@ -29287,7 +29410,7 @@
                 </a:solidFill>
                 <a:latin typeface="Calibri"/>
               </a:rPr>
-              <a:t>Jiang, H., Wu, Q., Lin, C.-Y., Yang, Y., and Qiu, L. LLMLingua: Compressing Prompts for Accelerated Inference of Large Language Models. Proceedings of the 2023 Conference on Empirical Methods in Natural Language Processing, pages 13358–13376. doi:10.18653/v1/2023.emnlp-main.825.</a:t>
+              <a:t>[14] Jiang, H., Wu, Q., Lin, C.-Y., Yang, Y., and Qiu, L. LLMLingua: Compressing Prompts for Accelerated Inference of Large Language Models. Proceedings of the 2023 Conference on Empirical Methods in Natural Language Processing, pages 13358–13376. doi:10.18653/v1/2023.emnlp-main.825.</a:t>
             </a:r>
           </a:p>
           <a:p>
@@ -29305,7 +29428,7 @@
                 </a:solidFill>
                 <a:latin typeface="Calibri"/>
               </a:rPr>
-              <a:t>Wei, J., Wang, X., Schuurmans, D., Bosma, M., Ichter, B., Xia, F., Chi, E., Le, Q., and Zhou, D. Chain-of-Thought Prompting Elicits Reasoning in Large Language Models. Advances in Neural Information Processing Systems 35 (NeurIPS 2022).</a:t>
+              <a:t>[15] Park, J. S., O’Brien, J. C., Cai, C. J., Morris, M. R., Liang, P., and Bernstein, M. S. Generative Agents: Interactive Simulacra of Human Behavior. Proceedings of the 36th Annual ACM Symposium on User Interface Software and Technology (UIST 2023), Best Paper. doi:10.1145/3586183.3606763.</a:t>
             </a:r>
           </a:p>
           <a:p>
@@ -29323,7 +29446,7 @@
                 </a:solidFill>
                 <a:latin typeface="Calibri"/>
               </a:rPr>
-              <a:t>Yao, S., Zhao, J., Yu, D., Du, N., Shafran, I., Narasimhan, K., and Cao, Y. ReAct: Synergizing Reasoning and Acting in Language Models. Proceedings of the Eleventh International Conference on Learning Representations (ICLR 2023).</a:t>
+              <a:t>[16] Tero, A., Takagi, S., Saigusa, T., Ito, K., Bebber, D. P., Fricker, M. D., Yumiki, K., Kobayashi, R., and Nakagaki, T. Rules for Biologically Inspired Adaptive Network Design. Science 327(5964):439–442. doi:10.1126/science.1177894.</a:t>
             </a:r>
           </a:p>
         </p:txBody>
@@ -29349,7 +29472,7 @@
           <a:lstStyle/>
           <a:p>
             <a:pPr algn="l"/>
-            <a:fld id="{7e8a1db6-538c-4746-a8f0-3613d703205a}" type="datetime3">
+            <a:fld id="{abddabb5-5ce3-4739-8483-ab7aa8478cfc}" type="datetime3">
               <a:rPr lang="en-GB" sz="1000" dirty="0">
                 <a:solidFill>
                   <a:srgbClr val="9AA3AE"/>
@@ -29383,7 +29506,7 @@
           <a:lstStyle/>
           <a:p>
             <a:pPr algn="ctr"/>
-            <a:fld id="{a778664c-4e2f-4304-a1d1-1b41ca886a29}" type="slidenum">
+            <a:fld id="{0012a6c7-475a-4374-9193-5c92fd15ba7d}" type="slidenum">
               <a:rPr lang="en-GB" sz="1200" b="1" dirty="0">
                 <a:solidFill>
                   <a:srgbClr val="FFFFFF"/>
@@ -29598,7 +29721,7 @@
                 </a:solidFill>
                 <a:latin typeface="Calibri"/>
               </a:rPr>
-              <a:t>References (3/3) — memory, biology, Indian agricultural data</a:t>
+              <a:t>References — [17]–[24]</a:t>
             </a:r>
           </a:p>
         </p:txBody>
@@ -29655,6 +29778,41 @@
         <p:spPr>
           <a:xfrm>
             <a:off x="365760" y="1051560"/>
+            <a:ext cx="11430000" cy="384048"/>
+          </a:xfrm>
+          <a:prstGeom prst="rect">
+            <a:avLst/>
+          </a:prstGeom>
+          <a:noFill/>
+        </p:spPr>
+        <p:txBody>
+          <a:bodyPr wrap="square">
+            <a:spAutoFit/>
+          </a:bodyPr>
+          <a:lstStyle/>
+          <a:p>
+            <a:pPr algn="l"/>
+            <a:r>
+              <a:rPr sz="1300" b="0">
+                <a:solidFill>
+                  <a:srgbClr val="5A5A5A"/>
+                </a:solidFill>
+                <a:latin typeface="Calibri"/>
+              </a:rPr>
+              <a:t>Continuation. Citations [17]–[24]. Click a DOI to open the publisher record.</a:t>
+            </a:r>
+          </a:p>
+        </p:txBody>
+      </p:sp>
+      <p:sp>
+        <p:nvSpPr>
+          <p:cNvPr id="9" name="TextBox 8"/>
+          <p:cNvSpPr txBox="1"/>
+          <p:nvPr/>
+        </p:nvSpPr>
+        <p:spPr>
+          <a:xfrm>
+            <a:off x="365760" y="1572768"/>
             <a:ext cx="11430000" cy="4160520"/>
           </a:xfrm>
           <a:prstGeom prst="rect">
@@ -29682,7 +29840,7 @@
                 </a:solidFill>
                 <a:latin typeface="Calibri"/>
               </a:rPr>
-              <a:t>Yao, S., Yu, D., Zhao, J., Shafran, I., Griffiths, T. L., Cao, Y., and Narasimhan, K. Tree of Thoughts: Deliberate Problem Solving with Large Language Models. Advances in Neural Information Processing Systems 36 (NeurIPS 2023).</a:t>
+              <a:t>[17] Guo, H., Woodruff, A., and Yadav, A. Improving Lives of Indebted Farmers Using Deep Learning: Predicting Agricultural Produce Prices Using Convolutional Neural Networks (PECAD). Proceedings of the AAAI Conference on Artificial Intelligence, 34(08):13294–13299. doi:10.1609/aaai.v34i08.7039.</a:t>
             </a:r>
           </a:p>
           <a:p>
@@ -29700,7 +29858,7 @@
                 </a:solidFill>
                 <a:latin typeface="Calibri"/>
               </a:rPr>
-              <a:t>Park, J. S., O’Brien, J. C., Cai, C. J., Morris, M. R., Liang, P., and Bernstein, M. S. Generative Agents: Interactive Simulacra of Human Behavior. Proceedings of the 36th Annual ACM Symposium on User Interface Software and Technology (UIST 2023), Best Paper. doi:10.1145/3586183.3606763.</a:t>
+              <a:t>[18] Yao, S., Zhao, J., Yu, D., Du, N., Shafran, I., Narasimhan, K., and Cao, Y. ReAct: Synergizing Reasoning and Acting in Language Models. Proceedings of the Eleventh International Conference on Learning Representations (ICLR 2023).</a:t>
             </a:r>
           </a:p>
           <a:p>
@@ -29718,7 +29876,7 @@
                 </a:solidFill>
                 <a:latin typeface="Calibri"/>
               </a:rPr>
-              <a:t>Tero, A., Takagi, S., Saigusa, T., Ito, K., Bebber, D. P., Fricker, M. D., Yumiki, K., Kobayashi, R., and Nakagaki, T. Rules for Biologically Inspired Adaptive Network Design. Science 327(5964):439–442, 2010. doi:10.1126/science.1177894.</a:t>
+              <a:t>[19] Wei, J., Wang, X., Schuurmans, D., Bosma, M., Ichter, B., Xia, F., Chi, E., Le, Q., and Zhou, D. Chain-of-Thought Prompting Elicits Reasoning in Large Language Models. Advances in Neural Information Processing Systems 35 (NeurIPS 2022).</a:t>
             </a:r>
           </a:p>
           <a:p>
@@ -29736,7 +29894,7 @@
                 </a:solidFill>
                 <a:latin typeface="Calibri"/>
               </a:rPr>
-              <a:t>Shinn, N., Cassano, F., Gopinath, A., Narasimhan, K., and Yao, S. Reflexion: Language Agents with Verbal Reinforcement Learning. Advances in Neural Information Processing Systems 36 (NeurIPS 2023).</a:t>
+              <a:t>[20] Yao, S., Yu, D., Zhao, J., Shafran, I., Griffiths, T. L., Cao, Y., and Narasimhan, K. Tree of Thoughts: Deliberate Problem Solving with Large Language Models. Advances in Neural Information Processing Systems 36 (NeurIPS 2023).</a:t>
             </a:r>
           </a:p>
           <a:p>
@@ -29754,7 +29912,7 @@
                 </a:solidFill>
                 <a:latin typeface="Calibri"/>
               </a:rPr>
-              <a:t>Shen, Y., Song, K., Tan, X., Li, D., Lu, W., and Zhuang, Y. HuggingGPT: Solving AI Tasks with ChatGPT and its Friends in Hugging Face. Advances in Neural Information Processing Systems 36 (NeurIPS 2023).</a:t>
+              <a:t>[21] Shinn, N., Cassano, F., Gopinath, A., Narasimhan, K., and Yao, S. Reflexion: Language Agents with Verbal Reinforcement Learning. Advances in Neural Information Processing Systems 36 (NeurIPS 2023).</a:t>
             </a:r>
           </a:p>
           <a:p>
@@ -29772,7 +29930,7 @@
                 </a:solidFill>
                 <a:latin typeface="Calibri"/>
               </a:rPr>
-              <a:t>Schick, T., Dwivedi-Yu, J., Dessì, R., Raileanu, R., Lomeli, M., Hambro, E., Zettlemoyer, L., Cancedda, N., and Scialom, T. Toolformer: Language Models Can Teach Themselves to Use Tools. Advances in Neural Information Processing Systems 36 (NeurIPS 2023).</a:t>
+              <a:t>[22] Shen, Y., Song, K., Tan, X., Li, D., Lu, W., and Zhuang, Y. HuggingGPT: Solving AI Tasks with ChatGPT and its Friends in Hugging Face. Advances in Neural Information Processing Systems 36 (NeurIPS 2023).</a:t>
             </a:r>
           </a:p>
           <a:p>
@@ -29790,7 +29948,7 @@
                 </a:solidFill>
                 <a:latin typeface="Calibri"/>
               </a:rPr>
-              <a:t>Guo, H., Woodruff, A., and Yadav, A. Improving Lives of Indebted Farmers Using Deep Learning: Predicting Agricultural Produce Prices Using Convolutional Neural Networks (PECAD). Proceedings of the AAAI Conference on Artificial Intelligence, 34(08):13294–13299. doi:10.1609/aaai.v34i08.7039. AGMARKNET scrape for price prediction; cited here as Indian OGD precedent, not as a baseline this proposal claims to beat.</a:t>
+              <a:t>[23] Schick, T., Dwivedi-Yu, J., Dessì, R., Raileanu, R., Lomeli, M., Hambro, E., Zettlemoyer, L., Cancedda, N., and Scialom, T. Toolformer: Language Models Can Teach Themselves to Use Tools. Advances in Neural Information Processing Systems 36 (NeurIPS 2023).</a:t>
             </a:r>
           </a:p>
           <a:p>
@@ -29808,42 +29966,7 @@
                 </a:solidFill>
                 <a:latin typeface="Calibri"/>
               </a:rPr>
-              <a:t>Government of India. Open Government Data Platform India (data.gov.in); AGMARKNET resource 9ef84268-d588-465a-a308-a864a43d0070; Directorate of Economics and Statistics crop production; IMD rainfall series; Government Open Data License — India (GODL-India).</a:t>
-            </a:r>
-          </a:p>
-        </p:txBody>
-      </p:sp>
-      <p:sp>
-        <p:nvSpPr>
-          <p:cNvPr id="9" name="TextBox 8"/>
-          <p:cNvSpPr txBox="1"/>
-          <p:nvPr/>
-        </p:nvSpPr>
-        <p:spPr>
-          <a:xfrm>
-            <a:off x="365760" y="6144768"/>
-            <a:ext cx="11430000" cy="256032"/>
-          </a:xfrm>
-          <a:prstGeom prst="rect">
-            <a:avLst/>
-          </a:prstGeom>
-          <a:noFill/>
-        </p:spPr>
-        <p:txBody>
-          <a:bodyPr wrap="square">
-            <a:spAutoFit/>
-          </a:bodyPr>
-          <a:lstStyle/>
-          <a:p>
-            <a:pPr algn="l"/>
-            <a:r>
-              <a:rPr sz="1000" b="0">
-                <a:solidFill>
-                  <a:srgbClr val="5A5A5A"/>
-                </a:solidFill>
-                <a:latin typeface="Calibri"/>
-              </a:rPr>
-              <a:t>CrewAI is an engineering framework without a flagship peer-reviewed paper in this list; AutoGen and MetaGPT are the MAS citations.</a:t>
+              <a:t>[24] Government of India Open Government Data Platform India. data.gov.in; AGMARKNET resource 9ef84268-d588-465a-a308-a864a43d0070; Directorate of Economics and Statistics crop production; IMD rainfall series; Government Open Data License — India (GODL-India). Live execution corpus, not a journal article.</a:t>
             </a:r>
           </a:p>
         </p:txBody>
@@ -29869,7 +29992,7 @@
           <a:lstStyle/>
           <a:p>
             <a:pPr algn="l"/>
-            <a:fld id="{436f79fe-72ab-4076-817d-a358770bc661}" type="datetime3">
+            <a:fld id="{9457d634-7bd3-4fd1-a6ec-664f277c13cc}" type="datetime3">
               <a:rPr lang="en-GB" sz="1000" dirty="0">
                 <a:solidFill>
                   <a:srgbClr val="9AA3AE"/>
@@ -29903,7 +30026,7 @@
           <a:lstStyle/>
           <a:p>
             <a:pPr algn="ctr"/>
-            <a:fld id="{f2eb8670-49d6-40ee-9fea-f1fd65e0a18c}" type="slidenum">
+            <a:fld id="{2d489fd4-c02a-48dd-a675-ca253cbfc81b}" type="slidenum">
               <a:rPr lang="en-GB" sz="1200" b="1" dirty="0">
                 <a:solidFill>
                   <a:srgbClr val="FFFFFF"/>
@@ -30353,7 +30476,7 @@
           <a:lstStyle/>
           <a:p>
             <a:pPr algn="l"/>
-            <a:fld id="{634aae4a-53cc-485b-bb21-2b1de8a83c43}" type="datetime3">
+            <a:fld id="{864c5944-a5c2-41fd-9f33-23d6f093e7e0}" type="datetime3">
               <a:rPr lang="en-GB" sz="1000" dirty="0">
                 <a:solidFill>
                   <a:srgbClr val="9AA3AE"/>
@@ -30387,7 +30510,7 @@
           <a:lstStyle/>
           <a:p>
             <a:pPr algn="ctr"/>
-            <a:fld id="{38f2bb69-bd8f-403a-8f0e-8f1fa088ecb3}" type="slidenum">
+            <a:fld id="{3db4d9ae-f9fd-4599-92ff-4ef579b73fe0}" type="slidenum">
               <a:rPr lang="en-GB" sz="1200" b="1" dirty="0">
                 <a:solidFill>
                   <a:srgbClr val="FFFFFF"/>
@@ -30854,7 +30977,7 @@
           <a:lstStyle/>
           <a:p>
             <a:pPr algn="l"/>
-            <a:fld id="{27274a5d-ec3b-4cbb-a5ff-ef873ac0f039}" type="datetime3">
+            <a:fld id="{0278330f-ab27-41a4-9150-024c821febc5}" type="datetime3">
               <a:rPr lang="en-GB" sz="1000" dirty="0">
                 <a:solidFill>
                   <a:srgbClr val="9AA3AE"/>
@@ -30888,7 +31011,7 @@
           <a:lstStyle/>
           <a:p>
             <a:pPr algn="ctr"/>
-            <a:fld id="{b8371c9e-8313-40c1-8185-ca56d26f56a0}" type="slidenum">
+            <a:fld id="{baca6da4-8281-4431-a397-72420e0d3cf8}" type="slidenum">
               <a:rPr lang="en-GB" sz="1200" b="1" dirty="0">
                 <a:solidFill>
                   <a:srgbClr val="FFFFFF"/>
@@ -31181,7 +31304,7 @@
                 </a:solidFill>
                 <a:latin typeface="Calibri"/>
               </a:rPr>
-              <a:t>FET template. Each paper is one Evidence block: Author(s), Year, Title, Publication, Objective, Methodology, Findings, Limitations, To solve the research gap. Publication is the journal or the full international conference proceedings title — not a preprint report.</a:t>
+              <a:t>FET template. Each paper is Evidence n and citation [n]. Fields: Author(s), Year, Title, Publication, DOI (linked at https://doi.org/…), Objective, Methodology, Findings, Limitations, To solve the research gap.</a:t>
             </a:r>
           </a:p>
         </p:txBody>
@@ -31815,7 +31938,7 @@
           <a:lstStyle/>
           <a:p>
             <a:pPr algn="l"/>
-            <a:fld id="{f3ab26a6-3f37-4d58-8133-c822b45bab1d}" type="datetime3">
+            <a:fld id="{b554e629-8511-45ff-aea0-64e53412a523}" type="datetime3">
               <a:rPr lang="en-GB" sz="1000" dirty="0">
                 <a:solidFill>
                   <a:srgbClr val="9AA3AE"/>
@@ -31849,7 +31972,7 @@
           <a:lstStyle/>
           <a:p>
             <a:pPr algn="ctr"/>
-            <a:fld id="{7454e94f-fa10-48e4-8320-07632ecf9a71}" type="slidenum">
+            <a:fld id="{9c5a3f78-cb95-459f-9713-37d0fa256a89}" type="slidenum">
               <a:rPr lang="en-GB" sz="1200" b="1" dirty="0">
                 <a:solidFill>
                   <a:srgbClr val="FFFFFF"/>
@@ -32776,7 +32899,7 @@
           <a:lstStyle/>
           <a:p>
             <a:pPr algn="l"/>
-            <a:fld id="{20b66ea6-b922-4173-bb50-9bdf3c601f4d}" type="datetime3">
+            <a:fld id="{cb87eb55-61c4-4790-afba-be5251c9fa23}" type="datetime3">
               <a:rPr lang="en-GB" sz="1000" dirty="0">
                 <a:solidFill>
                   <a:srgbClr val="9AA3AE"/>
@@ -32810,7 +32933,7 @@
           <a:lstStyle/>
           <a:p>
             <a:pPr algn="ctr"/>
-            <a:fld id="{702f82c1-f4e2-415f-9f1f-c4bd7cd13a02}" type="slidenum">
+            <a:fld id="{7291de2e-0fc0-4cdb-9f29-52150cc16ff1}" type="slidenum">
               <a:rPr lang="en-GB" sz="1200" b="1" dirty="0">
                 <a:solidFill>
                   <a:srgbClr val="FFFFFF"/>
@@ -33737,7 +33860,7 @@
           <a:lstStyle/>
           <a:p>
             <a:pPr algn="l"/>
-            <a:fld id="{3a63f844-f669-42ec-a906-42d6f173762e}" type="datetime3">
+            <a:fld id="{324b3a64-7e38-4bd4-961a-fb05b16b0ba3}" type="datetime3">
               <a:rPr lang="en-GB" sz="1000" dirty="0">
                 <a:solidFill>
                   <a:srgbClr val="9AA3AE"/>
@@ -33771,7 +33894,7 @@
           <a:lstStyle/>
           <a:p>
             <a:pPr algn="ctr"/>
-            <a:fld id="{fbdc83b9-9779-4c62-b688-49aa9efd83aa}" type="slidenum">
+            <a:fld id="{03624ba8-4215-4f5c-a50e-9a5454bb7129}" type="slidenum">
               <a:rPr lang="en-GB" sz="1200" b="1" dirty="0">
                 <a:solidFill>
                   <a:srgbClr val="FFFFFF"/>
@@ -34698,7 +34821,7 @@
           <a:lstStyle/>
           <a:p>
             <a:pPr algn="l"/>
-            <a:fld id="{7284679d-3c1c-4f46-a899-eac1bed4c9ee}" type="datetime3">
+            <a:fld id="{b8d9af0e-6795-4d62-a15d-04cbfcf47c43}" type="datetime3">
               <a:rPr lang="en-GB" sz="1000" dirty="0">
                 <a:solidFill>
                   <a:srgbClr val="9AA3AE"/>
@@ -34732,7 +34855,7 @@
           <a:lstStyle/>
           <a:p>
             <a:pPr algn="ctr"/>
-            <a:fld id="{ffc3683d-054f-430c-bc4a-3a55c2db559e}" type="slidenum">
+            <a:fld id="{766d859c-fb2c-4347-8b19-cd3f26a2893d}" type="slidenum">
               <a:rPr lang="en-GB" sz="1200" b="1" dirty="0">
                 <a:solidFill>
                   <a:srgbClr val="FFFFFF"/>

</xml_diff>

<commit_message>
Link every numbered reference to an official URL.
DOI papers keep https://doi.org/…; ICLR/NeurIPS/ACL/COLM/data.gov.in
entries now use their proceedings or portal landing pages.
</commit_message>
<xml_diff>
--- a/ACRS_PhD_Proposal_JenishaT_24ETRP720001.pptx
+++ b/ACRS_PhD_Proposal_JenishaT_24ETRP720001.pptx
@@ -3835,7 +3835,7 @@
           <a:lstStyle/>
           <a:p>
             <a:pPr algn="l"/>
-            <a:fld id="{654358f5-caf0-4de5-b717-88ffe6f87151}" type="datetime3">
+            <a:fld id="{07588079-6005-431f-9a8e-7bc56823444c}" type="datetime3">
               <a:rPr lang="en-GB" sz="1000" dirty="0">
                 <a:solidFill>
                   <a:srgbClr val="9AA3AE"/>
@@ -3869,7 +3869,7 @@
           <a:lstStyle/>
           <a:p>
             <a:pPr algn="ctr"/>
-            <a:fld id="{842b063f-fb15-41c6-9987-3afaf94517f3}" type="slidenum">
+            <a:fld id="{71b53968-04a8-491b-9ba6-e6c9490c64f9}" type="slidenum">
               <a:rPr lang="en-GB" sz="1200" b="1" dirty="0">
                 <a:solidFill>
                   <a:srgbClr val="FFFFFF"/>
@@ -4796,7 +4796,7 @@
           <a:lstStyle/>
           <a:p>
             <a:pPr algn="l"/>
-            <a:fld id="{efce820b-539a-45fb-b9b8-dc9d778614c7}" type="datetime3">
+            <a:fld id="{cb776610-fbdf-411d-81ad-c6d7a7000877}" type="datetime3">
               <a:rPr lang="en-GB" sz="1000" dirty="0">
                 <a:solidFill>
                   <a:srgbClr val="9AA3AE"/>
@@ -4830,7 +4830,7 @@
           <a:lstStyle/>
           <a:p>
             <a:pPr algn="ctr"/>
-            <a:fld id="{c060fcbc-7b94-412d-8c6b-aef9ace5044a}" type="slidenum">
+            <a:fld id="{b0b9a404-fad0-46ee-ad80-535535bb4436}" type="slidenum">
               <a:rPr lang="en-GB" sz="1200" b="1" dirty="0">
                 <a:solidFill>
                   <a:srgbClr val="FFFFFF"/>
@@ -5757,7 +5757,7 @@
           <a:lstStyle/>
           <a:p>
             <a:pPr algn="l"/>
-            <a:fld id="{aab8fbd1-bfde-47c9-b638-7411440db527}" type="datetime3">
+            <a:fld id="{b287a157-636b-48e4-b3dd-3c49f41d0f0b}" type="datetime3">
               <a:rPr lang="en-GB" sz="1000" dirty="0">
                 <a:solidFill>
                   <a:srgbClr val="9AA3AE"/>
@@ -5791,7 +5791,7 @@
           <a:lstStyle/>
           <a:p>
             <a:pPr algn="ctr"/>
-            <a:fld id="{201a12ea-9761-4640-a88f-b80086493f30}" type="slidenum">
+            <a:fld id="{dd24d6f3-d6b1-4833-a456-613f9ae5fbab}" type="slidenum">
               <a:rPr lang="en-GB" sz="1200" b="1" dirty="0">
                 <a:solidFill>
                   <a:srgbClr val="FFFFFF"/>
@@ -6718,7 +6718,7 @@
           <a:lstStyle/>
           <a:p>
             <a:pPr algn="l"/>
-            <a:fld id="{6805c05c-8356-4e91-9f93-b1add282f55c}" type="datetime3">
+            <a:fld id="{1534663f-2ce1-4d54-a623-35304ffce95c}" type="datetime3">
               <a:rPr lang="en-GB" sz="1000" dirty="0">
                 <a:solidFill>
                   <a:srgbClr val="9AA3AE"/>
@@ -6752,7 +6752,7 @@
           <a:lstStyle/>
           <a:p>
             <a:pPr algn="ctr"/>
-            <a:fld id="{7c4f265e-a1c6-4e70-93cb-35b900c3a795}" type="slidenum">
+            <a:fld id="{8484abdc-73c5-47a9-89a1-125ba21baeab}" type="slidenum">
               <a:rPr lang="en-GB" sz="1200" b="1" dirty="0">
                 <a:solidFill>
                   <a:srgbClr val="FFFFFF"/>
@@ -7679,7 +7679,7 @@
           <a:lstStyle/>
           <a:p>
             <a:pPr algn="l"/>
-            <a:fld id="{858c5eee-216e-4933-95b9-425d93cb2369}" type="datetime3">
+            <a:fld id="{3efe2991-bdf5-41ce-8fcb-7b2148c0b19a}" type="datetime3">
               <a:rPr lang="en-GB" sz="1000" dirty="0">
                 <a:solidFill>
                   <a:srgbClr val="9AA3AE"/>
@@ -7713,7 +7713,7 @@
           <a:lstStyle/>
           <a:p>
             <a:pPr algn="ctr"/>
-            <a:fld id="{67870495-24d6-4fd3-a022-dc5624eb1d95}" type="slidenum">
+            <a:fld id="{61828160-4e0e-4319-a6cc-d8e603284f49}" type="slidenum">
               <a:rPr lang="en-GB" sz="1200" b="1" dirty="0">
                 <a:solidFill>
                   <a:srgbClr val="FFFFFF"/>
@@ -8640,7 +8640,7 @@
           <a:lstStyle/>
           <a:p>
             <a:pPr algn="l"/>
-            <a:fld id="{092f85d5-a198-4b9e-b88d-fe748299f529}" type="datetime3">
+            <a:fld id="{0fb3341b-9e9a-469e-b53c-b5d3122aa9eb}" type="datetime3">
               <a:rPr lang="en-GB" sz="1000" dirty="0">
                 <a:solidFill>
                   <a:srgbClr val="9AA3AE"/>
@@ -8674,7 +8674,7 @@
           <a:lstStyle/>
           <a:p>
             <a:pPr algn="ctr"/>
-            <a:fld id="{5d0c0902-0676-48ed-87be-7af188518854}" type="slidenum">
+            <a:fld id="{ea3da54a-6545-4334-a77b-7a18debbb0f3}" type="slidenum">
               <a:rPr lang="en-GB" sz="1200" b="1" dirty="0">
                 <a:solidFill>
                   <a:srgbClr val="FFFFFF"/>
@@ -9496,7 +9496,7 @@
           <a:lstStyle/>
           <a:p>
             <a:pPr algn="l"/>
-            <a:fld id="{9c57c411-0883-4a3e-8186-427fbb0e5e11}" type="datetime3">
+            <a:fld id="{0d272d85-8c52-4056-b1e1-c32e660eb148}" type="datetime3">
               <a:rPr lang="en-GB" sz="1000" dirty="0">
                 <a:solidFill>
                   <a:srgbClr val="9AA3AE"/>
@@ -9530,7 +9530,7 @@
           <a:lstStyle/>
           <a:p>
             <a:pPr algn="ctr"/>
-            <a:fld id="{45475850-6966-4d0f-ad09-acf9ef68d1b4}" type="slidenum">
+            <a:fld id="{d0ce5681-8032-4478-8c78-b62c65e8a1e5}" type="slidenum">
               <a:rPr lang="en-GB" sz="1200" b="1" dirty="0">
                 <a:solidFill>
                   <a:srgbClr val="FFFFFF"/>
@@ -10284,7 +10284,7 @@
           <a:lstStyle/>
           <a:p>
             <a:pPr algn="l"/>
-            <a:fld id="{97385b77-8060-439c-b2ab-a421c9ea7f2a}" type="datetime3">
+            <a:fld id="{9d98fea4-30d0-4e01-aeac-7bd02a49b0f5}" type="datetime3">
               <a:rPr lang="en-GB" sz="1000" dirty="0">
                 <a:solidFill>
                   <a:srgbClr val="9AA3AE"/>
@@ -10318,7 +10318,7 @@
           <a:lstStyle/>
           <a:p>
             <a:pPr algn="ctr"/>
-            <a:fld id="{528a2512-f73e-45d2-9697-f314c3662cd7}" type="slidenum">
+            <a:fld id="{cd1a8987-f4ee-476b-b83d-c73086e10c11}" type="slidenum">
               <a:rPr lang="en-GB" sz="1200" b="1" dirty="0">
                 <a:solidFill>
                   <a:srgbClr val="FFFFFF"/>
@@ -11018,7 +11018,7 @@
           <a:lstStyle/>
           <a:p>
             <a:pPr algn="l"/>
-            <a:fld id="{15551e35-2fb6-444e-8fc7-a95714db58a4}" type="datetime3">
+            <a:fld id="{e84c95f5-5efd-4344-9f4f-b39560730c0a}" type="datetime3">
               <a:rPr lang="en-GB" sz="1000" dirty="0">
                 <a:solidFill>
                   <a:srgbClr val="9AA3AE"/>
@@ -11052,7 +11052,7 @@
           <a:lstStyle/>
           <a:p>
             <a:pPr algn="ctr"/>
-            <a:fld id="{8be17b33-8142-46e8-987a-38cec05b34d2}" type="slidenum">
+            <a:fld id="{5f1a5216-65ce-41ba-8118-9d2cfcd57f7c}" type="slidenum">
               <a:rPr lang="en-GB" sz="1200" b="1" dirty="0">
                 <a:solidFill>
                   <a:srgbClr val="FFFFFF"/>
@@ -11860,7 +11860,7 @@
           <a:lstStyle/>
           <a:p>
             <a:pPr algn="l"/>
-            <a:fld id="{b9d4b552-97ea-4070-88c0-f31d3be54d5d}" type="datetime3">
+            <a:fld id="{98e77da0-3400-4ceb-9cd1-3db617ef891f}" type="datetime3">
               <a:rPr lang="en-GB" sz="1000" dirty="0">
                 <a:solidFill>
                   <a:srgbClr val="9AA3AE"/>
@@ -11894,7 +11894,7 @@
           <a:lstStyle/>
           <a:p>
             <a:pPr algn="ctr"/>
-            <a:fld id="{c2f18ce8-5aa8-4221-ab1b-12cc89bf0f73}" type="slidenum">
+            <a:fld id="{90de5231-e94b-438e-87c5-860d2f3dfd54}" type="slidenum">
               <a:rPr lang="en-GB" sz="1200" b="1" dirty="0">
                 <a:solidFill>
                   <a:srgbClr val="FFFFFF"/>
@@ -12361,7 +12361,7 @@
           <a:lstStyle/>
           <a:p>
             <a:pPr algn="l"/>
-            <a:fld id="{c7a068e7-d6d0-4e60-b057-a929e422c05a}" type="datetime3">
+            <a:fld id="{9cf2c17f-23c3-42d5-974a-3750f3fb4f06}" type="datetime3">
               <a:rPr lang="en-GB" sz="1000" dirty="0">
                 <a:solidFill>
                   <a:srgbClr val="9AA3AE"/>
@@ -12395,7 +12395,7 @@
           <a:lstStyle/>
           <a:p>
             <a:pPr algn="ctr"/>
-            <a:fld id="{fc964bca-1c64-4292-af05-f907f1da1a16}" type="slidenum">
+            <a:fld id="{13da4252-b809-4643-9d20-a23607b007a2}" type="slidenum">
               <a:rPr lang="en-GB" sz="1200" b="1" dirty="0">
                 <a:solidFill>
                   <a:srgbClr val="FFFFFF"/>
@@ -13247,7 +13247,7 @@
           <a:lstStyle/>
           <a:p>
             <a:pPr algn="l"/>
-            <a:fld id="{5cebbbd2-6c67-4d00-afb9-6e9b8d063cad}" type="datetime3">
+            <a:fld id="{8766e330-e353-4e26-853b-018818ecef36}" type="datetime3">
               <a:rPr lang="en-GB" sz="1000" dirty="0">
                 <a:solidFill>
                   <a:srgbClr val="9AA3AE"/>
@@ -13281,7 +13281,7 @@
           <a:lstStyle/>
           <a:p>
             <a:pPr algn="ctr"/>
-            <a:fld id="{bd686c24-efd6-456a-80d8-c83d630cbac8}" type="slidenum">
+            <a:fld id="{0335c207-5f82-498f-aa02-f6d6143f8a2c}" type="slidenum">
               <a:rPr lang="en-GB" sz="1200" b="1" dirty="0">
                 <a:solidFill>
                   <a:srgbClr val="FFFFFF"/>
@@ -13713,7 +13713,7 @@
           <a:lstStyle/>
           <a:p>
             <a:pPr algn="l"/>
-            <a:fld id="{18166bff-3499-4efc-b65c-d6787322171d}" type="datetime3">
+            <a:fld id="{16d23620-841a-4473-a3a0-9feef0ba1bb5}" type="datetime3">
               <a:rPr lang="en-GB" sz="1000" dirty="0">
                 <a:solidFill>
                   <a:srgbClr val="9AA3AE"/>
@@ -13747,7 +13747,7 @@
           <a:lstStyle/>
           <a:p>
             <a:pPr algn="ctr"/>
-            <a:fld id="{bd00e1bf-8e84-4fcd-a05d-f797eeb1fccb}" type="slidenum">
+            <a:fld id="{0155adc7-7d40-49a8-a304-f5e7d9bf3293}" type="slidenum">
               <a:rPr lang="en-GB" sz="1200" b="1" dirty="0">
                 <a:solidFill>
                   <a:srgbClr val="FFFFFF"/>
@@ -14196,7 +14196,7 @@
           <a:lstStyle/>
           <a:p>
             <a:pPr algn="l"/>
-            <a:fld id="{ea69f39e-f29b-4c3f-8cbc-62e9e82b7399}" type="datetime3">
+            <a:fld id="{bfaa34a8-e3df-4446-be77-5ecacb880c6d}" type="datetime3">
               <a:rPr lang="en-GB" sz="1000" dirty="0">
                 <a:solidFill>
                   <a:srgbClr val="9AA3AE"/>
@@ -14230,7 +14230,7 @@
           <a:lstStyle/>
           <a:p>
             <a:pPr algn="ctr"/>
-            <a:fld id="{7dacb714-e7f8-427b-a399-e7080fe911c3}" type="slidenum">
+            <a:fld id="{593e3ae1-a46c-4ee7-82f6-ab9d4fc227db}" type="slidenum">
               <a:rPr lang="en-GB" sz="1200" b="1" dirty="0">
                 <a:solidFill>
                   <a:srgbClr val="FFFFFF"/>
@@ -14916,7 +14916,7 @@
           <a:lstStyle/>
           <a:p>
             <a:pPr algn="l"/>
-            <a:fld id="{eec7e33d-013b-49c6-94b4-338431b5f90b}" type="datetime3">
+            <a:fld id="{9fca7fe8-0255-4d81-8a93-f61a2fefefaf}" type="datetime3">
               <a:rPr lang="en-GB" sz="1000" dirty="0">
                 <a:solidFill>
                   <a:srgbClr val="9AA3AE"/>
@@ -14950,7 +14950,7 @@
           <a:lstStyle/>
           <a:p>
             <a:pPr algn="ctr"/>
-            <a:fld id="{a4243361-14c3-4ae7-8b84-8558713ea92c}" type="slidenum">
+            <a:fld id="{bb1bef7e-1d0d-4f29-80b4-9568d86428e4}" type="slidenum">
               <a:rPr lang="en-GB" sz="1200" b="1" dirty="0">
                 <a:solidFill>
                   <a:srgbClr val="FFFFFF"/>
@@ -15848,7 +15848,7 @@
           <a:lstStyle/>
           <a:p>
             <a:pPr algn="l"/>
-            <a:fld id="{2e3a5bb4-04d9-4ad6-ad5b-6ddef876a285}" type="datetime3">
+            <a:fld id="{e801af3f-c227-4878-b50a-f31aca5ef894}" type="datetime3">
               <a:rPr lang="en-GB" sz="1000" dirty="0">
                 <a:solidFill>
                   <a:srgbClr val="9AA3AE"/>
@@ -15882,7 +15882,7 @@
           <a:lstStyle/>
           <a:p>
             <a:pPr algn="ctr"/>
-            <a:fld id="{73be9799-60e9-41f7-9fbc-676c491ba1ad}" type="slidenum">
+            <a:fld id="{58b1bd8b-ca01-477d-a681-7220abac13eb}" type="slidenum">
               <a:rPr lang="en-GB" sz="1200" b="1" dirty="0">
                 <a:solidFill>
                   <a:srgbClr val="FFFFFF"/>
@@ -16672,7 +16672,7 @@
           <a:lstStyle/>
           <a:p>
             <a:pPr algn="l"/>
-            <a:fld id="{a1ccffb8-84f5-4789-a02b-fe1e8f203126}" type="datetime3">
+            <a:fld id="{5e8cd0cd-7d9d-41a2-b580-22979de29a24}" type="datetime3">
               <a:rPr lang="en-GB" sz="1000" dirty="0">
                 <a:solidFill>
                   <a:srgbClr val="9AA3AE"/>
@@ -16706,7 +16706,7 @@
           <a:lstStyle/>
           <a:p>
             <a:pPr algn="ctr"/>
-            <a:fld id="{37b7d82a-5b9a-431c-bf7d-48e2dfd428fe}" type="slidenum">
+            <a:fld id="{4f8e3a51-3597-41c0-b3f7-ed91b6ce2c3b}" type="slidenum">
               <a:rPr lang="en-GB" sz="1200" b="1" dirty="0">
                 <a:solidFill>
                   <a:srgbClr val="FFFFFF"/>
@@ -17442,7 +17442,7 @@
           <a:lstStyle/>
           <a:p>
             <a:pPr algn="l"/>
-            <a:fld id="{ef65ddd9-b05a-4ea9-a9c0-493c5a39d286}" type="datetime3">
+            <a:fld id="{1a07693e-ce26-4df2-8a8d-d0567a7cc1d7}" type="datetime3">
               <a:rPr lang="en-GB" sz="1000" dirty="0">
                 <a:solidFill>
                   <a:srgbClr val="9AA3AE"/>
@@ -17476,7 +17476,7 @@
           <a:lstStyle/>
           <a:p>
             <a:pPr algn="ctr"/>
-            <a:fld id="{f2d3b9b3-2822-44b7-a399-a0f3c1997c71}" type="slidenum">
+            <a:fld id="{4826273f-a500-495f-b936-641d5eee5af1}" type="slidenum">
               <a:rPr lang="en-GB" sz="1200" b="1" dirty="0">
                 <a:solidFill>
                   <a:srgbClr val="FFFFFF"/>
@@ -18266,7 +18266,7 @@
           <a:lstStyle/>
           <a:p>
             <a:pPr algn="l"/>
-            <a:fld id="{4b54cf07-d71f-4a24-a03b-2f0ff9fad3f1}" type="datetime3">
+            <a:fld id="{cdadd40a-8022-4fb3-879d-d8a5333eb722}" type="datetime3">
               <a:rPr lang="en-GB" sz="1000" dirty="0">
                 <a:solidFill>
                   <a:srgbClr val="9AA3AE"/>
@@ -18300,7 +18300,7 @@
           <a:lstStyle/>
           <a:p>
             <a:pPr algn="ctr"/>
-            <a:fld id="{2efa6f34-bc09-4d7e-b20b-26e441f4285e}" type="slidenum">
+            <a:fld id="{71434a09-bfb1-4cfd-9ca3-7c079a671fb2}" type="slidenum">
               <a:rPr lang="en-GB" sz="1200" b="1" dirty="0">
                 <a:solidFill>
                   <a:srgbClr val="FFFFFF"/>
@@ -18731,7 +18731,7 @@
           <a:lstStyle/>
           <a:p>
             <a:pPr algn="l"/>
-            <a:fld id="{f9b91bfa-44d3-41c6-9167-766f59736625}" type="datetime3">
+            <a:fld id="{c191220e-17eb-461a-8762-33d7daf9abcc}" type="datetime3">
               <a:rPr lang="en-GB" sz="1000" dirty="0">
                 <a:solidFill>
                   <a:srgbClr val="9AA3AE"/>
@@ -18765,7 +18765,7 @@
           <a:lstStyle/>
           <a:p>
             <a:pPr algn="ctr"/>
-            <a:fld id="{c2ec321e-a8fa-4e7a-8151-787e8a0beb7f}" type="slidenum">
+            <a:fld id="{4bef6d6c-684a-4dc4-9654-1addefee2656}" type="slidenum">
               <a:rPr lang="en-GB" sz="1200" b="1" dirty="0">
                 <a:solidFill>
                   <a:srgbClr val="FFFFFF"/>
@@ -19179,7 +19179,7 @@
           <a:lstStyle/>
           <a:p>
             <a:pPr algn="l"/>
-            <a:fld id="{6fb1371d-b2b8-4877-a6cc-a7a7796aa15a}" type="datetime3">
+            <a:fld id="{4cbe7169-0ea1-409d-9be7-7718533c3e82}" type="datetime3">
               <a:rPr lang="en-GB" sz="1000" dirty="0">
                 <a:solidFill>
                   <a:srgbClr val="9AA3AE"/>
@@ -19213,7 +19213,7 @@
           <a:lstStyle/>
           <a:p>
             <a:pPr algn="ctr"/>
-            <a:fld id="{b702aaa2-489e-46cd-a1c0-88cd8b81bb6e}" type="slidenum">
+            <a:fld id="{8de02106-df85-4b99-be3b-600d936f6873}" type="slidenum">
               <a:rPr lang="en-GB" sz="1200" b="1" dirty="0">
                 <a:solidFill>
                   <a:srgbClr val="FFFFFF"/>
@@ -20040,7 +20040,7 @@
           <a:lstStyle/>
           <a:p>
             <a:pPr algn="l"/>
-            <a:fld id="{71fbee0f-f2c1-430d-bc69-7811a8b3ed8d}" type="datetime3">
+            <a:fld id="{c4e4a54f-0306-456b-aed8-9afe2ffbab2e}" type="datetime3">
               <a:rPr lang="en-GB" sz="1000" dirty="0">
                 <a:solidFill>
                   <a:srgbClr val="9AA3AE"/>
@@ -20074,7 +20074,7 @@
           <a:lstStyle/>
           <a:p>
             <a:pPr algn="ctr"/>
-            <a:fld id="{b65170d4-0886-49bb-8108-19a0887fc549}" type="slidenum">
+            <a:fld id="{f50b8ce9-ca58-47ad-bb5b-68fc19d504b0}" type="slidenum">
               <a:rPr lang="en-GB" sz="1200" b="1" dirty="0">
                 <a:solidFill>
                   <a:srgbClr val="FFFFFF"/>
@@ -20367,7 +20367,7 @@
                 </a:solidFill>
                 <a:latin typeface="Calibri"/>
               </a:rPr>
-              <a:t>Main FET sections, then numbered References. Motivation, architecture figures, O1–O4, and methodology detail stay in the deck under these headings. Click 11 References for citations [1]–[24] with DOI links.</a:t>
+              <a:t>Main FET sections, then numbered References. Motivation, architecture figures, O1–O4, and methodology detail stay in the deck under these headings. Click 11 References for citations [1]–[24]; every citation has a URL.</a:t>
             </a:r>
           </a:p>
         </p:txBody>
@@ -20614,7 +20614,7 @@
           <a:lstStyle/>
           <a:p>
             <a:pPr algn="l"/>
-            <a:fld id="{7859b740-a759-4604-b3fb-96a0efd38d18}" type="datetime3">
+            <a:fld id="{2027db0c-c796-4201-adb3-20c6b2c05103}" type="datetime3">
               <a:rPr lang="en-GB" sz="1000" dirty="0">
                 <a:solidFill>
                   <a:srgbClr val="9AA3AE"/>
@@ -20648,7 +20648,7 @@
           <a:lstStyle/>
           <a:p>
             <a:pPr algn="ctr"/>
-            <a:fld id="{cdf40f45-aa04-4ac8-98fb-3085c02a8d85}" type="slidenum">
+            <a:fld id="{48a26ec3-94b5-4a70-a591-d3416811151a}" type="slidenum">
               <a:rPr lang="en-GB" sz="1200" b="1" dirty="0">
                 <a:solidFill>
                   <a:srgbClr val="FFFFFF"/>
@@ -21547,7 +21547,7 @@
           <a:lstStyle/>
           <a:p>
             <a:pPr algn="l"/>
-            <a:fld id="{2591b51b-1791-48c5-bbd0-02bfd535df53}" type="datetime3">
+            <a:fld id="{aca69bde-ce50-485f-a29b-903133f88fa4}" type="datetime3">
               <a:rPr lang="en-GB" sz="1000" dirty="0">
                 <a:solidFill>
                   <a:srgbClr val="9AA3AE"/>
@@ -21581,7 +21581,7 @@
           <a:lstStyle/>
           <a:p>
             <a:pPr algn="ctr"/>
-            <a:fld id="{d1598ad5-973e-4db3-912a-1d5ac5bff2dd}" type="slidenum">
+            <a:fld id="{e7a2162a-01d3-4401-b6c1-776d0408048c}" type="slidenum">
               <a:rPr lang="en-GB" sz="1200" b="1" dirty="0">
                 <a:solidFill>
                   <a:srgbClr val="FFFFFF"/>
@@ -22390,7 +22390,7 @@
           <a:lstStyle/>
           <a:p>
             <a:pPr algn="l"/>
-            <a:fld id="{8ae7e35e-e16d-4576-94c0-e04b4d110eff}" type="datetime3">
+            <a:fld id="{2db848ab-4f94-42cf-a3a2-f80a716d9c52}" type="datetime3">
               <a:rPr lang="en-GB" sz="1000" dirty="0">
                 <a:solidFill>
                   <a:srgbClr val="9AA3AE"/>
@@ -22424,7 +22424,7 @@
           <a:lstStyle/>
           <a:p>
             <a:pPr algn="ctr"/>
-            <a:fld id="{87861bc8-be9a-4c81-8a21-8bf6328ba936}" type="slidenum">
+            <a:fld id="{da4d8667-792f-4e0c-8032-bf81ef0c92f2}" type="slidenum">
               <a:rPr lang="en-GB" sz="1200" b="1" dirty="0">
                 <a:solidFill>
                   <a:srgbClr val="FFFFFF"/>
@@ -23179,7 +23179,7 @@
           <a:lstStyle/>
           <a:p>
             <a:pPr algn="l"/>
-            <a:fld id="{13204ec2-ee1b-489e-896a-9b4cc96b7428}" type="datetime3">
+            <a:fld id="{6b271643-4f6b-43fe-8014-c43081cec9bd}" type="datetime3">
               <a:rPr lang="en-GB" sz="1000" dirty="0">
                 <a:solidFill>
                   <a:srgbClr val="9AA3AE"/>
@@ -23213,7 +23213,7 @@
           <a:lstStyle/>
           <a:p>
             <a:pPr algn="ctr"/>
-            <a:fld id="{b9d6b2ec-2735-401e-b886-4638b2472131}" type="slidenum">
+            <a:fld id="{5c489e7c-96fe-4492-8d82-9fd78cd66325}" type="slidenum">
               <a:rPr lang="en-GB" sz="1200" b="1" dirty="0">
                 <a:solidFill>
                   <a:srgbClr val="FFFFFF"/>
@@ -24022,7 +24022,7 @@
           <a:lstStyle/>
           <a:p>
             <a:pPr algn="l"/>
-            <a:fld id="{a3bbff6e-1344-4b9c-9a77-f6a19aea3b29}" type="datetime3">
+            <a:fld id="{24825611-7ca9-49d4-9f2a-b977d923099e}" type="datetime3">
               <a:rPr lang="en-GB" sz="1000" dirty="0">
                 <a:solidFill>
                   <a:srgbClr val="9AA3AE"/>
@@ -24056,7 +24056,7 @@
           <a:lstStyle/>
           <a:p>
             <a:pPr algn="ctr"/>
-            <a:fld id="{319f7a6c-9f71-4841-951f-dad096e313fb}" type="slidenum">
+            <a:fld id="{475a87fc-66af-4a3f-b2fd-5ebf7906b49b}" type="slidenum">
               <a:rPr lang="en-GB" sz="1200" b="1" dirty="0">
                 <a:solidFill>
                   <a:srgbClr val="FFFFFF"/>
@@ -24900,7 +24900,7 @@
           <a:lstStyle/>
           <a:p>
             <a:pPr algn="l"/>
-            <a:fld id="{8f20f1f2-bea4-4c65-a8a7-9be1dc71db9c}" type="datetime3">
+            <a:fld id="{d29f32b7-fbe1-4ca7-98a7-04850f318d9d}" type="datetime3">
               <a:rPr lang="en-GB" sz="1000" dirty="0">
                 <a:solidFill>
                   <a:srgbClr val="9AA3AE"/>
@@ -24934,7 +24934,7 @@
           <a:lstStyle/>
           <a:p>
             <a:pPr algn="ctr"/>
-            <a:fld id="{7e854e8e-ae93-425c-8af1-3ae78dde2f51}" type="slidenum">
+            <a:fld id="{07ff1d9d-f423-4578-895d-0d505ffc8dc8}" type="slidenum">
               <a:rPr lang="en-GB" sz="1200" b="1" dirty="0">
                 <a:solidFill>
                   <a:srgbClr val="FFFFFF"/>
@@ -25620,7 +25620,7 @@
           <a:lstStyle/>
           <a:p>
             <a:pPr algn="l"/>
-            <a:fld id="{24d44e44-41d5-4890-802c-1c0d5ee70455}" type="datetime3">
+            <a:fld id="{a4c6537f-42c4-4d3f-b0ee-944a974e28c0}" type="datetime3">
               <a:rPr lang="en-GB" sz="1000" dirty="0">
                 <a:solidFill>
                   <a:srgbClr val="9AA3AE"/>
@@ -25654,7 +25654,7 @@
           <a:lstStyle/>
           <a:p>
             <a:pPr algn="ctr"/>
-            <a:fld id="{637a9b8e-9a95-48de-bf8b-293dd81a845e}" type="slidenum">
+            <a:fld id="{be2d2cf7-1ac1-46b0-aa13-ee968d766421}" type="slidenum">
               <a:rPr lang="en-GB" sz="1200" b="1" dirty="0">
                 <a:solidFill>
                   <a:srgbClr val="FFFFFF"/>
@@ -26463,7 +26463,7 @@
           <a:lstStyle/>
           <a:p>
             <a:pPr algn="l"/>
-            <a:fld id="{d0f58af1-fb50-44d3-91e3-1718154a66d5}" type="datetime3">
+            <a:fld id="{4dd6eb1c-acb4-4050-91f2-820a63d30de0}" type="datetime3">
               <a:rPr lang="en-GB" sz="1000" dirty="0">
                 <a:solidFill>
                   <a:srgbClr val="9AA3AE"/>
@@ -26497,7 +26497,7 @@
           <a:lstStyle/>
           <a:p>
             <a:pPr algn="ctr"/>
-            <a:fld id="{9739bd2b-8084-4e55-8078-3180baba6750}" type="slidenum">
+            <a:fld id="{150bd551-3f86-4326-a876-cca5727bb985}" type="slidenum">
               <a:rPr lang="en-GB" sz="1200" b="1" dirty="0">
                 <a:solidFill>
                   <a:srgbClr val="FFFFFF"/>
@@ -26964,7 +26964,7 @@
           <a:lstStyle/>
           <a:p>
             <a:pPr algn="l"/>
-            <a:fld id="{d7cd5aed-027e-49c0-9a8a-9607d70ff275}" type="datetime3">
+            <a:fld id="{c8422e84-45f4-4bc5-9f9b-e167ad35b9e8}" type="datetime3">
               <a:rPr lang="en-GB" sz="1000" dirty="0">
                 <a:solidFill>
                   <a:srgbClr val="9AA3AE"/>
@@ -26998,7 +26998,7 @@
           <a:lstStyle/>
           <a:p>
             <a:pPr algn="ctr"/>
-            <a:fld id="{86400a96-0f23-4c67-96f1-052ea3d591d9}" type="slidenum">
+            <a:fld id="{8cb80586-0137-4927-a632-6ada54eb2d4a}" type="slidenum">
               <a:rPr lang="en-GB" sz="1200" b="1" dirty="0">
                 <a:solidFill>
                   <a:srgbClr val="FFFFFF"/>
@@ -27465,7 +27465,7 @@
           <a:lstStyle/>
           <a:p>
             <a:pPr algn="l"/>
-            <a:fld id="{71dc09de-9c00-4119-b05d-64b58418ff07}" type="datetime3">
+            <a:fld id="{609ddffb-0321-437c-9b2d-1ca2b22aeaa7}" type="datetime3">
               <a:rPr lang="en-GB" sz="1000" dirty="0">
                 <a:solidFill>
                   <a:srgbClr val="9AA3AE"/>
@@ -27499,7 +27499,7 @@
           <a:lstStyle/>
           <a:p>
             <a:pPr algn="ctr"/>
-            <a:fld id="{900bef93-1106-4e85-9d71-610a5e86cf73}" type="slidenum">
+            <a:fld id="{cf4a227e-b386-4a99-8039-3bb7f2d10ace}" type="slidenum">
               <a:rPr lang="en-GB" sz="1200" b="1" dirty="0">
                 <a:solidFill>
                   <a:srgbClr val="FFFFFF"/>
@@ -27931,7 +27931,7 @@
           <a:lstStyle/>
           <a:p>
             <a:pPr algn="l"/>
-            <a:fld id="{5592e224-0cbd-4808-b3d2-d79578b5fc48}" type="datetime3">
+            <a:fld id="{49155fb5-d165-4f37-829e-a0f927e94394}" type="datetime3">
               <a:rPr lang="en-GB" sz="1000" dirty="0">
                 <a:solidFill>
                   <a:srgbClr val="9AA3AE"/>
@@ -27965,7 +27965,7 @@
           <a:lstStyle/>
           <a:p>
             <a:pPr algn="ctr"/>
-            <a:fld id="{05db1baf-ddcf-49aa-8373-4e106c833c21}" type="slidenum">
+            <a:fld id="{e5ed4a23-e8a5-40f2-a757-33b73ec40c56}" type="slidenum">
               <a:rPr lang="en-GB" sz="1200" b="1" dirty="0">
                 <a:solidFill>
                   <a:srgbClr val="FFFFFF"/>
@@ -28397,7 +28397,7 @@
           <a:lstStyle/>
           <a:p>
             <a:pPr algn="l"/>
-            <a:fld id="{372d5901-2295-4bca-ade1-32613dde5d04}" type="datetime3">
+            <a:fld id="{7791e3e7-ab70-4a36-b7e9-c69c4bccd0c5}" type="datetime3">
               <a:rPr lang="en-GB" sz="1000" dirty="0">
                 <a:solidFill>
                   <a:srgbClr val="9AA3AE"/>
@@ -28431,7 +28431,7 @@
           <a:lstStyle/>
           <a:p>
             <a:pPr algn="ctr"/>
-            <a:fld id="{b99bc3cc-ee97-481e-914d-57fa2c1f680c}" type="slidenum">
+            <a:fld id="{befccbdc-9446-4c64-ae08-ad4b927ed4ce}" type="slidenum">
               <a:rPr lang="en-GB" sz="1200" b="1" dirty="0">
                 <a:solidFill>
                   <a:srgbClr val="FFFFFF"/>
@@ -28724,7 +28724,7 @@
                 </a:solidFill>
                 <a:latin typeface="Calibri"/>
               </a:rPr>
-              <a:t>Numbered bibliography. Evidence 1–18 use the same numbers as citations [1]–[18]. A DOI is a link to https://doi.org/…. Papers without a Crossref DOI stay numbered and unlinked.</a:t>
+              <a:t>Numbered bibliography. Evidence 1–18 use the same numbers as citations [1]–[18]. Every entry ends with a clickable URL: a Crossref DOI where one exists, otherwise the official proceedings, OpenReview, ACL Anthology, or data.gov.in record.</a:t>
             </a:r>
           </a:p>
         </p:txBody>
@@ -28765,7 +28765,7 @@
                 </a:solidFill>
                 <a:latin typeface="Calibri"/>
               </a:rPr>
-              <a:t>[1] Wang, L., Ma, C., Feng, X., Zhang, Z., Yang, H., Zhang, J., Chen, Z., Tang, J., Chen, X., Lin, Y., Zhao, W. X., Wei, Z., and Wen, J. A survey on large language model based autonomous agents. Frontiers of Computer Science, 18, article 186345 (2024). doi:10.1007/s11704-024-40231-1.</a:t>
+              <a:t>[1] Wang, L., Ma, C., Feng, X., Zhang, Z., Yang, H., Zhang, J., Chen, Z., Tang, J., Chen, X., Lin, Y., Zhao, W. X., Wei, Z., and Wen, J. A survey on large language model based autonomous agents. Frontiers of Computer Science, 18, article 186345 (2024). doi:10.1007/s11704-024-40231-1. https://doi.org/10.1007/s11704-024-40231-1</a:t>
             </a:r>
           </a:p>
           <a:p>
@@ -28783,7 +28783,7 @@
                 </a:solidFill>
                 <a:latin typeface="Calibri"/>
               </a:rPr>
-              <a:t>[2] He, J., Treude, C., and Lo, D. LLM-Based Multi-Agent Systems for Software Engineering: Literature Review, Vision, and the Road Ahead. ACM Transactions on Software Engineering and Methodology, 34(5), May 2025. doi:10.1145/3712003.</a:t>
+              <a:t>[2] He, J., Treude, C., and Lo, D. LLM-Based Multi-Agent Systems for Software Engineering: Literature Review, Vision, and the Road Ahead. ACM Transactions on Software Engineering and Methodology, 34(5), May 2025. doi:10.1145/3712003. https://doi.org/10.1145/3712003</a:t>
             </a:r>
           </a:p>
           <a:p>
@@ -28801,7 +28801,7 @@
                 </a:solidFill>
                 <a:latin typeface="Calibri"/>
               </a:rPr>
-              <a:t>[3] Guo, T., Chen, X., Wang, Y., Chang, R., Pei, S., Chawla, N. V., Wiest, O., and Zhang, X. Large Language Model based Multi-Agents: A Survey of Progress and Challenges. Proceedings of the Thirty-Third International Joint Conference on Artificial Intelligence (IJCAI-24), Survey Track, pages 8048–8057. doi:10.24963/ijcai.2024/890.</a:t>
+              <a:t>[3] Guo, T., Chen, X., Wang, Y., Chang, R., Pei, S., Chawla, N. V., Wiest, O., and Zhang, X. Large Language Model based Multi-Agents: A Survey of Progress and Challenges. Proceedings of the Thirty-Third International Joint Conference on Artificial Intelligence (IJCAI-24), Survey Track, pages 8048–8057. doi:10.24963/ijcai.2024/890. https://doi.org/10.24963/ijcai.2024/890</a:t>
             </a:r>
           </a:p>
           <a:p>
@@ -28819,7 +28819,7 @@
                 </a:solidFill>
                 <a:latin typeface="Calibri"/>
               </a:rPr>
-              <a:t>[4] Chang, E. Y., and Geng, L. SagaLLM: Context Management, Validation, and Transaction Guarantees for Multi-Agent LLM Planning. Proceedings of the VLDB Endowment (PVLDB), 18(12):4874–4886, 2025. doi:10.14778/3750601.3750611.</a:t>
+              <a:t>[4] Chang, E. Y., and Geng, L. SagaLLM: Context Management, Validation, and Transaction Guarantees for Multi-Agent LLM Planning. Proceedings of the VLDB Endowment (PVLDB), 18(12):4874–4886, 2025. doi:10.14778/3750601.3750611. https://doi.org/10.14778/3750601.3750611</a:t>
             </a:r>
           </a:p>
           <a:p>
@@ -28837,7 +28837,7 @@
                 </a:solidFill>
                 <a:latin typeface="Calibri"/>
               </a:rPr>
-              <a:t>[5] Wu, Q., Bansal, G., Zhang, J., Wu, Y., Li, B., Zhu, E., Jiang, L., Zhang, X., Zhang, S., Liu, J., Awadallah, A. H., White, R. W., Burger, D., and Wang, C. AutoGen: Enabling Next-Gen LLM Applications via Multi-Agent Conversations. Proceedings of the First Conference on Language Modeling (COLM 2024).</a:t>
+              <a:t>[5] Wu, Q., Bansal, G., Zhang, J., Wu, Y., Li, B., Zhu, E., Jiang, L., Zhang, X., Zhang, S., Liu, J., Awadallah, A. H., White, R. W., Burger, D., and Wang, C. AutoGen: Enabling Next-Gen LLM Applications via Multi-Agent Conversations. Proceedings of the First Conference on Language Modeling (COLM 2024). https://www.microsoft.com/en-us/research/publication/autogen-enabling-next-gen-llm-applications-via-multi-agent-conversation-framework/</a:t>
             </a:r>
           </a:p>
           <a:p>
@@ -28855,7 +28855,7 @@
                 </a:solidFill>
                 <a:latin typeface="Calibri"/>
               </a:rPr>
-              <a:t>[6] Hong, S., Zhuge, M., Chen, J., Zheng, X., Cheng, Y., Wang, J., Zhang, C., Wang, Z., Yau, S. K. S., Lin, Z., Zhou, L., Ran, C., Xiao, L., Wu, C., and Schmidhuber, J. MetaGPT: Meta Programming for A Multi-Agent Collaborative Framework. Proceedings of the Twelfth International Conference on Learning Representations (ICLR 2024).</a:t>
+              <a:t>[6] Hong, S., Zhuge, M., Chen, J., Zheng, X., Cheng, Y., Wang, J., Zhang, C., Wang, Z., Yau, S. K. S., Lin, Z., Zhou, L., Ran, C., Xiao, L., Wu, C., and Schmidhuber, J. MetaGPT: Meta Programming for A Multi-Agent Collaborative Framework. Proceedings of the Twelfth International Conference on Learning Representations (ICLR 2024). https://proceedings.iclr.cc/paper_files/paper/2024/hash/6507b115562bb0a305f1958ccc87355a-Abstract-Conference.html</a:t>
             </a:r>
           </a:p>
           <a:p>
@@ -28873,7 +28873,7 @@
                 </a:solidFill>
                 <a:latin typeface="Calibri"/>
               </a:rPr>
-              <a:t>[7] Qian, C., Liu, W., Liu, H., Chen, N., Dang, Y., Li, J., Yang, C., Chen, W., Su, Y., Cong, X., Xu, J., Li, D., Liu, Z., and Sun, M. ChatDev: Communicative Agents for Software Development. Proceedings of the 62nd Annual Meeting of the Association for Computational Linguistics (Volume 1: Long Papers), pages 15174–15186. doi:10.18653/v1/2024.acl-long.810.</a:t>
+              <a:t>[7] Qian, C., Liu, W., Liu, H., Chen, N., Dang, Y., Li, J., Yang, C., Chen, W., Su, Y., Cong, X., Xu, J., Li, D., Liu, Z., and Sun, M. ChatDev: Communicative Agents for Software Development. Proceedings of the 62nd Annual Meeting of the Association for Computational Linguistics (Volume 1: Long Papers), pages 15174–15186. doi:10.18653/v1/2024.acl-long.810. https://doi.org/10.18653/v1/2024.acl-long.810</a:t>
             </a:r>
           </a:p>
           <a:p>
@@ -28891,7 +28891,7 @@
                 </a:solidFill>
                 <a:latin typeface="Calibri"/>
               </a:rPr>
-              <a:t>[8] Li, G., Hammoud, H. A. A. K., Itani, H., Khizbullin, D., and Ghanem, B. CAMEL: Communicative Agents for “Mind” Exploration of Large Language Model Society. Advances in Neural Information Processing Systems 36 (NeurIPS 2023).</a:t>
+              <a:t>[8] Li, G., Hammoud, H. A. A. K., Itani, H., Khizbullin, D., and Ghanem, B. CAMEL: Communicative Agents for “Mind” Exploration of Large Language Model Society. Advances in Neural Information Processing Systems 36 (NeurIPS 2023). https://proceedings.neurips.cc/paper_files/paper/2023/hash/a3621ee907def47c1b952ade25c67698-Abstract-Conference.html</a:t>
             </a:r>
           </a:p>
         </p:txBody>
@@ -28952,7 +28952,7 @@
           <a:lstStyle/>
           <a:p>
             <a:pPr algn="l"/>
-            <a:fld id="{9b413a79-2a85-47b7-85a4-1e5e0787af6d}" type="datetime3">
+            <a:fld id="{35511a80-aafd-48ba-9727-2ae9eae3d4c3}" type="datetime3">
               <a:rPr lang="en-GB" sz="1000" dirty="0">
                 <a:solidFill>
                   <a:srgbClr val="9AA3AE"/>
@@ -28986,7 +28986,7 @@
           <a:lstStyle/>
           <a:p>
             <a:pPr algn="ctr"/>
-            <a:fld id="{7270f86b-1c08-4d4d-bc67-e6d47def8ca1}" type="slidenum">
+            <a:fld id="{5516c673-7c95-4ec0-b5d6-c452d93009ca}" type="slidenum">
               <a:rPr lang="en-GB" sz="1200" b="1" dirty="0">
                 <a:solidFill>
                   <a:srgbClr val="FFFFFF"/>
@@ -29279,7 +29279,7 @@
                 </a:solidFill>
                 <a:latin typeface="Calibri"/>
               </a:rPr>
-              <a:t>Continuation. Citations [9]–[16]. Click a DOI to open the publisher record.</a:t>
+              <a:t>Continuation. Citations [9]–[16]. Click the URL to open the publisher or portal record.</a:t>
             </a:r>
           </a:p>
         </p:txBody>
@@ -29320,7 +29320,7 @@
                 </a:solidFill>
                 <a:latin typeface="Calibri"/>
               </a:rPr>
-              <a:t>[9] Qin, Y., Liang, S., Ye, Y., Zhu, K., Yan, L., Lu, Y., Lin, Y., Cong, X., Tang, X., Qian, B., Zhao, S., Hong, L., Tian, R., Xie, R., Zhou, J., Gerstein, M., Li, D., Liu, Z., and Sun, M. ToolLLM: Facilitating Large Language Models to Master 16000+ Real-world APIs. Proceedings of the Twelfth International Conference on Learning Representations (ICLR 2024).</a:t>
+              <a:t>[9] Qin, Y., Liang, S., Ye, Y., Zhu, K., Yan, L., Lu, Y., Lin, Y., Cong, X., Tang, X., Qian, B., Zhao, S., Hong, L., Tian, R., Xie, R., Zhou, J., Gerstein, M., Li, D., Liu, Z., and Sun, M. ToolLLM: Facilitating Large Language Models to Master 16000+ Real-world APIs. Proceedings of the Twelfth International Conference on Learning Representations (ICLR 2024). https://proceedings.iclr.cc/paper_files/paper/2024/hash/28e50ee5b72e90b50e7196fde8ea260e-Abstract-Conference.html</a:t>
             </a:r>
           </a:p>
           <a:p>
@@ -29338,7 +29338,7 @@
                 </a:solidFill>
                 <a:latin typeface="Calibri"/>
               </a:rPr>
-              <a:t>[10] Zheng, Y., Li, P., Liu, W., Liu, Y., Luan, J., and Wang, B. ToolRerank: Adaptive and Hierarchy-Aware Reranking for Tool Retrieval. Proceedings of the 2024 Joint International Conference on Computational Linguistics, Language Resources and Evaluation (LREC-COLING 2024), pages 16263–16273. ACL Anthology 2024.lrec-main.1413.</a:t>
+              <a:t>[10] Zheng, Y., Li, P., Liu, W., Liu, Y., Luan, J., and Wang, B. ToolRerank: Adaptive and Hierarchy-Aware Reranking for Tool Retrieval. Proceedings of the 2024 Joint International Conference on Computational Linguistics, Language Resources and Evaluation (LREC-COLING 2024), pages 16263–16273. ACL Anthology 2024.lrec-main.1413. https://aclanthology.org/2024.lrec-main.1413/</a:t>
             </a:r>
           </a:p>
           <a:p>
@@ -29356,7 +29356,7 @@
                 </a:solidFill>
                 <a:latin typeface="Calibri"/>
               </a:rPr>
-              <a:t>[11] Ong, I., Almahairi, A., Wu, V., Chiang, W.-L., Wu, T., Gonzalez, J. E., Kadous, M. W., and Stoica, I. RouteLLM: Learning to Route LLMs from Preference Data. Proceedings of the Thirteenth International Conference on Learning Representations (ICLR 2025).</a:t>
+              <a:t>[11] Ong, I., Almahairi, A., Wu, V., Chiang, W.-L., Wu, T., Gonzalez, J. E., Kadous, M. W., and Stoica, I. RouteLLM: Learning to Route LLMs from Preference Data. Proceedings of the Thirteenth International Conference on Learning Representations (ICLR 2025). https://proceedings.iclr.cc/paper_files/paper/2025/hash/5503a7c69d48a2f86fc00b3dc09de686-Abstract-Conference.html</a:t>
             </a:r>
           </a:p>
           <a:p>
@@ -29374,7 +29374,7 @@
                 </a:solidFill>
                 <a:latin typeface="Calibri"/>
               </a:rPr>
-              <a:t>[12] Yue, Y., Zhang, G., Liu, B., Wan, G., Wang, K., Cheng, D., and Qi, Y. MasRouter: Learning to Route LLMs for Multi-Agent Systems. Proceedings of the 63rd Annual Meeting of the Association for Computational Linguistics (Volume 1: Long Papers), pages 15549–15572. doi:10.18653/v1/2025.acl-long.757.</a:t>
+              <a:t>[12] Yue, Y., Zhang, G., Liu, B., Wan, G., Wang, K., Cheng, D., and Qi, Y. MasRouter: Learning to Route LLMs for Multi-Agent Systems. Proceedings of the 63rd Annual Meeting of the Association for Computational Linguistics (Volume 1: Long Papers), pages 15549–15572. doi:10.18653/v1/2025.acl-long.757. https://doi.org/10.18653/v1/2025.acl-long.757</a:t>
             </a:r>
           </a:p>
           <a:p>
@@ -29392,7 +29392,7 @@
                 </a:solidFill>
                 <a:latin typeface="Calibri"/>
               </a:rPr>
-              <a:t>[13] Panda, P., Magazine, R., Devaguptapu, C., Takemori, S., and Sharma, V. Adaptive LLM Routing under Budget Constraints. Findings of the Association for Computational Linguistics: EMNLP 2025, pages 23934–23949. doi:10.18653/v1/2025.findings-emnlp.1301. Method name: PILOT (Preference-prior Informed LinUCB).</a:t>
+              <a:t>[13] Panda, P., Magazine, R., Devaguptapu, C., Takemori, S., and Sharma, V. Adaptive LLM Routing under Budget Constraints. Findings of the Association for Computational Linguistics: EMNLP 2025, pages 23934–23949. doi:10.18653/v1/2025.findings-emnlp.1301. Method name: PILOT (Preference-prior Informed LinUCB). https://doi.org/10.18653/v1/2025.findings-emnlp.1301</a:t>
             </a:r>
           </a:p>
           <a:p>
@@ -29410,7 +29410,7 @@
                 </a:solidFill>
                 <a:latin typeface="Calibri"/>
               </a:rPr>
-              <a:t>[14] Jiang, H., Wu, Q., Lin, C.-Y., Yang, Y., and Qiu, L. LLMLingua: Compressing Prompts for Accelerated Inference of Large Language Models. Proceedings of the 2023 Conference on Empirical Methods in Natural Language Processing, pages 13358–13376. doi:10.18653/v1/2023.emnlp-main.825.</a:t>
+              <a:t>[14] Jiang, H., Wu, Q., Lin, C.-Y., Yang, Y., and Qiu, L. LLMLingua: Compressing Prompts for Accelerated Inference of Large Language Models. Proceedings of the 2023 Conference on Empirical Methods in Natural Language Processing, pages 13358–13376. doi:10.18653/v1/2023.emnlp-main.825. https://doi.org/10.18653/v1/2023.emnlp-main.825</a:t>
             </a:r>
           </a:p>
           <a:p>
@@ -29428,7 +29428,7 @@
                 </a:solidFill>
                 <a:latin typeface="Calibri"/>
               </a:rPr>
-              <a:t>[15] Park, J. S., O’Brien, J. C., Cai, C. J., Morris, M. R., Liang, P., and Bernstein, M. S. Generative Agents: Interactive Simulacra of Human Behavior. Proceedings of the 36th Annual ACM Symposium on User Interface Software and Technology (UIST 2023), Best Paper. doi:10.1145/3586183.3606763.</a:t>
+              <a:t>[15] Park, J. S., O’Brien, J. C., Cai, C. J., Morris, M. R., Liang, P., and Bernstein, M. S. Generative Agents: Interactive Simulacra of Human Behavior. Proceedings of the 36th Annual ACM Symposium on User Interface Software and Technology (UIST 2023), Best Paper. doi:10.1145/3586183.3606763. https://doi.org/10.1145/3586183.3606763</a:t>
             </a:r>
           </a:p>
           <a:p>
@@ -29446,7 +29446,7 @@
                 </a:solidFill>
                 <a:latin typeface="Calibri"/>
               </a:rPr>
-              <a:t>[16] Tero, A., Takagi, S., Saigusa, T., Ito, K., Bebber, D. P., Fricker, M. D., Yumiki, K., Kobayashi, R., and Nakagaki, T. Rules for Biologically Inspired Adaptive Network Design. Science 327(5964):439–442. doi:10.1126/science.1177894.</a:t>
+              <a:t>[16] Tero, A., Takagi, S., Saigusa, T., Ito, K., Bebber, D. P., Fricker, M. D., Yumiki, K., Kobayashi, R., and Nakagaki, T. Rules for Biologically Inspired Adaptive Network Design. Science 327(5964):439–442. doi:10.1126/science.1177894. https://doi.org/10.1126/science.1177894</a:t>
             </a:r>
           </a:p>
         </p:txBody>
@@ -29472,7 +29472,7 @@
           <a:lstStyle/>
           <a:p>
             <a:pPr algn="l"/>
-            <a:fld id="{abddabb5-5ce3-4739-8483-ab7aa8478cfc}" type="datetime3">
+            <a:fld id="{4157f35e-ef82-4382-8ff3-b86ac73fa399}" type="datetime3">
               <a:rPr lang="en-GB" sz="1000" dirty="0">
                 <a:solidFill>
                   <a:srgbClr val="9AA3AE"/>
@@ -29506,7 +29506,7 @@
           <a:lstStyle/>
           <a:p>
             <a:pPr algn="ctr"/>
-            <a:fld id="{0012a6c7-475a-4374-9193-5c92fd15ba7d}" type="slidenum">
+            <a:fld id="{f4f104b0-9923-4032-9ffb-adc18d5dfadd}" type="slidenum">
               <a:rPr lang="en-GB" sz="1200" b="1" dirty="0">
                 <a:solidFill>
                   <a:srgbClr val="FFFFFF"/>
@@ -29799,7 +29799,7 @@
                 </a:solidFill>
                 <a:latin typeface="Calibri"/>
               </a:rPr>
-              <a:t>Continuation. Citations [17]–[24]. Click a DOI to open the publisher record.</a:t>
+              <a:t>Continuation. Citations [17]–[24]. Click the URL to open the publisher or portal record.</a:t>
             </a:r>
           </a:p>
         </p:txBody>
@@ -29840,7 +29840,7 @@
                 </a:solidFill>
                 <a:latin typeface="Calibri"/>
               </a:rPr>
-              <a:t>[17] Guo, H., Woodruff, A., and Yadav, A. Improving Lives of Indebted Farmers Using Deep Learning: Predicting Agricultural Produce Prices Using Convolutional Neural Networks (PECAD). Proceedings of the AAAI Conference on Artificial Intelligence, 34(08):13294–13299. doi:10.1609/aaai.v34i08.7039.</a:t>
+              <a:t>[17] Guo, H., Woodruff, A., and Yadav, A. Improving Lives of Indebted Farmers Using Deep Learning: Predicting Agricultural Produce Prices Using Convolutional Neural Networks (PECAD). Proceedings of the AAAI Conference on Artificial Intelligence, 34(08):13294–13299. doi:10.1609/aaai.v34i08.7039. https://doi.org/10.1609/aaai.v34i08.7039</a:t>
             </a:r>
           </a:p>
           <a:p>
@@ -29858,7 +29858,7 @@
                 </a:solidFill>
                 <a:latin typeface="Calibri"/>
               </a:rPr>
-              <a:t>[18] Yao, S., Zhao, J., Yu, D., Du, N., Shafran, I., Narasimhan, K., and Cao, Y. ReAct: Synergizing Reasoning and Acting in Language Models. Proceedings of the Eleventh International Conference on Learning Representations (ICLR 2023).</a:t>
+              <a:t>[18] Yao, S., Zhao, J., Yu, D., Du, N., Shafran, I., Narasimhan, K., and Cao, Y. ReAct: Synergizing Reasoning and Acting in Language Models. Proceedings of the Eleventh International Conference on Learning Representations (ICLR 2023). https://openreview.net/forum?id=WE_vluYUL-X</a:t>
             </a:r>
           </a:p>
           <a:p>
@@ -29876,7 +29876,7 @@
                 </a:solidFill>
                 <a:latin typeface="Calibri"/>
               </a:rPr>
-              <a:t>[19] Wei, J., Wang, X., Schuurmans, D., Bosma, M., Ichter, B., Xia, F., Chi, E., Le, Q., and Zhou, D. Chain-of-Thought Prompting Elicits Reasoning in Large Language Models. Advances in Neural Information Processing Systems 35 (NeurIPS 2022).</a:t>
+              <a:t>[19] Wei, J., Wang, X., Schuurmans, D., Bosma, M., Ichter, B., Xia, F., Chi, E., Le, Q., and Zhou, D. Chain-of-Thought Prompting Elicits Reasoning in Large Language Models. Advances in Neural Information Processing Systems 35 (NeurIPS 2022). https://proceedings.neurips.cc/paper/2022/hash/9d5609613524ecf4f15af0f7b31abca4-Abstract-Conference.html</a:t>
             </a:r>
           </a:p>
           <a:p>
@@ -29894,7 +29894,7 @@
                 </a:solidFill>
                 <a:latin typeface="Calibri"/>
               </a:rPr>
-              <a:t>[20] Yao, S., Yu, D., Zhao, J., Shafran, I., Griffiths, T. L., Cao, Y., and Narasimhan, K. Tree of Thoughts: Deliberate Problem Solving with Large Language Models. Advances in Neural Information Processing Systems 36 (NeurIPS 2023).</a:t>
+              <a:t>[20] Yao, S., Yu, D., Zhao, J., Shafran, I., Griffiths, T. L., Cao, Y., and Narasimhan, K. Tree of Thoughts: Deliberate Problem Solving with Large Language Models. Advances in Neural Information Processing Systems 36 (NeurIPS 2023). https://proceedings.neurips.cc/paper_files/paper/2023/hash/271db9922b8d1f4dd7aaef84ed5ac703-Abstract-Conference.html</a:t>
             </a:r>
           </a:p>
           <a:p>
@@ -29912,7 +29912,7 @@
                 </a:solidFill>
                 <a:latin typeface="Calibri"/>
               </a:rPr>
-              <a:t>[21] Shinn, N., Cassano, F., Gopinath, A., Narasimhan, K., and Yao, S. Reflexion: Language Agents with Verbal Reinforcement Learning. Advances in Neural Information Processing Systems 36 (NeurIPS 2023).</a:t>
+              <a:t>[21] Shinn, N., Cassano, F., Gopinath, A., Narasimhan, K., and Yao, S. Reflexion: Language Agents with Verbal Reinforcement Learning. Advances in Neural Information Processing Systems 36 (NeurIPS 2023). https://proceedings.neurips.cc/paper_files/paper/2023/hash/1b44b878bb782e6954cd888628510e90-Abstract-Conference.html</a:t>
             </a:r>
           </a:p>
           <a:p>
@@ -29930,7 +29930,7 @@
                 </a:solidFill>
                 <a:latin typeface="Calibri"/>
               </a:rPr>
-              <a:t>[22] Shen, Y., Song, K., Tan, X., Li, D., Lu, W., and Zhuang, Y. HuggingGPT: Solving AI Tasks with ChatGPT and its Friends in Hugging Face. Advances in Neural Information Processing Systems 36 (NeurIPS 2023).</a:t>
+              <a:t>[22] Shen, Y., Song, K., Tan, X., Li, D., Lu, W., and Zhuang, Y. HuggingGPT: Solving AI Tasks with ChatGPT and its Friends in Hugging Face. Advances in Neural Information Processing Systems 36 (NeurIPS 2023). https://proceedings.neurips.cc/paper_files/paper/2023/hash/77c33e6a367922d003ff102ffb92b658-Abstract-Conference.html</a:t>
             </a:r>
           </a:p>
           <a:p>
@@ -29948,7 +29948,7 @@
                 </a:solidFill>
                 <a:latin typeface="Calibri"/>
               </a:rPr>
-              <a:t>[23] Schick, T., Dwivedi-Yu, J., Dessì, R., Raileanu, R., Lomeli, M., Hambro, E., Zettlemoyer, L., Cancedda, N., and Scialom, T. Toolformer: Language Models Can Teach Themselves to Use Tools. Advances in Neural Information Processing Systems 36 (NeurIPS 2023).</a:t>
+              <a:t>[23] Schick, T., Dwivedi-Yu, J., Dessì, R., Raileanu, R., Lomeli, M., Hambro, E., Zettlemoyer, L., Cancedda, N., and Scialom, T. Toolformer: Language Models Can Teach Themselves to Use Tools. Advances in Neural Information Processing Systems 36 (NeurIPS 2023). https://proceedings.neurips.cc/paper_files/paper/2023/hash/d842425e4bf79ba039352da0f658a906-Abstract-Conference.html</a:t>
             </a:r>
           </a:p>
           <a:p>
@@ -29966,7 +29966,7 @@
                 </a:solidFill>
                 <a:latin typeface="Calibri"/>
               </a:rPr>
-              <a:t>[24] Government of India Open Government Data Platform India. data.gov.in; AGMARKNET resource 9ef84268-d588-465a-a308-a864a43d0070; Directorate of Economics and Statistics crop production; IMD rainfall series; Government Open Data License — India (GODL-India). Live execution corpus, not a journal article.</a:t>
+              <a:t>[24] Government of India Open Government Data Platform India. data.gov.in; AGMARKNET resource 9ef84268-d588-465a-a308-a864a43d0070; Directorate of Economics and Statistics crop production; IMD rainfall series; Government Open Data License — India (GODL-India). https://data.gov.in/ Live execution corpus, not a journal article.</a:t>
             </a:r>
           </a:p>
         </p:txBody>
@@ -29992,7 +29992,7 @@
           <a:lstStyle/>
           <a:p>
             <a:pPr algn="l"/>
-            <a:fld id="{9457d634-7bd3-4fd1-a6ec-664f277c13cc}" type="datetime3">
+            <a:fld id="{a9172a06-edc5-4e1a-8f75-d2702b5ef19a}" type="datetime3">
               <a:rPr lang="en-GB" sz="1000" dirty="0">
                 <a:solidFill>
                   <a:srgbClr val="9AA3AE"/>
@@ -30026,7 +30026,7 @@
           <a:lstStyle/>
           <a:p>
             <a:pPr algn="ctr"/>
-            <a:fld id="{2d489fd4-c02a-48dd-a675-ca253cbfc81b}" type="slidenum">
+            <a:fld id="{799b28a3-0c62-4aa0-8336-affe6d7020fc}" type="slidenum">
               <a:rPr lang="en-GB" sz="1200" b="1" dirty="0">
                 <a:solidFill>
                   <a:srgbClr val="FFFFFF"/>
@@ -30476,7 +30476,7 @@
           <a:lstStyle/>
           <a:p>
             <a:pPr algn="l"/>
-            <a:fld id="{864c5944-a5c2-41fd-9f33-23d6f093e7e0}" type="datetime3">
+            <a:fld id="{043d4b92-9ef7-41fe-9119-011385f95b2d}" type="datetime3">
               <a:rPr lang="en-GB" sz="1000" dirty="0">
                 <a:solidFill>
                   <a:srgbClr val="9AA3AE"/>
@@ -30510,7 +30510,7 @@
           <a:lstStyle/>
           <a:p>
             <a:pPr algn="ctr"/>
-            <a:fld id="{3db4d9ae-f9fd-4599-92ff-4ef579b73fe0}" type="slidenum">
+            <a:fld id="{caf49f3a-3986-4777-8225-305b4e04c92a}" type="slidenum">
               <a:rPr lang="en-GB" sz="1200" b="1" dirty="0">
                 <a:solidFill>
                   <a:srgbClr val="FFFFFF"/>
@@ -30977,7 +30977,7 @@
           <a:lstStyle/>
           <a:p>
             <a:pPr algn="l"/>
-            <a:fld id="{0278330f-ab27-41a4-9150-024c821febc5}" type="datetime3">
+            <a:fld id="{7f66cc9d-abed-4c90-93a0-102a2b4f4119}" type="datetime3">
               <a:rPr lang="en-GB" sz="1000" dirty="0">
                 <a:solidFill>
                   <a:srgbClr val="9AA3AE"/>
@@ -31011,7 +31011,7 @@
           <a:lstStyle/>
           <a:p>
             <a:pPr algn="ctr"/>
-            <a:fld id="{baca6da4-8281-4431-a397-72420e0d3cf8}" type="slidenum">
+            <a:fld id="{0b0e8942-4d25-4f36-97c1-c5461934c90f}" type="slidenum">
               <a:rPr lang="en-GB" sz="1200" b="1" dirty="0">
                 <a:solidFill>
                   <a:srgbClr val="FFFFFF"/>
@@ -31304,7 +31304,7 @@
                 </a:solidFill>
                 <a:latin typeface="Calibri"/>
               </a:rPr>
-              <a:t>FET template. Each paper is Evidence n and citation [n]. Fields: Author(s), Year, Title, Publication, DOI (linked at https://doi.org/…), Objective, Methodology, Findings, Limitations, To solve the research gap.</a:t>
+              <a:t>FET template. Each paper is Evidence n and citation [n]. Fields: Author(s), Year, Title, Publication, DOI or URL (publisher / proceedings / data.gov.in), Objective, Methodology, Findings, Limitations, To solve the research gap.</a:t>
             </a:r>
           </a:p>
         </p:txBody>
@@ -31938,7 +31938,7 @@
           <a:lstStyle/>
           <a:p>
             <a:pPr algn="l"/>
-            <a:fld id="{b554e629-8511-45ff-aea0-64e53412a523}" type="datetime3">
+            <a:fld id="{081b1333-0f02-40e3-9c4e-76d2ff6a1685}" type="datetime3">
               <a:rPr lang="en-GB" sz="1000" dirty="0">
                 <a:solidFill>
                   <a:srgbClr val="9AA3AE"/>
@@ -31972,7 +31972,7 @@
           <a:lstStyle/>
           <a:p>
             <a:pPr algn="ctr"/>
-            <a:fld id="{9c5a3f78-cb95-459f-9713-37d0fa256a89}" type="slidenum">
+            <a:fld id="{f97da85d-1218-4992-a33a-f2eca0ecfb9e}" type="slidenum">
               <a:rPr lang="en-GB" sz="1200" b="1" dirty="0">
                 <a:solidFill>
                   <a:srgbClr val="FFFFFF"/>
@@ -32899,7 +32899,7 @@
           <a:lstStyle/>
           <a:p>
             <a:pPr algn="l"/>
-            <a:fld id="{cb87eb55-61c4-4790-afba-be5251c9fa23}" type="datetime3">
+            <a:fld id="{c46a87e9-0283-4d71-b5fa-803c9c60c7b5}" type="datetime3">
               <a:rPr lang="en-GB" sz="1000" dirty="0">
                 <a:solidFill>
                   <a:srgbClr val="9AA3AE"/>
@@ -32933,7 +32933,7 @@
           <a:lstStyle/>
           <a:p>
             <a:pPr algn="ctr"/>
-            <a:fld id="{7291de2e-0fc0-4cdb-9f29-52150cc16ff1}" type="slidenum">
+            <a:fld id="{64977f8a-8fb8-4700-8459-e18e209032e3}" type="slidenum">
               <a:rPr lang="en-GB" sz="1200" b="1" dirty="0">
                 <a:solidFill>
                   <a:srgbClr val="FFFFFF"/>
@@ -33860,7 +33860,7 @@
           <a:lstStyle/>
           <a:p>
             <a:pPr algn="l"/>
-            <a:fld id="{324b3a64-7e38-4bd4-961a-fb05b16b0ba3}" type="datetime3">
+            <a:fld id="{bb96f0cc-ad73-4b09-b36e-ed8412adbd2c}" type="datetime3">
               <a:rPr lang="en-GB" sz="1000" dirty="0">
                 <a:solidFill>
                   <a:srgbClr val="9AA3AE"/>
@@ -33894,7 +33894,7 @@
           <a:lstStyle/>
           <a:p>
             <a:pPr algn="ctr"/>
-            <a:fld id="{03624ba8-4215-4f5c-a50e-9a5454bb7129}" type="slidenum">
+            <a:fld id="{2b2c7de8-d727-46a2-b09f-4f68c2d448ee}" type="slidenum">
               <a:rPr lang="en-GB" sz="1200" b="1" dirty="0">
                 <a:solidFill>
                   <a:srgbClr val="FFFFFF"/>
@@ -34821,7 +34821,7 @@
           <a:lstStyle/>
           <a:p>
             <a:pPr algn="l"/>
-            <a:fld id="{b8d9af0e-6795-4d62-a15d-04cbfcf47c43}" type="datetime3">
+            <a:fld id="{74a1b98a-a8a8-4ee0-8ba5-28430b55f2b8}" type="datetime3">
               <a:rPr lang="en-GB" sz="1000" dirty="0">
                 <a:solidFill>
                   <a:srgbClr val="9AA3AE"/>
@@ -34855,7 +34855,7 @@
           <a:lstStyle/>
           <a:p>
             <a:pPr algn="ctr"/>
-            <a:fld id="{766d859c-fb2c-4347-8b19-cd3f26a2893d}" type="slidenum">
+            <a:fld id="{f8db61ad-48b4-4e55-983e-21f0b2194249}" type="slidenum">
               <a:rPr lang="en-GB" sz="1200" b="1" dirty="0">
                 <a:solidFill>
                   <a:srgbClr val="FFFFFF"/>

</xml_diff>